<commit_message>
Psaume 19 : audit et révision du PowerPoint contre le plan
Retire les codes de sermon des diapositives (comme dans la présentation
précédente), corrige deux citations inexactes et l'accroche de la stèle,
remplace deux icônes trompeuses, passe les polices à 13 pt minimum et
ajoute pièges et consignes du plan aux notes. Ajoute audit.js (1179
contrôles contre le plan) et le texte NEG79 du Psaume 19.

Co-Authored-By: Claude Sonnet 5.5 <noreply@anthropic.com>
</commit_message>
<xml_diff>
--- a/Presentation-Psaume-19.pptx
+++ b/Presentation-Psaume-19.pptx
@@ -120,7 +120,7 @@
   <p:extLst>
     <p:ext uri="{521415D9-36F7-43E2-AB2F-B90AF26B5E84}">
       <p14:sectionLst xmlns:p14="http://schemas.microsoft.com/office/powerpoint/2010/main">
-        <p14:section name="Ouverture" id="{6119c159-caa7-4393-a9e3-2728ecc41bac}">
+        <p14:section name="Ouverture" id="{df887675-8f8f-27e5-679d-eaa0deffcdc1}">
           <p14:sldIdLst>
             <p14:sldId id="256"/>
             <p14:sldId id="257"/>
@@ -128,31 +128,31 @@
             <p14:sldId id="259"/>
           </p14:sldIdLst>
         </p14:section>
-        <p14:section name="I. Le ciel qui parle" id="{6e584508-74b3-ab15-1f02-cb4c55f81bb7}">
+        <p14:section name="I. Le ciel qui parle" id="{2e6ee100-2e1c-b793-432e-608fe8f4aaac}">
           <p14:sldIdLst>
             <p14:sldId id="260"/>
             <p14:sldId id="261"/>
           </p14:sldIdLst>
         </p14:section>
-        <p14:section name="II. La Parole qui suffit" id="{adb20e34-c99c-89a0-d365-0b6d8629137d}">
+        <p14:section name="II. La Parole qui suffit" id="{2c2ae0b4-da42-477f-0855-7487b1866b53}">
           <p14:sldIdLst>
             <p14:sldId id="262"/>
             <p14:sldId id="263"/>
             <p14:sldId id="264"/>
           </p14:sldIdLst>
         </p14:section>
-        <p14:section name="III. La Parole qu'on désire" id="{79cbc26e-4234-7181-ab17-afe48e105233}">
+        <p14:section name="III. La Parole qu'on désire" id="{b415ce79-ae1e-ca3c-57ce-8e3c7dac599e}">
           <p14:sldIdLst>
             <p14:sldId id="265"/>
           </p14:sldIdLst>
         </p14:section>
-        <p14:section name="IV. Le cœur qui s'offre" id="{3bd761b9-4555-00ea-b2ec-95f2822a21d1}">
+        <p14:section name="IV. Le cœur qui s'offre" id="{7f4a3d90-ea20-3325-00cc-54756ec45174}">
           <p14:sldIdLst>
             <p14:sldId id="266"/>
             <p14:sldId id="267"/>
           </p14:sldIdLst>
         </p14:section>
-        <p14:section name="Conclusion" id="{86a12da8-61f7-d443-4146-3b2f3ade7498}">
+        <p14:section name="Conclusion" id="{5c04fa8c-51b1-3ebd-3cca-0366de327093}">
           <p14:sldIdLst>
             <p14:sldId id="268"/>
             <p14:sldId id="269"/>
@@ -656,6 +656,151 @@
               <a:t>NEG79. Les sermons de MacArthur comptent la suscription hors des versets : leurs « versets 7 à 9 » sont les versets 8 à 10 de la NEG79.</a:t>
             </a:r>
           </a:p>
+          <a:p>
+            <a:pPr marL="0" indent="0">
+              <a:spcBef>
+                <a:spcPts val="600"/>
+              </a:spcBef>
+              <a:buNone/>
+            </a:pPr>
+            <a:r>
+              <a:rPr lang="fr-CA" sz="1400" b="1" dirty="0"/>
+              <a:t>À éviter</a:t>
+            </a:r>
+          </a:p>
+          <a:p>
+            <a:pPr marL="228600" indent="-228600">
+              <a:spcBef>
+                <a:spcPts val="300"/>
+              </a:spcBef>
+              <a:buFont typeface="Arial"/>
+              <a:buChar char="•"/>
+            </a:pPr>
+            <a:r>
+              <a:rPr lang="fr-CA" sz="1400" dirty="0"/>
+              <a:t>Attribuer à MacArthur les propos de Street : les citer sous son nom.</a:t>
+            </a:r>
+          </a:p>
+          <a:p>
+            <a:pPr marL="228600" indent="-228600">
+              <a:spcBef>
+                <a:spcPts val="300"/>
+              </a:spcBef>
+              <a:buFont typeface="Arial"/>
+              <a:buChar char="•"/>
+            </a:pPr>
+            <a:r>
+              <a:rPr lang="fr-CA" sz="1400" dirty="0"/>
+              <a:t>Numérotation : les « versets 7 à 9 » des sermons de MacArthur sont les versets 8 à 10 de la NEG79.</a:t>
+            </a:r>
+          </a:p>
+          <a:p>
+            <a:pPr marL="0" indent="0">
+              <a:spcBef>
+                <a:spcPts val="600"/>
+              </a:spcBef>
+              <a:buNone/>
+            </a:pPr>
+            <a:r>
+              <a:rPr lang="fr-CA" sz="1400" b="1" dirty="0"/>
+              <a:t>Avant de monter en chaire</a:t>
+            </a:r>
+          </a:p>
+          <a:p>
+            <a:pPr marL="228600" indent="-228600">
+              <a:spcBef>
+                <a:spcPts val="300"/>
+              </a:spcBef>
+              <a:buFont typeface="Arial"/>
+              <a:buChar char="•"/>
+            </a:pPr>
+            <a:r>
+              <a:rPr lang="fr-CA" sz="1400" dirty="0"/>
+              <a:t>Relire à voix haute les citations bibliques dans votre Bible NEG79.</a:t>
+            </a:r>
+          </a:p>
+          <a:p>
+            <a:pPr marL="228600" indent="-228600">
+              <a:spcBef>
+                <a:spcPts val="300"/>
+              </a:spcBef>
+              <a:buFont typeface="Arial"/>
+              <a:buChar char="•"/>
+            </a:pPr>
+            <a:r>
+              <a:rPr lang="fr-CA" sz="1400" dirty="0"/>
+              <a:t>Les citations de MacArthur sont des traductions de passages relus dans les transcriptions de gty.org. Avant de les prononcer, réécouter ou relire au moins 80-420, 80-308 et TM19-6.</a:t>
+            </a:r>
+          </a:p>
+          <a:p>
+            <a:pPr marL="228600" indent="-228600">
+              <a:spcBef>
+                <a:spcPts val="300"/>
+              </a:spcBef>
+              <a:buFont typeface="Arial"/>
+              <a:buChar char="•"/>
+            </a:pPr>
+            <a:r>
+              <a:rPr lang="fr-CA" sz="1400" dirty="0"/>
+              <a:t>Le tableau du point II affiche les mots de la NEG79; MacArthur lit « claire » et « nette » : le dire à voix haute.</a:t>
+            </a:r>
+          </a:p>
+          <a:p>
+            <a:pPr marL="228600" indent="-228600">
+              <a:spcBef>
+                <a:spcPts val="300"/>
+              </a:spcBef>
+              <a:buFont typeface="Arial"/>
+              <a:buChar char="•"/>
+            </a:pPr>
+            <a:r>
+              <a:rPr lang="fr-CA" sz="1400" dirty="0"/>
+              <a:t>Préparer à l'écran le tableau des six lignes (diapositive 7) et, pour l'accroche, une image de la stèle de Hammurabi : la diapositive 3 en propose un dessin, à remplacer par une photo au besoin.</a:t>
+            </a:r>
+          </a:p>
+          <a:p>
+            <a:pPr marL="228600" indent="-228600">
+              <a:spcBef>
+                <a:spcPts val="300"/>
+              </a:spcBef>
+              <a:buFont typeface="Arial"/>
+              <a:buChar char="•"/>
+            </a:pPr>
+            <a:r>
+              <a:rPr lang="fr-CA" sz="1400" dirty="0"/>
+              <a:t>Chronométrer une répétition : le point II est le plus long; les sous-points I.A et III sont les plus faciles à raccourcir.</a:t>
+            </a:r>
+          </a:p>
+          <a:p>
+            <a:pPr marL="228600" indent="-228600">
+              <a:spcBef>
+                <a:spcPts val="300"/>
+              </a:spcBef>
+              <a:buFont typeface="Arial"/>
+              <a:buChar char="•"/>
+            </a:pPr>
+            <a:r>
+              <a:rPr lang="fr-CA" sz="1400" dirty="0"/>
+              <a:t>Imprimer la version PDF de ce plan.</a:t>
+            </a:r>
+          </a:p>
+          <a:p>
+            <a:pPr marL="228600" indent="-228600">
+              <a:spcBef>
+                <a:spcPts val="300"/>
+              </a:spcBef>
+              <a:buFont typeface="Arial"/>
+              <a:buChar char="•"/>
+            </a:pPr>
+            <a:r>
+              <a:rPr lang="fr-CA" sz="1400" b="1" dirty="0"/>
+              <a:t>Sur les diapositives : </a:t>
+            </a:r>
+            <a:r>
+              <a:rPr lang="fr-CA" sz="1400" dirty="0"/>
+              <a:t>aucun code de sermon; les sources sont dans ces notes.</a:t>
+            </a:r>
+          </a:p>
         </p:txBody>
       </p:sp>
       <p:sp>
@@ -868,6 +1013,31 @@
             </a:pPr>
             <a:r>
               <a:rPr lang="fr-CA" sz="1400" b="1" dirty="0"/>
+              <a:t>À éviter</a:t>
+            </a:r>
+          </a:p>
+          <a:p>
+            <a:pPr marL="228600" indent="-228600">
+              <a:spcBef>
+                <a:spcPts val="300"/>
+              </a:spcBef>
+              <a:buFont typeface="Arial"/>
+              <a:buChar char="•"/>
+            </a:pPr>
+            <a:r>
+              <a:rPr lang="fr-CA" sz="1400" dirty="0"/>
+              <a:t>Lire « la récompense est grande » comme une prospérité terrestre (80-19; 80-251).</a:t>
+            </a:r>
+          </a:p>
+          <a:p>
+            <a:pPr marL="0" indent="0">
+              <a:spcBef>
+                <a:spcPts val="600"/>
+              </a:spcBef>
+              <a:buNone/>
+            </a:pPr>
+            <a:r>
+              <a:rPr lang="fr-CA" sz="1400" b="1" dirty="0"/>
               <a:t>Transition</a:t>
             </a:r>
           </a:p>
@@ -1126,6 +1296,31 @@
               <a:t>Ce n'est pas du scrupule : c'est l'attitude d'un disciple mûr que la grâce et les ressources de Dieu amènent à reconnaître et à combattre ses péchés (BEM, 19.13-14).</a:t>
             </a:r>
           </a:p>
+          <a:p>
+            <a:pPr marL="0" indent="0">
+              <a:spcBef>
+                <a:spcPts val="600"/>
+              </a:spcBef>
+              <a:buNone/>
+            </a:pPr>
+            <a:r>
+              <a:rPr lang="fr-CA" sz="1400" b="1" dirty="0"/>
+              <a:t>À éviter</a:t>
+            </a:r>
+          </a:p>
+          <a:p>
+            <a:pPr marL="228600" indent="-228600">
+              <a:spcBef>
+                <a:spcPts val="300"/>
+              </a:spcBef>
+              <a:buFont typeface="Arial"/>
+              <a:buChar char="•"/>
+            </a:pPr>
+            <a:r>
+              <a:rPr lang="fr-CA" sz="1400" dirty="0"/>
+              <a:t>Lire « des orgueilleux » (NEG79) comme des ennemis extérieurs, au détriment des péchés présomptueux.</a:t>
+            </a:r>
+          </a:p>
         </p:txBody>
       </p:sp>
       <p:sp>
@@ -2592,6 +2787,44 @@
               <a:t>« Le psalmiste passe du monde à la Parole au verset 7 » (80-420; verset 8 de la NEG79), et El devient l'Éternel. Où entendre la sagesse qui sauve?</a:t>
             </a:r>
           </a:p>
+          <a:p>
+            <a:pPr marL="0" indent="0">
+              <a:spcBef>
+                <a:spcPts val="600"/>
+              </a:spcBef>
+              <a:buNone/>
+            </a:pPr>
+            <a:r>
+              <a:rPr lang="fr-CA" sz="1400" b="1" dirty="0"/>
+              <a:t>À éviter</a:t>
+            </a:r>
+          </a:p>
+          <a:p>
+            <a:pPr marL="228600" indent="-228600">
+              <a:spcBef>
+                <a:spcPts val="300"/>
+              </a:spcBef>
+              <a:buFont typeface="Arial"/>
+              <a:buChar char="•"/>
+            </a:pPr>
+            <a:r>
+              <a:rPr lang="fr-CA" sz="1400" dirty="0"/>
+              <a:t>Traiter les versets 2 à 7 comme une simple introduction poétique, ou, à l'inverse, comme une révélation qui sauve : elle rend inexcusable, sans convertir (BEM, 19.2-7).</a:t>
+            </a:r>
+          </a:p>
+          <a:p>
+            <a:pPr marL="228600" indent="-228600">
+              <a:spcBef>
+                <a:spcPts val="300"/>
+              </a:spcBef>
+              <a:buFont typeface="Arial"/>
+              <a:buChar char="•"/>
+            </a:pPr>
+            <a:r>
+              <a:rPr lang="fr-CA" sz="1400" dirty="0"/>
+              <a:t>Oublier la résistance du cœur pécheur : le problème n'est pas que la création soit obscure, mais que l'homme retient la vérité captive.</a:t>
+            </a:r>
+          </a:p>
         </p:txBody>
       </p:sp>
       <p:sp>
@@ -3064,6 +3297,57 @@
               <a:t>La Parole « fournit tout ce qu'il faut » (80-250) : toute l'Écriture rend l'homme de Dieu accompli (2 Timothée 3.16-17). Retour au Rappel.</a:t>
             </a:r>
           </a:p>
+          <a:p>
+            <a:pPr marL="0" indent="0">
+              <a:spcBef>
+                <a:spcPts val="600"/>
+              </a:spcBef>
+              <a:buNone/>
+            </a:pPr>
+            <a:r>
+              <a:rPr lang="fr-CA" sz="1400" b="1" dirty="0"/>
+              <a:t>À éviter</a:t>
+            </a:r>
+          </a:p>
+          <a:p>
+            <a:pPr marL="228600" indent="-228600">
+              <a:spcBef>
+                <a:spcPts val="300"/>
+              </a:spcBef>
+              <a:buFont typeface="Arial"/>
+              <a:buChar char="•"/>
+            </a:pPr>
+            <a:r>
+              <a:rPr lang="fr-CA" sz="1400" dirty="0"/>
+              <a:t>Affaiblir « restaure l'âme » en simple réconfort : c'est la conversion et la transformation de la personne entière (80-308).</a:t>
+            </a:r>
+          </a:p>
+          <a:p>
+            <a:pPr marL="228600" indent="-228600">
+              <a:spcBef>
+                <a:spcPts val="300"/>
+              </a:spcBef>
+              <a:buFont typeface="Arial"/>
+              <a:buChar char="•"/>
+            </a:pPr>
+            <a:r>
+              <a:rPr lang="fr-CA" sz="1400" dirty="0"/>
+              <a:t>Réduire « parfaite » à « sans défaut » : MacArthur y entend d'abord la complétude (80-308).</a:t>
+            </a:r>
+          </a:p>
+          <a:p>
+            <a:pPr marL="228600" indent="-228600">
+              <a:spcBef>
+                <a:spcPts val="300"/>
+              </a:spcBef>
+              <a:buFont typeface="Arial"/>
+              <a:buChar char="•"/>
+            </a:pPr>
+            <a:r>
+              <a:rPr lang="fr-CA" sz="1400" dirty="0"/>
+              <a:t>Isoler la « crainte » de la liste : c'est l'Écriture comme guide de l'adoration.</a:t>
+            </a:r>
+          </a:p>
         </p:txBody>
       </p:sp>
       <p:sp>
@@ -3197,11 +3481,23 @@
             </a:pPr>
             <a:r>
               <a:rPr lang="fr-CA" sz="1400" b="1" dirty="0"/>
-              <a:t>À ne pas dire : </a:t>
+              <a:t>Question : </a:t>
             </a:r>
             <a:r>
               <a:rPr lang="fr-CA" sz="1400" dirty="0"/>
-              <a:t>que la suffisance méprise les sciences. Street reconnaît les bienfaits de la révélation naturelle en sciences et en médecine; la suffisance vise le domaine de l'âme.</a:t>
+              <a:t>vers quoi vous tournez-vous en premier quand votre âme est troublée?</a:t>
+            </a:r>
+          </a:p>
+          <a:p>
+            <a:pPr marL="0" indent="0">
+              <a:spcBef>
+                <a:spcPts val="600"/>
+              </a:spcBef>
+              <a:buNone/>
+            </a:pPr>
+            <a:r>
+              <a:rPr lang="fr-CA" sz="1400" b="1" dirty="0"/>
+              <a:t>À éviter</a:t>
             </a:r>
           </a:p>
           <a:p>
@@ -3213,12 +3509,8 @@
               <a:buChar char="•"/>
             </a:pPr>
             <a:r>
-              <a:rPr lang="fr-CA" sz="1400" b="1" dirty="0"/>
-              <a:t>Question : </a:t>
-            </a:r>
-            <a:r>
               <a:rPr lang="fr-CA" sz="1400" dirty="0"/>
-              <a:t>vers quoi vous tournez-vous en premier quand votre âme est troublée?</a:t>
+              <a:t>Faire de la suffisance un mépris des sciences : Street reconnaît les bienfaits de la révélation naturelle en sciences et en médecine; la suffisance vise le domaine de l'âme.</a:t>
             </a:r>
           </a:p>
           <a:p>
@@ -4739,7 +5031,7 @@
                 <a:ea typeface="Calibri" pitchFamily="34" charset="-122"/>
                 <a:cs typeface="Calibri" pitchFamily="34" charset="-120"/>
               </a:rPr>
-              <a:t>Plus précieuse que beaucoup d'or fin, l'or affiné (80‑251).</a:t>
+              <a:t>Plus précieuse que beaucoup d'or fin, l'or affiné.</a:t>
             </a:r>
             <a:endParaRPr lang="fr-CA" sz="1500" dirty="0"/>
           </a:p>
@@ -4850,7 +5142,7 @@
                 <a:ea typeface="Calibri" pitchFamily="34" charset="-122"/>
                 <a:cs typeface="Calibri" pitchFamily="34" charset="-120"/>
               </a:rPr>
-              <a:t>Plus douce que celui qui coule des rayons (80‑251).</a:t>
+              <a:t>Plus douce que celui qui coule des rayons.</a:t>
             </a:r>
             <a:endParaRPr lang="fr-CA" sz="1500" dirty="0"/>
           </a:p>
@@ -4961,7 +5253,7 @@
                 <a:ea typeface="Calibri" pitchFamily="34" charset="-122"/>
                 <a:cs typeface="Calibri" pitchFamily="34" charset="-120"/>
               </a:rPr>
-              <a:t>« La Parole de Dieu est pleine d'avertissements » (80‑251).</a:t>
+              <a:t>« La Parole de Dieu est pleine d'avertissements » (MacArthur).</a:t>
             </a:r>
             <a:endParaRPr lang="fr-CA" sz="1500" dirty="0"/>
           </a:p>
@@ -5072,7 +5364,7 @@
                 <a:ea typeface="Calibri" pitchFamily="34" charset="-122"/>
                 <a:cs typeface="Calibri" pitchFamily="34" charset="-120"/>
               </a:rPr>
-              <a:t>« En les gardant, il y a la fin » : non ici et maintenant, mais la gloire à venir (80‑19; 80‑251).</a:t>
+              <a:t>« En les gardant, il y a la fin » : non ici et maintenant, mais la gloire à venir.</a:t>
             </a:r>
             <a:endParaRPr lang="fr-CA" sz="1500" dirty="0"/>
           </a:p>
@@ -5817,7 +6109,7 @@
             <a:r>
               <a:rPr lang="fr-CA" altLang="en-US" sz="2600" b="1" dirty="0">
                 <a:solidFill>
-                  <a:srgbClr val="6E5A4C"/>
+                  <a:srgbClr val="968A80"/>
                 </a:solidFill>
                 <a:latin typeface="Cambria" pitchFamily="34" charset="0"/>
                 <a:ea typeface="Cambria" pitchFamily="34" charset="-122"/>
@@ -5879,7 +6171,7 @@
                 <a:ea typeface="Calibri" pitchFamily="34" charset="-122"/>
                 <a:cs typeface="Calibri" pitchFamily="34" charset="-120"/>
               </a:rPr>
-              <a:t>Péchés d'ignorance, non intentionnels (TM19‑6; BEM).</a:t>
+              <a:t>Péchés d'ignorance, non intentionnels.</a:t>
             </a:r>
             <a:endParaRPr lang="fr-CA" sz="1500" dirty="0"/>
           </a:p>
@@ -5930,7 +6222,7 @@
           <a:ln/>
         </p:spPr>
         <p:txBody>
-          <a:bodyPr wrap="square" lIns="0" tIns="0" rIns="0" bIns="0" rtlCol="0" anchor="ctr"/>
+          <a:bodyPr wrap="none" lIns="0" tIns="0" rIns="0" bIns="0" rtlCol="0" anchor="ctr"/>
           <a:lstStyle/>
           <a:p>
             <a:pPr algn="ctr" indent="0" marL="0">
@@ -6179,7 +6471,7 @@
                 <a:ea typeface="Calibri" pitchFamily="34" charset="-122"/>
                 <a:cs typeface="Calibri" pitchFamily="34" charset="-120"/>
               </a:rPr>
-              <a:t>Délibérés : ceux que je vois, prémédite et planifie (80‑19).</a:t>
+              <a:t>Délibérés : ceux que je vois, prémédite et planifie.</a:t>
             </a:r>
             <a:endParaRPr lang="fr-CA" sz="1500" dirty="0"/>
           </a:p>
@@ -6230,7 +6522,7 @@
           <a:ln/>
         </p:spPr>
         <p:txBody>
-          <a:bodyPr wrap="square" lIns="0" tIns="0" rIns="0" bIns="0" rtlCol="0" anchor="ctr"/>
+          <a:bodyPr wrap="none" lIns="0" tIns="0" rIns="0" bIns="0" rtlCol="0" anchor="ctr"/>
           <a:lstStyle/>
           <a:p>
             <a:pPr algn="ctr" indent="0" marL="0">
@@ -6284,7 +6576,7 @@
                 <a:ea typeface="Calibri" pitchFamily="34" charset="-122"/>
                 <a:cs typeface="Calibri" pitchFamily="34" charset="-120"/>
               </a:rPr>
-              <a:t>« Préserve ton serviteur »</a:t>
+              <a:t>« Préserve aussi ton serviteur »</a:t>
             </a:r>
             <a:endParaRPr lang="fr-CA" sz="1500" dirty="0"/>
           </a:p>
@@ -6479,7 +6771,7 @@
                 <a:ea typeface="Calibri" pitchFamily="34" charset="-122"/>
                 <a:cs typeface="Calibri" pitchFamily="34" charset="-120"/>
               </a:rPr>
-              <a:t>La rébellion ouverte (TM19‑6) : se détourner du Seigneur (80‑251).</a:t>
+              <a:t>La rébellion ouverte : se détourner du Seigneur.</a:t>
             </a:r>
             <a:endParaRPr lang="fr-CA" sz="1500" dirty="0"/>
           </a:p>
@@ -6530,7 +6822,7 @@
           <a:ln/>
         </p:spPr>
         <p:txBody>
-          <a:bodyPr wrap="square" lIns="0" tIns="0" rIns="0" bIns="0" rtlCol="0" anchor="ctr"/>
+          <a:bodyPr wrap="none" lIns="0" tIns="0" rIns="0" bIns="0" rtlCol="0" anchor="ctr"/>
           <a:lstStyle/>
           <a:p>
             <a:pPr algn="ctr" indent="0" marL="0">
@@ -6860,7 +7152,7 @@
                 <a:ea typeface="Calibri" pitchFamily="34" charset="-122"/>
                 <a:cs typeface="Calibri" pitchFamily="34" charset="-120"/>
               </a:rPr>
-              <a:t>que la grâce et les ressources de Dieu amènent à reconnaître et à combattre ses péchés (BEM).</a:t>
+              <a:t>que la grâce et les ressources de Dieu amènent à reconnaître et à combattre ses péchés.</a:t>
             </a:r>
             <a:endParaRPr lang="fr-CA" sz="1500" dirty="0"/>
           </a:p>
@@ -7592,7 +7884,7 @@
                 <a:ea typeface="Calibri" pitchFamily="34" charset="-122"/>
                 <a:cs typeface="Calibri" pitchFamily="34" charset="-120"/>
               </a:rPr>
-              <a:t>Le vocabulaire des sacrifices agréés : David dépose sur l'autel ses lèvres et sa vie (BEM).</a:t>
+              <a:t>Le vocabulaire des sacrifices agréés : David dépose sur l'autel ses lèvres et sa vie.</a:t>
             </a:r>
             <a:endParaRPr lang="fr-CA" sz="1500" dirty="0"/>
           </a:p>
@@ -7703,7 +7995,7 @@
                 <a:ea typeface="Calibri" pitchFamily="34" charset="-122"/>
                 <a:cs typeface="Calibri" pitchFamily="34" charset="-120"/>
               </a:rPr>
-              <a:t>L'écho de Josué 1.8 : la loi méditée jour et nuit (BEM; TM19‑6).</a:t>
+              <a:t>L'écho de Josué 1.8 : la loi méditée jour et nuit.</a:t>
             </a:r>
             <a:endParaRPr lang="fr-CA" sz="1500" dirty="0"/>
           </a:p>
@@ -7736,7 +8028,7 @@
       </p:sp>
       <p:pic>
         <p:nvPicPr>
-          <p:cNvPr id="17" name="Image 3" descr="Icône : sommet rocheux">    </p:cNvPr>
+          <p:cNvPr id="17" name="Image 3" descr="Icône : rocher">    </p:cNvPr>
           <p:cNvPicPr>
             <a:picLocks noChangeAspect="1"/>
           </p:cNvPicPr>
@@ -8993,7 +9285,7 @@
                 <a:ea typeface="Calibri" pitchFamily="34" charset="-122"/>
                 <a:cs typeface="Calibri" pitchFamily="34" charset="-120"/>
               </a:rPr>
-              <a:t>« Personne ne peut être sauvé, régénéré, né de nouveau sans comprendre la Parole de Dieu, en particulier la Parole de Dieu concernant la personne de Jésus-Christ » (GTY143).</a:t>
+              <a:t>« Personne ne peut être sauvé, régénéré, né de nouveau sans comprendre la Parole de Dieu, en particulier la Parole de Dieu concernant la personne de Jésus-Christ » (MacArthur).</a:t>
             </a:r>
             <a:endParaRPr lang="fr-CA" sz="1500" dirty="0"/>
           </a:p>
@@ -9243,7 +9535,7 @@
                 <a:ea typeface="Calibri" pitchFamily="34" charset="-122"/>
                 <a:cs typeface="Calibri" pitchFamily="34" charset="-120"/>
               </a:rPr>
-              <a:t>« Dans votre cœur, en ce moment, pouvez-vous prendre devant le Seigneur un engagement renouvelé à vous vouer à sa Parole? » (80‑19)</a:t>
+              <a:t>« Dans votre cœur, en ce moment, pouvez-vous prendre devant le Seigneur un engagement renouvelé à vous vouer à sa Parole? » (MacArthur)</a:t>
             </a:r>
             <a:endParaRPr lang="fr-CA" sz="1500" dirty="0"/>
           </a:p>
@@ -10321,7 +10613,7 @@
                 <a:ea typeface="Calibri" pitchFamily="34" charset="-122"/>
                 <a:cs typeface="Calibri" pitchFamily="34" charset="-120"/>
               </a:rPr>
-              <a:t>« Ce que l'Écriture dit, Dieu le dit. »  (55‑17)</a:t>
+              <a:t>« Ce que l'Écriture dit, Dieu le dit. »  (MacArthur)</a:t>
             </a:r>
             <a:endParaRPr lang="fr-CA" sz="1900" dirty="0"/>
           </a:p>
@@ -11158,7 +11450,7 @@
                 <a:ea typeface="Calibri" pitchFamily="34" charset="-122"/>
                 <a:cs typeface="Calibri" pitchFamily="34" charset="-120"/>
               </a:rPr>
-              <a:t>que l'homme de Dieu soit propre, non à la plupart, mais à toutes les bonnes œuvres (55‑19).</a:t>
+              <a:t>que l'homme de Dieu soit propre, non à la plupart, mais à toutes les bonnes œuvres.</a:t>
             </a:r>
             <a:endParaRPr lang="fr-CA" sz="1700" dirty="0"/>
           </a:p>
@@ -11619,7 +11911,7 @@
                 <a:ea typeface="Calibri" pitchFamily="34" charset="-122"/>
                 <a:cs typeface="Calibri" pitchFamily="34" charset="-120"/>
               </a:rPr>
-              <a:t>Babylone la fait descendre du soleil; le Psaume 19 la remet entre les mains de l'Éternel</a:t>
+              <a:t>Babylone la fait se réclamer du dieu-soleil; le Psaume 19 la remet entre les mains de l'Éternel</a:t>
             </a:r>
             <a:endParaRPr lang="fr-CA" sz="1900" dirty="0"/>
           </a:p>
@@ -11810,7 +12102,7 @@
                 <a:ea typeface="Calibri" pitchFamily="34" charset="-122"/>
                 <a:cs typeface="Calibri" pitchFamily="34" charset="-120"/>
               </a:rPr>
-              <a:t>Le soleil voit tout : on le fait juge, et la loi du roi se réclame de lui.</a:t>
+              <a:t>Shamash, dieu-soleil et dieu de la justice : la loi du roi se réclame de lui.</a:t>
             </a:r>
             <a:endParaRPr lang="fr-CA" sz="1500" dirty="0"/>
           </a:p>
@@ -13746,7 +14038,7 @@
               <a:buNone/>
             </a:pPr>
             <a:r>
-              <a:rPr lang="fr-CA" altLang="en-US" sz="1500" i="1" dirty="0">
+              <a:rPr lang="fr-CA" altLang="en-US" sz="1400" i="1" dirty="0">
                 <a:solidFill>
                   <a:srgbClr val="A89A8C"/>
                 </a:solidFill>
@@ -13754,9 +14046,9 @@
                 <a:ea typeface="Calibri" pitchFamily="34" charset="-122"/>
                 <a:cs typeface="Calibri" pitchFamily="34" charset="-120"/>
               </a:rPr>
-              <a:t>« Le plus grand passage, à lui seul, sur la suffisance de l'Écriture dans toute la Bible »  (80‑18)</a:t>
-            </a:r>
-            <a:endParaRPr lang="fr-CA" sz="1500" dirty="0"/>
+              <a:t>« Je pense que c'est le plus grand passage, à lui seul, sur la suffisance de l'Écriture dans toute la Bible »  (MacArthur)</a:t>
+            </a:r>
+            <a:endParaRPr lang="fr-CA" sz="1400" dirty="0"/>
           </a:p>
         </p:txBody>
       </p:sp>
@@ -14541,7 +14833,7 @@
                 <a:ea typeface="Calibri" pitchFamily="34" charset="-122"/>
                 <a:cs typeface="Calibri" pitchFamily="34" charset="-120"/>
               </a:rPr>
-              <a:t>BEM, 19.5c-7</a:t>
+              <a:t>19.5c-7</a:t>
             </a:r>
             <a:endParaRPr lang="fr-CA" sz="1400" dirty="0"/>
           </a:p>
@@ -14735,7 +15027,7 @@
                 <a:ea typeface="Calibri" pitchFamily="34" charset="-122"/>
                 <a:cs typeface="Calibri" pitchFamily="34" charset="-120"/>
               </a:rPr>
-              <a:t>« Racontent », « manifeste » : la révélation ne s'interrompt jamais (BEM, 19.2).</a:t>
+              <a:t>« Racontent », « manifeste » : la révélation ne s'interrompt jamais.</a:t>
             </a:r>
             <a:endParaRPr lang="fr-CA" sz="1500" dirty="0"/>
           </a:p>
@@ -14879,7 +15171,7 @@
       </p:sp>
       <p:pic>
         <p:nvPicPr>
-          <p:cNvPr id="23" name="Image 3" descr="Icône : fontaine">    </p:cNvPr>
+          <p:cNvPr id="23" name="Image 3" descr="Icône : disque moitié clair, moitié sombre : le jour et la nuit">    </p:cNvPr>
           <p:cNvPicPr>
             <a:picLocks noChangeAspect="1"/>
           </p:cNvPicPr>
@@ -15068,7 +15360,7 @@
                 <a:ea typeface="Calibri" pitchFamily="34" charset="-122"/>
                 <a:cs typeface="Calibri" pitchFamily="34" charset="-120"/>
               </a:rPr>
-              <a:t>Pas de mots au sens littéral, mais un message qui atteint toute la terre (BEM; Romains 10.18).</a:t>
+              <a:t>Pas de mots au sens littéral, mais un message qui atteint toute la terre (Romains 10.18).</a:t>
             </a:r>
             <a:endParaRPr lang="fr-CA" sz="1500" dirty="0"/>
           </a:p>
@@ -15509,7 +15801,7 @@
                 <a:ea typeface="Calibri" pitchFamily="34" charset="-122"/>
                 <a:cs typeface="Calibri" pitchFamily="34" charset="-120"/>
               </a:rPr>
-              <a:t>« Ce qu'on ne peut pas connaître, c'est la sagesse qui sauve »  (TM19‑6)</a:t>
+              <a:t>« Ce qu'on ne peut pas connaître, c'est la sagesse qui sauve »  (MacArthur)</a:t>
             </a:r>
             <a:endParaRPr lang="fr-CA" sz="1900" dirty="0"/>
           </a:p>
@@ -15811,8 +16103,8 @@
         </p:nvSpPr>
         <p:spPr>
           <a:xfrm>
-            <a:off x="868680" y="3072384"/>
-            <a:ext cx="1691640" cy="365760"/>
+            <a:off x="868680" y="3063240"/>
+            <a:ext cx="1783080" cy="365760"/>
           </a:xfrm>
           <a:prstGeom prst="rect">
             <a:avLst/>
@@ -15828,7 +16120,7 @@
               <a:buNone/>
             </a:pPr>
             <a:r>
-              <a:rPr lang="fr-CA" altLang="en-US" sz="1200" b="1" spc="200" kern="0" dirty="0">
+              <a:rPr lang="fr-CA" altLang="en-US" sz="1300" b="1" spc="100" kern="0" dirty="0">
                 <a:solidFill>
                   <a:srgbClr val="968A80"/>
                 </a:solidFill>
@@ -15838,7 +16130,7 @@
               </a:rPr>
               <a:t>FAIT CONNAÎTRE</a:t>
             </a:r>
-            <a:endParaRPr lang="fr-CA" sz="1200" dirty="0"/>
+            <a:endParaRPr lang="fr-CA" sz="1300" dirty="0"/>
           </a:p>
         </p:txBody>
       </p:sp>
@@ -15850,8 +16142,8 @@
         </p:nvSpPr>
         <p:spPr>
           <a:xfrm>
-            <a:off x="2651760" y="3017520"/>
-            <a:ext cx="3108960" cy="457200"/>
+            <a:off x="2743200" y="3017520"/>
+            <a:ext cx="3017520" cy="457200"/>
           </a:xfrm>
           <a:prstGeom prst="rect">
             <a:avLst/>
@@ -15889,8 +16181,8 @@
         </p:nvSpPr>
         <p:spPr>
           <a:xfrm>
-            <a:off x="868680" y="3602736"/>
-            <a:ext cx="1691640" cy="365760"/>
+            <a:off x="868680" y="3593592"/>
+            <a:ext cx="1783080" cy="365760"/>
           </a:xfrm>
           <a:prstGeom prst="rect">
             <a:avLst/>
@@ -15906,7 +16198,7 @@
               <a:buNone/>
             </a:pPr>
             <a:r>
-              <a:rPr lang="fr-CA" altLang="en-US" sz="1200" b="1" spc="200" kern="0" dirty="0">
+              <a:rPr lang="fr-CA" altLang="en-US" sz="1300" b="1" spc="100" kern="0" dirty="0">
                 <a:solidFill>
                   <a:srgbClr val="968A80"/>
                 </a:solidFill>
@@ -15916,7 +16208,7 @@
               </a:rPr>
               <a:t>EFFET</a:t>
             </a:r>
-            <a:endParaRPr lang="fr-CA" sz="1200" dirty="0"/>
+            <a:endParaRPr lang="fr-CA" sz="1300" dirty="0"/>
           </a:p>
         </p:txBody>
       </p:sp>
@@ -15928,8 +16220,8 @@
         </p:nvSpPr>
         <p:spPr>
           <a:xfrm>
-            <a:off x="2651760" y="3547872"/>
-            <a:ext cx="3108960" cy="457200"/>
+            <a:off x="2743200" y="3547872"/>
+            <a:ext cx="3017520" cy="457200"/>
           </a:xfrm>
           <a:prstGeom prst="rect">
             <a:avLst/>
@@ -15967,8 +16259,8 @@
         </p:nvSpPr>
         <p:spPr>
           <a:xfrm>
-            <a:off x="868680" y="4133088"/>
-            <a:ext cx="1691640" cy="365760"/>
+            <a:off x="868680" y="4123944"/>
+            <a:ext cx="1783080" cy="365760"/>
           </a:xfrm>
           <a:prstGeom prst="rect">
             <a:avLst/>
@@ -15984,7 +16276,7 @@
               <a:buNone/>
             </a:pPr>
             <a:r>
-              <a:rPr lang="fr-CA" altLang="en-US" sz="1200" b="1" spc="200" kern="0" dirty="0">
+              <a:rPr lang="fr-CA" altLang="en-US" sz="1300" b="1" spc="100" kern="0" dirty="0">
                 <a:solidFill>
                   <a:srgbClr val="968A80"/>
                 </a:solidFill>
@@ -15994,7 +16286,7 @@
               </a:rPr>
               <a:t>LIMITE</a:t>
             </a:r>
-            <a:endParaRPr lang="fr-CA" sz="1200" dirty="0"/>
+            <a:endParaRPr lang="fr-CA" sz="1300" dirty="0"/>
           </a:p>
         </p:txBody>
       </p:sp>
@@ -16006,8 +16298,8 @@
         </p:nvSpPr>
         <p:spPr>
           <a:xfrm>
-            <a:off x="2651760" y="4078224"/>
-            <a:ext cx="3108960" cy="457200"/>
+            <a:off x="2743200" y="4078224"/>
+            <a:ext cx="3017520" cy="457200"/>
           </a:xfrm>
           <a:prstGeom prst="rect">
             <a:avLst/>
@@ -16177,8 +16469,8 @@
         </p:nvSpPr>
         <p:spPr>
           <a:xfrm>
-            <a:off x="6565392" y="3072384"/>
-            <a:ext cx="1691640" cy="365760"/>
+            <a:off x="6565392" y="3063240"/>
+            <a:ext cx="1783080" cy="365760"/>
           </a:xfrm>
           <a:prstGeom prst="rect">
             <a:avLst/>
@@ -16194,7 +16486,7 @@
               <a:buNone/>
             </a:pPr>
             <a:r>
-              <a:rPr lang="fr-CA" altLang="en-US" sz="1200" b="1" spc="200" kern="0" dirty="0">
+              <a:rPr lang="fr-CA" altLang="en-US" sz="1300" b="1" spc="100" kern="0" dirty="0">
                 <a:solidFill>
                   <a:srgbClr val="E8742A"/>
                 </a:solidFill>
@@ -16204,7 +16496,7 @@
               </a:rPr>
               <a:t>FAIT CONNAÎTRE</a:t>
             </a:r>
-            <a:endParaRPr lang="fr-CA" sz="1200" dirty="0"/>
+            <a:endParaRPr lang="fr-CA" sz="1300" dirty="0"/>
           </a:p>
         </p:txBody>
       </p:sp>
@@ -16216,8 +16508,8 @@
         </p:nvSpPr>
         <p:spPr>
           <a:xfrm>
-            <a:off x="8348472" y="3017520"/>
-            <a:ext cx="3108960" cy="457200"/>
+            <a:off x="8439912" y="3017520"/>
+            <a:ext cx="3017520" cy="457200"/>
           </a:xfrm>
           <a:prstGeom prst="rect">
             <a:avLst/>
@@ -16255,8 +16547,8 @@
         </p:nvSpPr>
         <p:spPr>
           <a:xfrm>
-            <a:off x="6565392" y="3602736"/>
-            <a:ext cx="1691640" cy="365760"/>
+            <a:off x="6565392" y="3593592"/>
+            <a:ext cx="1783080" cy="365760"/>
           </a:xfrm>
           <a:prstGeom prst="rect">
             <a:avLst/>
@@ -16272,7 +16564,7 @@
               <a:buNone/>
             </a:pPr>
             <a:r>
-              <a:rPr lang="fr-CA" altLang="en-US" sz="1200" b="1" spc="200" kern="0" dirty="0">
+              <a:rPr lang="fr-CA" altLang="en-US" sz="1300" b="1" spc="100" kern="0" dirty="0">
                 <a:solidFill>
                   <a:srgbClr val="E8742A"/>
                 </a:solidFill>
@@ -16282,7 +16574,7 @@
               </a:rPr>
               <a:t>EFFET</a:t>
             </a:r>
-            <a:endParaRPr lang="fr-CA" sz="1200" dirty="0"/>
+            <a:endParaRPr lang="fr-CA" sz="1300" dirty="0"/>
           </a:p>
         </p:txBody>
       </p:sp>
@@ -16294,8 +16586,8 @@
         </p:nvSpPr>
         <p:spPr>
           <a:xfrm>
-            <a:off x="8348472" y="3547872"/>
-            <a:ext cx="3108960" cy="457200"/>
+            <a:off x="8439912" y="3547872"/>
+            <a:ext cx="3017520" cy="457200"/>
           </a:xfrm>
           <a:prstGeom prst="rect">
             <a:avLst/>
@@ -16333,8 +16625,8 @@
         </p:nvSpPr>
         <p:spPr>
           <a:xfrm>
-            <a:off x="6565392" y="4133088"/>
-            <a:ext cx="1691640" cy="365760"/>
+            <a:off x="6565392" y="4123944"/>
+            <a:ext cx="1783080" cy="365760"/>
           </a:xfrm>
           <a:prstGeom prst="rect">
             <a:avLst/>
@@ -16350,7 +16642,7 @@
               <a:buNone/>
             </a:pPr>
             <a:r>
-              <a:rPr lang="fr-CA" altLang="en-US" sz="1200" b="1" spc="200" kern="0" dirty="0">
+              <a:rPr lang="fr-CA" altLang="en-US" sz="1300" b="1" spc="100" kern="0" dirty="0">
                 <a:solidFill>
                   <a:srgbClr val="E8742A"/>
                 </a:solidFill>
@@ -16360,7 +16652,7 @@
               </a:rPr>
               <a:t>MOYEN</a:t>
             </a:r>
-            <a:endParaRPr lang="fr-CA" sz="1200" dirty="0"/>
+            <a:endParaRPr lang="fr-CA" sz="1300" dirty="0"/>
           </a:p>
         </p:txBody>
       </p:sp>
@@ -16372,8 +16664,8 @@
         </p:nvSpPr>
         <p:spPr>
           <a:xfrm>
-            <a:off x="8348472" y="4078224"/>
-            <a:ext cx="3108960" cy="457200"/>
+            <a:off x="8439912" y="4078224"/>
+            <a:ext cx="3017520" cy="457200"/>
           </a:xfrm>
           <a:prstGeom prst="rect">
             <a:avLst/>
@@ -16397,7 +16689,7 @@
                 <a:ea typeface="Calibri" pitchFamily="34" charset="-122"/>
                 <a:cs typeface="Calibri" pitchFamily="34" charset="-120"/>
               </a:rPr>
-              <a:t>l'Esprit applique la Parole (BEM)</a:t>
+              <a:t>l'Esprit applique la Parole</a:t>
             </a:r>
             <a:endParaRPr lang="fr-CA" sz="1700" dirty="0"/>
           </a:p>
@@ -16478,7 +16770,7 @@
               <a:buNone/>
             </a:pPr>
             <a:r>
-              <a:rPr lang="fr-CA" altLang="en-US" sz="1350" dirty="0">
+              <a:rPr lang="fr-CA" altLang="en-US" sz="1400" dirty="0">
                 <a:solidFill>
                   <a:srgbClr val="A89A8C"/>
                 </a:solidFill>
@@ -16486,7 +16778,7 @@
                 <a:ea typeface="Calibri" pitchFamily="34" charset="-122"/>
                 <a:cs typeface="Calibri" pitchFamily="34" charset="-120"/>
               </a:rPr>
-              <a:t>« La révélation de Dieu dans le monde : assez pour condamner, assez pour damner. La révélation dans la Parole : suffisante pour sauver » (80‑420)</a:t>
+              <a:t>« La révélation de Dieu dans le monde : assez pour condamner, assez pour damner. La révélation dans la Parole : suffisante pour sauver, suffisante pour sauver » (MacArthur)</a:t>
             </a:r>
             <a:endParaRPr lang="fr-CA" sz="1600" dirty="0"/>
           </a:p>
@@ -16927,7 +17219,7 @@
                 <a:ea typeface="Calibri" pitchFamily="34" charset="-122"/>
                 <a:cs typeface="Calibri" pitchFamily="34" charset="-120"/>
               </a:rPr>
-              <a:t>Six titres, six qualités, six bienfaits : six fois « l'Éternel »  (TM19‑6)</a:t>
+              <a:t>Six titres, six qualités, six bienfaits : six fois « l'Éternel »  (MacArthur)</a:t>
             </a:r>
             <a:endParaRPr lang="fr-CA" sz="1900" dirty="0"/>
           </a:p>
@@ -17097,7 +17389,7 @@
         </p:nvSpPr>
         <p:spPr>
           <a:xfrm>
-            <a:off x="777240" y="1847088"/>
+            <a:off x="777240" y="1828800"/>
             <a:ext cx="3291840" cy="274320"/>
           </a:xfrm>
           <a:prstGeom prst="rect">
@@ -17114,7 +17406,7 @@
               <a:buNone/>
             </a:pPr>
             <a:r>
-              <a:rPr lang="fr-CA" altLang="en-US" sz="1200" b="1" spc="200" kern="0" dirty="0">
+              <a:rPr lang="fr-CA" altLang="en-US" sz="1300" b="1" spc="100" kern="0" dirty="0">
                 <a:solidFill>
                   <a:srgbClr val="968A80"/>
                 </a:solidFill>
@@ -17124,7 +17416,7 @@
               </a:rPr>
               <a:t>TITRE</a:t>
             </a:r>
-            <a:endParaRPr lang="fr-CA" sz="1200" dirty="0"/>
+            <a:endParaRPr lang="fr-CA" sz="1300" dirty="0"/>
           </a:p>
         </p:txBody>
       </p:sp>
@@ -17136,7 +17428,7 @@
         </p:nvSpPr>
         <p:spPr>
           <a:xfrm>
-            <a:off x="4160520" y="1847088"/>
+            <a:off x="4160520" y="1828800"/>
             <a:ext cx="3291840" cy="274320"/>
           </a:xfrm>
           <a:prstGeom prst="rect">
@@ -17153,7 +17445,7 @@
               <a:buNone/>
             </a:pPr>
             <a:r>
-              <a:rPr lang="fr-CA" altLang="en-US" sz="1200" b="1" spc="200" kern="0" dirty="0">
+              <a:rPr lang="fr-CA" altLang="en-US" sz="1300" b="1" spc="100" kern="0" dirty="0">
                 <a:solidFill>
                   <a:srgbClr val="968A80"/>
                 </a:solidFill>
@@ -17163,7 +17455,7 @@
               </a:rPr>
               <a:t>QUALITÉ · NEG79 / MACARTHUR</a:t>
             </a:r>
-            <a:endParaRPr lang="fr-CA" sz="1200" dirty="0"/>
+            <a:endParaRPr lang="fr-CA" sz="1300" dirty="0"/>
           </a:p>
         </p:txBody>
       </p:sp>
@@ -17175,7 +17467,7 @@
         </p:nvSpPr>
         <p:spPr>
           <a:xfrm>
-            <a:off x="7635240" y="1847088"/>
+            <a:off x="7635240" y="1828800"/>
             <a:ext cx="3291840" cy="274320"/>
           </a:xfrm>
           <a:prstGeom prst="rect">
@@ -17192,7 +17484,7 @@
               <a:buNone/>
             </a:pPr>
             <a:r>
-              <a:rPr lang="fr-CA" altLang="en-US" sz="1200" b="1" spc="200" kern="0" dirty="0">
+              <a:rPr lang="fr-CA" altLang="en-US" sz="1300" b="1" spc="100" kern="0" dirty="0">
                 <a:solidFill>
                   <a:srgbClr val="968A80"/>
                 </a:solidFill>
@@ -17202,7 +17494,7 @@
               </a:rPr>
               <a:t>BIENFAIT</a:t>
             </a:r>
-            <a:endParaRPr lang="fr-CA" sz="1200" dirty="0"/>
+            <a:endParaRPr lang="fr-CA" sz="1300" dirty="0"/>
           </a:p>
         </p:txBody>
       </p:sp>
@@ -19111,7 +19403,7 @@
                 <a:ea typeface="Calibri" pitchFamily="34" charset="-122"/>
                 <a:cs typeface="Calibri" pitchFamily="34" charset="-120"/>
               </a:rPr>
-              <a:t>« On ne peut rien lui retrancher; on ne peut rien lui ajouter »  (80‑420)</a:t>
+              <a:t>« On ne peut rien lui retrancher; on ne peut rien lui ajouter »  (MacArthur)</a:t>
             </a:r>
             <a:endParaRPr lang="fr-CA" sz="1900" dirty="0"/>
           </a:p>
@@ -19442,7 +19734,7 @@
                 <a:ea typeface="Calibri" pitchFamily="34" charset="-122"/>
                 <a:cs typeface="Calibri" pitchFamily="34" charset="-120"/>
               </a:rPr>
-              <a:t>« Loi » : mieux rendue par « enseignement » (BEM).</a:t>
+              <a:t>« Loi » : mieux rendue par « enseignement » (Bible d'étude).</a:t>
             </a:r>
             <a:endParaRPr lang="fr-CA" sz="1500" dirty="0"/>
           </a:p>
@@ -19463,7 +19755,7 @@
                 <a:ea typeface="Calibri" pitchFamily="34" charset="-122"/>
                 <a:cs typeface="Calibri" pitchFamily="34" charset="-120"/>
               </a:rPr>
-              <a:t>« Parfaite » : au sens de complétude, non seulement d'irréprochable (80‑308).</a:t>
+              <a:t>« Parfaite » : au sens de complétude, non seulement d'irréprochable.</a:t>
             </a:r>
             <a:endParaRPr lang="fr-CA" sz="1500" dirty="0"/>
           </a:p>
@@ -19484,7 +19776,7 @@
                 <a:ea typeface="Calibri" pitchFamily="34" charset="-122"/>
                 <a:cs typeface="Calibri" pitchFamily="34" charset="-120"/>
               </a:rPr>
-              <a:t>« Restaure l'âme » : convertir, transformer, régénérer par l'œuvre de l'Esprit (80‑308).</a:t>
+              <a:t>« Restaure l'âme » : convertir, transformer, régénérer par l'œuvre de l'Esprit.</a:t>
             </a:r>
             <a:endParaRPr lang="fr-CA" sz="1500" dirty="0"/>
           </a:p>
@@ -19680,7 +19972,7 @@
                 <a:ea typeface="Calibri" pitchFamily="34" charset="-122"/>
                 <a:cs typeface="Calibri" pitchFamily="34" charset="-120"/>
               </a:rPr>
-              <a:t>Plus sûre que l'expérience : Pierre, témoin de la transfiguration (2 Pierre 1.16‑19; 80‑250).</a:t>
+              <a:t>Plus sûre que l'expérience : Pierre, témoin de la transfiguration (2 Pierre 1.16‑19).</a:t>
             </a:r>
             <a:endParaRPr lang="fr-CA" sz="1500" dirty="0"/>
           </a:p>
@@ -19701,7 +19993,7 @@
                 <a:ea typeface="Calibri" pitchFamily="34" charset="-122"/>
                 <a:cs typeface="Calibri" pitchFamily="34" charset="-120"/>
               </a:rPr>
-              <a:t>« Sage » : maîtriser l'art de vivre (80‑250).</a:t>
+              <a:t>L'« ignorant » : le naïf, sans discernement; l'Écriture lui apporte la sagesse.</a:t>
             </a:r>
             <a:endParaRPr lang="fr-CA" sz="1500" dirty="0"/>
           </a:p>
@@ -19722,7 +20014,7 @@
                 <a:ea typeface="Calibri" pitchFamily="34" charset="-122"/>
                 <a:cs typeface="Calibri" pitchFamily="34" charset="-120"/>
               </a:rPr>
-              <a:t>« La Parole est le sentier » (80‑250).</a:t>
+              <a:t>« Sage » : maîtriser l'art de vivre.</a:t>
             </a:r>
             <a:endParaRPr lang="fr-CA" sz="1500" dirty="0"/>
           </a:p>
@@ -19743,7 +20035,28 @@
                 <a:ea typeface="Calibri" pitchFamily="34" charset="-122"/>
                 <a:cs typeface="Calibri" pitchFamily="34" charset="-120"/>
               </a:rPr>
-              <a:t>« Purs » : clairs, ils éclairent les yeux (80‑308).</a:t>
+              <a:t>« La Parole est le sentier » (MacArthur).</a:t>
+            </a:r>
+            <a:endParaRPr lang="fr-CA" sz="1500" dirty="0"/>
+          </a:p>
+          <a:p>
+            <a:pPr marL="177800" indent="-177800">
+              <a:spcAft>
+                <a:spcPts val="900"/>
+              </a:spcAft>
+              <a:buSzPct val="100000"/>
+              <a:buChar char="•"/>
+            </a:pPr>
+            <a:r>
+              <a:rPr lang="fr-CA" altLang="en-US" sz="1500" dirty="0">
+                <a:solidFill>
+                  <a:srgbClr val="F4EDE4"/>
+                </a:solidFill>
+                <a:latin typeface="Calibri" pitchFamily="34" charset="0"/>
+                <a:ea typeface="Calibri" pitchFamily="34" charset="-122"/>
+                <a:cs typeface="Calibri" pitchFamily="34" charset="-120"/>
+              </a:rPr>
+              <a:t>« Purs » : clairs, ils éclairent les yeux.</a:t>
             </a:r>
             <a:endParaRPr lang="fr-CA" sz="1500" dirty="0"/>
           </a:p>
@@ -19918,7 +20231,7 @@
                 <a:ea typeface="Calibri" pitchFamily="34" charset="-122"/>
                 <a:cs typeface="Calibri" pitchFamily="34" charset="-120"/>
               </a:rPr>
-              <a:t>« Crainte » : l'Écriture, guide pour l'adoration (BEM); « un manuel du culte » (80‑308).</a:t>
+              <a:t>« Crainte » : l'Écriture, guide pour l'adoration; « un manuel du culte » (MacArthur).</a:t>
             </a:r>
             <a:endParaRPr lang="fr-CA" sz="1500" dirty="0"/>
           </a:p>
@@ -19939,7 +20252,7 @@
                 <a:ea typeface="Calibri" pitchFamily="34" charset="-122"/>
                 <a:cs typeface="Calibri" pitchFamily="34" charset="-120"/>
               </a:rPr>
-              <a:t>Nette, « sans tache, sans défaut » (80‑308) : jamais de mise à jour (80‑19).</a:t>
+              <a:t>Nette, « sans tache, sans défaut » (MacArthur) : jamais de mise à jour.</a:t>
             </a:r>
             <a:endParaRPr lang="fr-CA" sz="1500" dirty="0"/>
           </a:p>
@@ -19960,7 +20273,7 @@
                 <a:ea typeface="Calibri" pitchFamily="34" charset="-122"/>
                 <a:cs typeface="Calibri" pitchFamily="34" charset="-120"/>
               </a:rPr>
-              <a:t>« Absolument, sans équivoque, vrai » (80‑308).</a:t>
+              <a:t>« Absolument, sans équivoque, vrai » (MacArthur).</a:t>
             </a:r>
             <a:endParaRPr lang="fr-CA" sz="1500" dirty="0"/>
           </a:p>
@@ -21310,7 +21623,7 @@
                 <a:ea typeface="Calibri" pitchFamily="34" charset="-122"/>
                 <a:cs typeface="Calibri" pitchFamily="34" charset="-120"/>
               </a:rPr>
-              <a:t>Ce qui, dans l'Église, prend la place de la Parole : MacArthur, 1985 (80‑18)</a:t>
+              <a:t>Ce qui, dans l'Église, prend la place de la Parole : MacArthur, 1985</a:t>
             </a:r>
             <a:endParaRPr lang="fr-CA" sz="1400" dirty="0"/>
           </a:p>

</xml_diff>

<commit_message>
Psaume 19 : photo de la stèle de Hammurabi à la diapositive 3
La photo insérée dans PowerPoint (Codice_di_hammurabi_03.JPG, Sailko,
CC BY 2.5, Wikimedia Commons) remplace le dessin et passe dans deck.js,
crédit à l'écran; la tâche du dessin quitte illus.js.

Co-Authored-By: Claude Opus 5.5 <noreply@anthropic.com>
</commit_message>
<xml_diff>
--- a/Presentation-Psaume-19.pptx
+++ b/Presentation-Psaume-19.pptx
@@ -121,7 +121,7 @@
   <p:extLst>
     <p:ext uri="{521415D9-36F7-43E2-AB2F-B90AF26B5E84}">
       <p14:sectionLst xmlns:p14="http://schemas.microsoft.com/office/powerpoint/2010/main">
-        <p14:section name="Ouverture" id="{d0f512ac-2126-8f75-7cbb-4db93f4c8e42}">
+        <p14:section name="Ouverture" id="{ae73308b-331f-8530-73cb-97906b768366}">
           <p14:sldIdLst>
             <p14:sldId id="256"/>
             <p14:sldId id="257"/>
@@ -129,13 +129,13 @@
             <p14:sldId id="259"/>
           </p14:sldIdLst>
         </p14:section>
-        <p14:section name="I. Le ciel qui parle" id="{8da859fc-e8ab-8147-1dd8-95af739f5ab3}">
+        <p14:section name="I. Le ciel qui parle" id="{b128673a-6448-f014-1391-e37fc41f15e3}">
           <p14:sldIdLst>
             <p14:sldId id="260"/>
             <p14:sldId id="261"/>
           </p14:sldIdLst>
         </p14:section>
-        <p14:section name="II. La Parole qui suffit" id="{f55662e7-f484-43a6-c8b4-782478461ca5}">
+        <p14:section name="II. La Parole qui suffit" id="{edf6b329-f805-7e60-afe7-3ce14d42b25d}">
           <p14:sldIdLst>
             <p14:sldId id="262"/>
             <p14:sldId id="263"/>
@@ -143,18 +143,18 @@
             <p14:sldId id="265"/>
           </p14:sldIdLst>
         </p14:section>
-        <p14:section name="III. La Parole qu'on désire" id="{dff51e5b-d282-0364-d050-c8ae22002c06}">
+        <p14:section name="III. La Parole qu'on désire" id="{3b3dc1a1-9178-2c8d-9e23-e0b398f5627a}">
           <p14:sldIdLst>
             <p14:sldId id="266"/>
           </p14:sldIdLst>
         </p14:section>
-        <p14:section name="IV. Le cœur qui s'offre" id="{9a46eb8e-b315-76a3-3265-efe1d78e1bfd}">
+        <p14:section name="IV. Le cœur qui s'offre" id="{978bf33d-a206-6fc7-cdb2-c980801854be}">
           <p14:sldIdLst>
             <p14:sldId id="267"/>
             <p14:sldId id="268"/>
           </p14:sldIdLst>
         </p14:section>
-        <p14:section name="Conclusion" id="{73c44f17-2889-c6df-58a1-c5ad318d4d24}">
+        <p14:section name="Conclusion" id="{5ad16ede-654b-61f6-67b9-a79a9b47cd34}">
           <p14:sldIdLst>
             <p14:sldId id="269"/>
             <p14:sldId id="270"/>
@@ -757,7 +757,7 @@
             </a:pPr>
             <a:r>
               <a:rPr lang="fr-CA" sz="1400" dirty="0"/>
-              <a:t>Préparer à l'écran le tableau des six lignes (diapositive 7) et, pour l'accroche, une image de la stèle de Hammurabi : la diapositive 3 en propose un dessin, à remplacer par une photo au besoin.</a:t>
+              <a:t>Préparer à l'écran le tableau des six lignes (diapositive 7) et, pour l'accroche, la photo de la stèle de Hammurabi (diapositive 3).</a:t>
             </a:r>
           </a:p>
           <a:p>
@@ -13783,7 +13783,7 @@
       </p:sp>
       <p:pic>
         <p:nvPicPr>
-          <p:cNvPr id="5" name="Image 0" descr="Stèle stylisée : en haut, un roi debout devant le dieu-soleil; en dessous, des lignes d'écriture cunéiforme">    </p:cNvPr>
+          <p:cNvPr id="5" name="Photo de la stèle" descr="Photo : partie supérieure de la stèle de Hammurabi (Louvre), le roi debout devant Shamash assis sur son trône">    </p:cNvPr>
           <p:cNvPicPr>
             <a:picLocks noChangeAspect="1"/>
           </p:cNvPicPr>
@@ -13797,8 +13797,8 @@
         </p:blipFill>
         <p:spPr>
           <a:xfrm>
-            <a:off x="1143000" y="1920240"/>
-            <a:ext cx="2240280" cy="3200400"/>
+            <a:off x="1197864" y="1920240"/>
+            <a:ext cx="2185416" cy="2916936"/>
           </a:xfrm>
           <a:prstGeom prst="rect">
             <a:avLst/>
@@ -13813,8 +13813,8 @@
         </p:nvSpPr>
         <p:spPr>
           <a:xfrm>
-            <a:off x="274320" y="5193792"/>
-            <a:ext cx="3977640" cy="731520"/>
+            <a:off x="274320" y="5029200"/>
+            <a:ext cx="3977640" cy="868680"/>
           </a:xfrm>
           <a:prstGeom prst="rect">
             <a:avLst/>
@@ -13855,7 +13855,27 @@
                 <a:ea typeface="Calibri" pitchFamily="34" charset="-122"/>
                 <a:cs typeface="Calibri" pitchFamily="34" charset="-120"/>
               </a:rPr>
-              <a:t>le roi devant Shamash, dieu-soleil et dieu de la justice</a:t>
+              <a:t>le roi devant Shamash, le dieu-soleil</a:t>
+            </a:r>
+            <a:endParaRPr lang="fr-CA" sz="1500" dirty="0"/>
+          </a:p>
+          <a:p>
+            <a:pPr algn="ctr" indent="0" marL="0">
+              <a:spcBef>
+                <a:spcPts val="400"/>
+              </a:spcBef>
+              <a:buNone/>
+            </a:pPr>
+            <a:r>
+              <a:rPr lang="fr-CA" altLang="en-US" sz="1300" dirty="0">
+                <a:solidFill>
+                  <a:srgbClr val="968A80"/>
+                </a:solidFill>
+                <a:latin typeface="Calibri" pitchFamily="34" charset="0"/>
+                <a:ea typeface="Calibri" pitchFamily="34" charset="-122"/>
+                <a:cs typeface="Calibri" pitchFamily="34" charset="-120"/>
+              </a:rPr>
+              <a:t>Photo : Sailko, CC BY 2.5, Wikimedia Commons</a:t>
             </a:r>
             <a:endParaRPr lang="fr-CA" sz="1500" dirty="0"/>
           </a:p>

</xml_diff>

<commit_message>
Psaume 19 : revue de cohérence du plan, de la recherche et du PowerPoint
Revue en 9 dimensions (plan/deck, plan/recherche, texte biblique NEG79,
citations de MacArthur contre gty.org, Street et BEM, théologie, langue,
visuel), chaque constat éprouvé par un vérificateur adverse. Retenu :

- Citations bibliques ramenées à la NEG79 (2 Pierre 1.19, Hébreux 1.2 et
  4.12, Nombres 15.27-31); versions KJF et S21 signalées comme telles.
- Citations de MacArthur resserrées sur les transcriptions (80-18, 80-308).
- Appel : l'Évangile énoncé à l'incroyant, la grâce nommée au croyant,
  la demande de grâce de David (BEM 19.15) rétablie.
- Plan, notes et recherche alignés : ligne Source (55-17, 55-19), lecture
  publique située et minutée, textes d'appui, titres de sections.
- Diapositives : coupures de ligne, translittérations en italique,
  alignements, tailles de police, icône du rocher.

Audit : 15 diapositives, 1312 contrôles, 0 écart.

Co-Authored-By: Claude Sonnet 5.5 <noreply@anthropic.com>
</commit_message>
<xml_diff>
--- a/Presentation-Psaume-19.pptx
+++ b/Presentation-Psaume-19.pptx
@@ -121,7 +121,7 @@
   <p:extLst>
     <p:ext uri="{521415D9-36F7-43E2-AB2F-B90AF26B5E84}">
       <p14:sectionLst xmlns:p14="http://schemas.microsoft.com/office/powerpoint/2010/main">
-        <p14:section name="Ouverture" id="{ae73308b-331f-8530-73cb-97906b768366}">
+        <p14:section name="Ouverture" id="{f04809b4-4310-43e8-cf39-6c19c89163f4}">
           <p14:sldIdLst>
             <p14:sldId id="256"/>
             <p14:sldId id="257"/>
@@ -129,13 +129,13 @@
             <p14:sldId id="259"/>
           </p14:sldIdLst>
         </p14:section>
-        <p14:section name="I. Le ciel qui parle" id="{b128673a-6448-f014-1391-e37fc41f15e3}">
+        <p14:section name="I. Le ciel qui parle" id="{0e994664-0eca-261b-f080-becfbbc4951e}">
           <p14:sldIdLst>
             <p14:sldId id="260"/>
             <p14:sldId id="261"/>
           </p14:sldIdLst>
         </p14:section>
-        <p14:section name="II. La Parole qui suffit" id="{edf6b329-f805-7e60-afe7-3ce14d42b25d}">
+        <p14:section name="II. La Parole qui suffit" id="{98c1f9e8-baaf-3518-899b-7eaf79406466}">
           <p14:sldIdLst>
             <p14:sldId id="262"/>
             <p14:sldId id="263"/>
@@ -143,18 +143,18 @@
             <p14:sldId id="265"/>
           </p14:sldIdLst>
         </p14:section>
-        <p14:section name="III. La Parole qu'on désire" id="{3b3dc1a1-9178-2c8d-9e23-e0b398f5627a}">
+        <p14:section name="III. La Parole qu'on désire" id="{92526145-4157-280f-3499-91d04996938a}">
           <p14:sldIdLst>
             <p14:sldId id="266"/>
           </p14:sldIdLst>
         </p14:section>
-        <p14:section name="IV. Le cœur qui s'offre" id="{978bf33d-a206-6fc7-cdb2-c980801854be}">
+        <p14:section name="IV. Le cœur qui s'offre" id="{6fb97dfa-42d6-aefe-55f9-17e471efc4fd}">
           <p14:sldIdLst>
             <p14:sldId id="267"/>
             <p14:sldId id="268"/>
           </p14:sldIdLst>
         </p14:section>
-        <p14:section name="Conclusion" id="{5ad16ede-654b-61f6-67b9-a79a9b47cd34}">
+        <p14:section name="Conclusion" id="{421a1c06-051c-4c26-ef30-270f0bf18135}">
           <p14:sldIdLst>
             <p14:sldId id="269"/>
             <p14:sldId id="270"/>
@@ -587,7 +587,7 @@
             </a:r>
             <a:r>
               <a:rPr lang="fr-CA" sz="1400" dirty="0"/>
-              <a:t>Psaume 19 (en entier), avec à l'écran ses trois mouvements (diapositive 2) : le cosmos (19.2-7), l'Écriture (19.8-12), le cœur (19.13-15).</a:t>
+              <a:t>Psaume 19 (en entier), après le Rappel et avant l'accroche, avec à l'écran ses trois mouvements (diapositive 2) : le cosmos (19.2-7), l'Écriture (19.8-12), le cœur (19.13-15).</a:t>
             </a:r>
           </a:p>
           <a:p>
@@ -604,7 +604,7 @@
             </a:r>
             <a:r>
               <a:rPr lang="fr-CA" sz="1400" dirty="0"/>
-              <a:t>45 minutes.</a:t>
+              <a:t>45 minutes, plus la lecture publique du Psaume 19 (environ 2 min, hors tableau).</a:t>
             </a:r>
           </a:p>
           <a:p>
@@ -617,11 +617,11 @@
             </a:pPr>
             <a:r>
               <a:rPr lang="fr-CA" sz="1400" b="1" dirty="0"/>
-              <a:t>Phrase à faire retenir : </a:t>
+              <a:t>Idée centrale : </a:t>
             </a:r>
             <a:r>
               <a:rPr lang="fr-CA" sz="1400" dirty="0"/>
-              <a:t>Les cieux suffisent à condamner; la Parole suffit à sauver.</a:t>
+              <a:t>Le Dieu qui parle sans paroles dans la création, assez pour rendre tout homme inexcusable, parle avec des paroles dans l'Écriture, assez pour sauver et transformer; cette Parole, plus précieuse que l'or, sonde le cœur et le conduit à s'offrir à l'Éternel, son rocher et son rédempteur.</a:t>
             </a:r>
           </a:p>
           <a:p>
@@ -634,11 +634,11 @@
             </a:pPr>
             <a:r>
               <a:rPr lang="fr-CA" sz="1400" b="1" dirty="0"/>
-              <a:t>But : </a:t>
+              <a:t>Phrase à faire retenir : </a:t>
             </a:r>
             <a:r>
               <a:rPr lang="fr-CA" sz="1400" dirty="0"/>
-              <a:t>que l'incroyant comprenne que la création le rend inexcusable sans pouvoir le sauver, et qu'il écoute la Parole qui convertit l'âme; que le croyant cesse de chercher ailleurs ce que la Parole lui donne, la désire plus que l'or, la laisse sonder son cœur et offre à Dieu ses paroles et ses pensées.</a:t>
+              <a:t>Les cieux suffisent à condamner; la Parole suffit à sauver.</a:t>
             </a:r>
           </a:p>
           <a:p>
@@ -651,23 +651,11 @@
             </a:pPr>
             <a:r>
               <a:rPr lang="fr-CA" sz="1400" b="1" dirty="0"/>
-              <a:t>Citations : </a:t>
+              <a:t>But : </a:t>
             </a:r>
             <a:r>
               <a:rPr lang="fr-CA" sz="1400" dirty="0"/>
-              <a:t>NEG79. Les sermons de MacArthur comptent la suscription hors des versets : leurs « versets 7 à 9 » sont les versets 8 à 10 de la NEG79.</a:t>
-            </a:r>
-          </a:p>
-          <a:p>
-            <a:pPr marL="0" indent="0">
-              <a:spcBef>
-                <a:spcPts val="600"/>
-              </a:spcBef>
-              <a:buNone/>
-            </a:pPr>
-            <a:r>
-              <a:rPr lang="fr-CA" sz="1400" b="1" dirty="0"/>
-              <a:t>À éviter</a:t>
+              <a:t>que l'incroyant comprenne que la création le rend inexcusable sans pouvoir le sauver, et qu'il écoute la Parole qui convertit l'âme, se repente et croie au Rédempteur; que le croyant cesse de chercher ailleurs ce que la Parole lui donne, la désire plus que l'or, la laisse sonder son cœur et offre à Dieu ses paroles et ses pensées.</a:t>
             </a:r>
           </a:p>
           <a:p>
@@ -679,8 +667,24 @@
               <a:buChar char="•"/>
             </a:pPr>
             <a:r>
+              <a:rPr lang="fr-CA" sz="1400" b="1" dirty="0"/>
+              <a:t>Citations : </a:t>
+            </a:r>
+            <a:r>
               <a:rPr lang="fr-CA" sz="1400" dirty="0"/>
-              <a:t>Attribuer à MacArthur les propos de Street : les citer sous son nom.</a:t>
+              <a:t>NEG79. Les sermons de MacArthur comptent la suscription hors des versets; leurs « versets 7 à 9 » sont les versets 8 à 10 de la NEG79.</a:t>
+            </a:r>
+          </a:p>
+          <a:p>
+            <a:pPr marL="0" indent="0">
+              <a:spcBef>
+                <a:spcPts val="600"/>
+              </a:spcBef>
+              <a:buNone/>
+            </a:pPr>
+            <a:r>
+              <a:rPr lang="fr-CA" sz="1400" b="1" dirty="0"/>
+              <a:t>À éviter</a:t>
             </a:r>
           </a:p>
           <a:p>
@@ -693,19 +697,7 @@
             </a:pPr>
             <a:r>
               <a:rPr lang="fr-CA" sz="1400" dirty="0"/>
-              <a:t>Numérotation : les « versets 7 à 9 » des sermons de MacArthur sont les versets 8 à 10 de la NEG79.</a:t>
-            </a:r>
-          </a:p>
-          <a:p>
-            <a:pPr marL="0" indent="0">
-              <a:spcBef>
-                <a:spcPts val="600"/>
-              </a:spcBef>
-              <a:buNone/>
-            </a:pPr>
-            <a:r>
-              <a:rPr lang="fr-CA" sz="1400" b="1" dirty="0"/>
-              <a:t>Avant de monter en chaire</a:t>
+              <a:t>Attribuer à MacArthur les propos de Street : les citer sous le nom de Street.</a:t>
             </a:r>
           </a:p>
           <a:p>
@@ -718,7 +710,19 @@
             </a:pPr>
             <a:r>
               <a:rPr lang="fr-CA" sz="1400" dirty="0"/>
-              <a:t>Relire à voix haute les citations bibliques dans votre Bible NEG79.</a:t>
+              <a:t>Numérotation : les « versets 7 à 9 » des sermons de MacArthur sont les versets 8 à 10 de la NEG79.</a:t>
+            </a:r>
+          </a:p>
+          <a:p>
+            <a:pPr marL="0" indent="0">
+              <a:spcBef>
+                <a:spcPts val="600"/>
+              </a:spcBef>
+              <a:buNone/>
+            </a:pPr>
+            <a:r>
+              <a:rPr lang="fr-CA" sz="1400" b="1" dirty="0"/>
+              <a:t>Avant de monter en chaire</a:t>
             </a:r>
           </a:p>
           <a:p>
@@ -731,7 +735,7 @@
             </a:pPr>
             <a:r>
               <a:rPr lang="fr-CA" sz="1400" dirty="0"/>
-              <a:t>Les citations de MacArthur sont des traductions de passages relus dans les transcriptions de gty.org. Avant de les prononcer, réécouter ou relire au moins 80-420, 80-308 et TM19-6.</a:t>
+              <a:t>Relire à voix haute les citations bibliques dans votre Bible NEG79.</a:t>
             </a:r>
           </a:p>
           <a:p>
@@ -744,7 +748,7 @@
             </a:pPr>
             <a:r>
               <a:rPr lang="fr-CA" sz="1400" dirty="0"/>
-              <a:t>Le tableau du point II affiche les mots de la NEG79; MacArthur lit « claire » et « nette » : le dire à voix haute.</a:t>
+              <a:t>Les citations de MacArthur sont des traductions de passages relus dans les transcriptions de gty.org. Avant de les prononcer, réécouter ou relire au moins 80-420, 80-308 et TM19-6, puis 80-250 et 80-251 (points II et III), GTY143 (conclusion), 55-17 et 55-19 (Rappel).</a:t>
             </a:r>
           </a:p>
           <a:p>
@@ -757,7 +761,7 @@
             </a:pPr>
             <a:r>
               <a:rPr lang="fr-CA" sz="1400" dirty="0"/>
-              <a:t>Préparer à l'écran le tableau des six lignes (diapositive 7) et, pour l'accroche, la photo de la stèle de Hammurabi (diapositive 3).</a:t>
+              <a:t>Le tableau du point II affiche les mots de la NEG79, suivis de la lecture de MacArthur : dire à voix haute que « sûr », « clairs » et « nette » sont ses mots, non ceux de la NEG79.</a:t>
             </a:r>
           </a:p>
           <a:p>
@@ -770,7 +774,7 @@
             </a:pPr>
             <a:r>
               <a:rPr lang="fr-CA" sz="1400" dirty="0"/>
-              <a:t>Chronométrer une répétition : le point II est le plus long; les sous-points I.A et III sont les plus faciles à raccourcir.</a:t>
+              <a:t>Vérifier à l'écran le tableau des six lignes (diapositive 7) et, pour l'accroche, la photo de la stèle de Hammurabi (diapositive 3).</a:t>
             </a:r>
           </a:p>
           <a:p>
@@ -783,7 +787,20 @@
             </a:pPr>
             <a:r>
               <a:rPr lang="fr-CA" sz="1400" dirty="0"/>
-              <a:t>Imprimer la version PDF de ce plan.</a:t>
+              <a:t>Chronométrer une répétition : le point II est le plus long; le sous-point I.A et le point III sont les plus faciles à raccourcir.</a:t>
+            </a:r>
+          </a:p>
+          <a:p>
+            <a:pPr marL="228600" indent="-228600">
+              <a:spcBef>
+                <a:spcPts val="300"/>
+              </a:spcBef>
+              <a:buFont typeface="Arial"/>
+              <a:buChar char="•"/>
+            </a:pPr>
+            <a:r>
+              <a:rPr lang="fr-CA" sz="1400" dirty="0"/>
+              <a:t>Imprimer la version PDF du plan de prédication.</a:t>
             </a:r>
           </a:p>
           <a:p>
@@ -906,7 +923,7 @@
             </a:pPr>
             <a:r>
               <a:rPr lang="fr-CA" sz="1400" dirty="0"/>
-              <a:t>En 1985, MacArthur passait en revue ce qui tient lieu de Parole dans l'Église : techniques de gestion, divertissement, mysticisme, psychologie, visualisation, confession positive (80-18).</a:t>
+              <a:t>En 1985, MacArthur passait en revue ce qui, dans l'Église, s'attaque à la suffisance de la Parole : techniques de gestion empruntées au monde, divertissement, mysticisme et occultisme (confession positive, visualisation) et, peut-être plus que tout le reste, psychologie (80-18).</a:t>
             </a:r>
           </a:p>
           <a:p>
@@ -965,7 +982,7 @@
             </a:pPr>
             <a:r>
               <a:rPr lang="fr-CA" sz="1400" dirty="0"/>
-              <a:t>Faire de la suffisance un mépris des sciences : Street reconnaît les bienfaits de la révélation naturelle en sciences et en médecine; la suffisance vise le domaine de l'âme.</a:t>
+              <a:t>Faire de la suffisance un mépris des sciences : Street reconnaît les bienfaits de la révélation naturelle en sciences naturelles et en médecine; la suffisance vise le domaine de l'âme.</a:t>
             </a:r>
           </a:p>
           <a:p>
@@ -1117,7 +1134,7 @@
             </a:r>
             <a:r>
               <a:rPr lang="fr-CA" sz="1400" dirty="0"/>
-              <a:t>« L'or, dans l'Antiquité, était le bien suprême d'ici-bas »; « le délice des délices, en ce temps-là, c'était le miel » (80-251). Le plus grand bien qu'on puisse posséder, le plus grand plaisir qu'on puisse goûter (80-19; TM19-6).</a:t>
+              <a:t>« L'or, dans l'Antiquité, était le bien suprême d'ici-bas »; « le délice des délices, en ce temps-là, c'était le miel » (80-251). Le plus grand bien qu'on puisse posséder, le plus grand plaisir qu'on puisse goûter (80-19; 80-251; TM19-6).</a:t>
             </a:r>
           </a:p>
           <a:p>
@@ -1134,7 +1151,7 @@
             </a:r>
             <a:r>
               <a:rPr lang="fr-CA" sz="1400" dirty="0"/>
-              <a:t>« La Parole de Dieu est pleine d'avertissements. Et celui qui la connaît est dûment averti » (80-251). La KJF dit « est averti ».</a:t>
+              <a:t>« La Parole de Dieu est pleine d'avertissements. Et celui qui la connaît est dûment averti » (80-251). La NEG79 dit « en reçoit instruction »; la KJF, « est averti ».</a:t>
             </a:r>
           </a:p>
           <a:p>
@@ -1147,11 +1164,11 @@
             </a:pPr>
             <a:r>
               <a:rPr lang="fr-CA" sz="1400" b="1" dirty="0"/>
-              <a:t>Une récompense grande : </a:t>
+              <a:t>Une grande récompense : </a:t>
             </a:r>
             <a:r>
               <a:rPr lang="fr-CA" sz="1400" dirty="0"/>
-              <a:t>« La vraie récompense n'est pas ici et maintenant », ni la confession positive ni la visualisation de ce qu'on veut tout de suite (80-19). « L'hébreu se lit littéralement ainsi : en les gardant, il y a la fin. La fin » (80-251).</a:t>
+              <a:t>« La vraie récompense n'est pas ici et maintenant », elle n'est ni la confession positive ni la visualisation de ce qu'on veut tout de suite (80-19). « L'hébreu se lit littéralement ainsi : en les gardant, il y a la fin. La fin » (80-251) : la bénédiction éternelle de celui qui obéit.</a:t>
             </a:r>
           </a:p>
           <a:p>
@@ -1168,7 +1185,7 @@
             </a:r>
             <a:r>
               <a:rPr lang="fr-CA" sz="1400" dirty="0"/>
-              <a:t>les noms mêmes de la Parole commandent de l'aborder avec le plus grand respect, non avec désinvolture (Street).</a:t>
+              <a:t>les noms mêmes de la Parole commandent de l'aborder avec le plus grand respect, non avec désinvolture; c'est ainsi qu'on la trouve douce (Street).</a:t>
             </a:r>
           </a:p>
           <a:p>
@@ -1446,7 +1463,7 @@
             </a:pPr>
             <a:r>
               <a:rPr lang="fr-CA" sz="1400" dirty="0"/>
-              <a:t>La NEG79 dit « des orgueilleux »; la KJF, « des péchés présomptueux » : ceux que je vois, prémédite et planifie (80-19).</a:t>
+              <a:t>La NEG79 dit « des orgueilleux »; la KJF, « des péchés présomptueux » : ceux que je vois, prémédite et planifie (80-19). En fin de verset, la NEG79 dit « innocent de grands péchés »; la KJF, « innocent de la grande transgression » : la rébellion ouverte (TM19-6).</a:t>
             </a:r>
           </a:p>
           <a:p>
@@ -1459,7 +1476,7 @@
             </a:pPr>
             <a:r>
               <a:rPr lang="fr-CA" sz="1400" dirty="0"/>
-              <a:t>La loi distinguait le péché par inadvertance, qui avait son sacrifice, et le péché commis par défi, qui n'en avait pas (Nombres 15.30-31); la BEM renvoie à Nombres 15.22ss (19.13-14).</a:t>
+              <a:t>La loi distinguait le péché commis involontairement, qui avait son sacrifice (Nombres 15.27-29), et le péché commis « la main levée », qui n'en avait pas (Nombres 15.30-31); la BEM renvoie à Nombres 15.22ss pour éclairer cette distinction (19.13-14).</a:t>
             </a:r>
           </a:p>
           <a:p>
@@ -1620,7 +1637,7 @@
             </a:r>
             <a:r>
               <a:rPr lang="fr-CA" sz="1400" dirty="0"/>
-              <a:t>un terme souvent associé à l'acceptation des sacrifices; David dépose sur l'autel le sacrifice de ses lèvres et de sa vie (BEM, 19.15). Il ne promet pas de se corriger par ses propres forces : il demande à Dieu la grâce et les capacités nécessaires (BEM, 19.15).</a:t>
+              <a:t>un terme souvent associé à l'acceptation des sacrifices; David demande à Dieu la grâce et les capacités nécessaires pour déposer sur l'autel le sacrifice de ses lèvres et de sa vie (BEM, 19.15).</a:t>
             </a:r>
           </a:p>
           <a:p>
@@ -1637,7 +1654,7 @@
             </a:r>
             <a:r>
               <a:rPr lang="fr-CA" sz="1400" dirty="0"/>
-              <a:t>l'écho de Josué 1.8, la loi méditée jour et nuit (BEM, 19.15; TM19-6; 80-251).</a:t>
+              <a:t>les « sentiments » du cœur (hegyon, la méditation) : l'écho de Josué 1.8, la loi méditée jour et nuit (BEM, 19.15; TM19-6; 80-251).</a:t>
             </a:r>
           </a:p>
           <a:p>
@@ -1705,7 +1722,7 @@
             </a:pPr>
             <a:r>
               <a:rPr lang="fr-CA" sz="1400" dirty="0"/>
-              <a:t>Quand la Parole fait son œuvre, on marche sans culpabilité, « intègre » (19.14).</a:t>
+              <a:t>Quand la Parole fait son œuvre, on marche sans culpabilité, « intègre » (19.14; Street) : non par l'effort propre, mais par la grâce du Rédempteur, qui pardonne toute faute confessée.</a:t>
             </a:r>
           </a:p>
           <a:p>
@@ -1836,7 +1853,7 @@
             </a:pPr>
             <a:r>
               <a:rPr lang="fr-CA" sz="1400" b="1" dirty="0"/>
-              <a:t>4 min · Romains 10.17; Psaume 19.15</a:t>
+              <a:t>4 min (avec la diapositive suivante) · Romains 10.17; Psaume 19.15</a:t>
             </a:r>
           </a:p>
           <a:p>
@@ -1870,7 +1887,7 @@
             </a:r>
             <a:r>
               <a:rPr lang="fr-CA" sz="1400" dirty="0"/>
-              <a:t>Dieu qui a parlé autrefois par les prophètes nous a parlé en son Fils (Hébreux 1.1-2). « Personne ne peut être sauvé, régénéré, né de nouveau sans comprendre la Parole de Dieu, en particulier la Parole de Dieu concernant la personne de Jésus-Christ » (GTY143; Romains 10.17).</a:t>
+              <a:t>Dieu, qui a parlé autrefois par les prophètes, nous a parlé par le Fils (Hébreux 1.1-2). Paul rappelle, juste avant de citer notre psaume (Romains 10.18), que la foi vient de ce qu'on entend, et que ce qu'on entend vient de la parole de Christ (Romains 10.17). « Personne ne peut être sauvé, régénéré, né de nouveau sans comprendre la Parole de Dieu, en particulier la Parole de Dieu concernant la personne de Jésus-Christ » (GTY143).</a:t>
             </a:r>
           </a:p>
           <a:p>
@@ -1887,7 +1904,7 @@
             </a:r>
             <a:r>
               <a:rPr lang="fr-CA" sz="1400" dirty="0"/>
-              <a:t>les cieux vous ont parlé toute votre vie, et vous êtes sans excuse. Aujourd'hui, la Parole vous parle du Rédempteur : repentez-vous, croyez en Christ et soumettez-vous à lui comme Seigneur.</a:t>
+              <a:t>les cieux vous ont parlé toute votre vie, et vous êtes sans excuse. Aujourd'hui, la Parole vous parle du Rédempteur : Christ est mort pour nos péchés et il est ressuscité (1 Corinthiens 15.3-4); il a payé le rachat, non avec de l'or, mais par son sang précieux (1 Pierre 1.18-19). Repentez-vous, croyez en Christ et soumettez-vous à lui comme Seigneur.</a:t>
             </a:r>
           </a:p>
           <a:p>
@@ -1904,7 +1921,7 @@
             </a:r>
             <a:r>
               <a:rPr lang="fr-CA" sz="1400" dirty="0"/>
-              <a:t>ne cherchez pas ailleurs ce que la Parole vous donne. Désirez-la, laissez-la vous sonder, offrez-vous à Dieu. « Dans votre cœur, en ce moment, pouvez-vous prendre devant le Seigneur un engagement renouvelé à vous vouer à sa Parole? » (80-19).</a:t>
+              <a:t>ne cherchez pas ailleurs ce que la Parole vous donne. Ce n'est pas un effort de plus : uni à Christ, vous avez reçu son Esprit, qui se sert de cette Parole pour vous transformer. Désirez-la, laissez-la vous sonder, offrez-vous à Dieu. « Dans votre cœur, en ce moment, pouvez-vous prendre devant le Seigneur un engagement renouvelé à vous vouer à sa Parole? » (80-19).</a:t>
             </a:r>
           </a:p>
         </p:txBody>
@@ -2171,7 +2188,7 @@
             </a:r>
             <a:r>
               <a:rPr lang="fr-CA" sz="1400" dirty="0"/>
-              <a:t>enseigner, convaincre, corriger, instruire dans la justice; pour que l'homme de Dieu soit propre non à la plupart des bonnes œuvres, mais à toutes (55-19).</a:t>
+              <a:t>enseigner, convaincre, corriger, instruire dans la justice, pour que l'homme de Dieu soit propre non à la plupart des bonnes œuvres, mais à toutes (55-19).</a:t>
             </a:r>
           </a:p>
           <a:p>
@@ -2188,7 +2205,7 @@
             </a:r>
             <a:r>
               <a:rPr lang="fr-CA" sz="1400" dirty="0"/>
-              <a:t>un psaume de David dit la même chose dix siècles plus tôt; c'est le texte que MacArthur tient pour le plus grand sur la suffisance de l'Écriture.</a:t>
+              <a:t>un psaume de David dit la même chose, dix siècles plus tôt : c'est le texte que MacArthur tient pour le plus grand sur la suffisance de l'Écriture.</a:t>
             </a:r>
           </a:p>
           <a:p>
@@ -2205,7 +2222,7 @@
             </a:r>
             <a:r>
               <a:rPr lang="fr-CA" sz="1400" dirty="0"/>
-              <a:t>Introduction au counseling biblique (Éditions Impact, 2021), chapitre de John Street sur le Psaume 19.</a:t>
+              <a:t>John Street, « Pourquoi parler de counseling biblique et non de psychologie? », dans Introduction au counseling biblique (Éditions Impact, 2021), p. 74-82, en particulier « Le paradigme du Psaume 19 ».</a:t>
             </a:r>
           </a:p>
           <a:p>
@@ -2285,7 +2302,7 @@
             </a:r>
             <a:r>
               <a:rPr lang="fr-CA" sz="1400" dirty="0"/>
-              <a:t>l'application; le cœur sondé, gardé, offert à l'Éternel, son rocher et son rédempteur.</a:t>
+              <a:t>l'application de la Parole, dernier volet de la révélation spéciale; le cœur sondé, gardé, présenté à l'Éternel, son rocher et son rédempteur.</a:t>
             </a:r>
           </a:p>
           <a:p>
@@ -2395,7 +2412,7 @@
             </a:pPr>
             <a:r>
               <a:rPr lang="fr-CA" sz="1400" b="1" dirty="0"/>
-              <a:t>4 min · Psaume 19.5, 8</a:t>
+              <a:t>4 min (avec la diapositive suivante) · Psaume 19.2, 5, 8</a:t>
             </a:r>
           </a:p>
           <a:p>
@@ -2564,7 +2581,7 @@
             </a:pPr>
             <a:r>
               <a:rPr lang="fr-CA" sz="1400" dirty="0"/>
-              <a:t>« Je pense que c'est le plus grand passage, à lui seul, sur la suffisance de l'Écriture dans toute la Bible » (80-18).</a:t>
+              <a:t>« Je pense que c'est le plus grand passage de toute la Bible sur la suffisance de l'Écriture » (80-18).</a:t>
             </a:r>
           </a:p>
           <a:p>
@@ -2581,7 +2598,7 @@
             </a:r>
             <a:r>
               <a:rPr lang="fr-CA" sz="1400" dirty="0"/>
-              <a:t>le nom court El, la puissance du Créateur (19.2); puis l'Éternel, le Dieu de l'alliance (19.8-15) (BEM, 19.1-15).</a:t>
+              <a:t>le nom court El, la puissance du Créateur (19.2); puis l'Éternel, le Dieu de l'alliance (19.8-15; BEM, 19.1-15).</a:t>
             </a:r>
           </a:p>
           <a:p>
@@ -2780,7 +2797,7 @@
             </a:r>
             <a:r>
               <a:rPr lang="fr-CA" sz="1400" dirty="0"/>
-              <a:t>la « gloire », c'est d'abord le poids; le ciel nocturne fait sentir le poids de Dieu (Street).</a:t>
+              <a:t>la « gloire » désigne à l'origine le poids, d'où l'importance; le ciel nocturne fait comprendre le poids de Dieu (Street).</a:t>
             </a:r>
           </a:p>
           <a:p>
@@ -2814,7 +2831,7 @@
             </a:r>
             <a:r>
               <a:rPr lang="fr-CA" sz="1400" dirty="0"/>
-              <a:t>la contradiction n'est qu'apparente, le message ne passe pas par des mots au sens littéral (BEM, 19.3-4). Paul cite le verset 5 en Romains 10.18.</a:t>
+              <a:t>la contradiction n'est qu'apparente, car le message ne passe pas par des mots au sens littéral (BEM, 19.3-4). Paul cite le verset 5 en Romains 10.18.</a:t>
             </a:r>
           </a:p>
           <a:p>
@@ -2852,7 +2869,7 @@
             </a:pPr>
             <a:r>
               <a:rPr lang="fr-CA" sz="1400" dirty="0"/>
-              <a:t>Ni le soleil ni les cieux ne sont divinisés, comme dans les religions païennes : Dieu est le créateur et le chef de toute la création (BEM, 19.5c-7). Retour à l'accroche.</a:t>
+              <a:t>Ni le soleil ni les cieux ne sont divinisés, comme dans les religions païennes : Dieu est le créateur et le chef de toute la création (BEM, 19.5c-7). Retour à l'accroche : le soleil n'est ni dieu ni législateur; il brûle, mais ne légifère pas, car la loi est à l'Éternel.</a:t>
             </a:r>
           </a:p>
           <a:p>
@@ -2971,7 +2988,7 @@
             </a:pPr>
             <a:r>
               <a:rPr lang="fr-CA" sz="1400" dirty="0"/>
-              <a:t>Le témoignage est clair et cohérent, mais l'humanité pécheresse lui résiste; il ne peut donc pas convertir, mais il rend entièrement responsable (BEM, 19.2-7).</a:t>
+              <a:t>Le témoignage est clair et cohérent, mais l'humanité pécheresse lui résiste; il ne peut donc pas la convertir, mais il la rend entièrement responsable. Seule la révélation spéciale apporte le salut, par l'application efficace que le Saint-Esprit fait de la Parole (BEM, 19.2-7).</a:t>
             </a:r>
           </a:p>
           <a:p>
@@ -3048,7 +3065,7 @@
             </a:pPr>
             <a:r>
               <a:rPr lang="fr-CA" sz="1400" dirty="0"/>
-              <a:t>Le croyant adore devant le ciel étoilé, mais ne lui demande ni le salut ni la direction de son âme.</a:t>
+              <a:t>Le croyant, lui, adore devant le ciel étoilé, mais ne lui demande ni le salut ni la direction de son âme.</a:t>
             </a:r>
           </a:p>
           <a:p>
@@ -3073,7 +3090,7 @@
             </a:pPr>
             <a:r>
               <a:rPr lang="fr-CA" sz="1400" dirty="0"/>
-              <a:t>« Le psalmiste passe du monde à la Parole au verset 7 » (80-420; verset 8 de la NEG79), et El devient l'Éternel. Où entendre la sagesse qui sauve?</a:t>
+              <a:t>Au verset 8, le psalmiste passe « du monde à la Parole » (80-420), et El devient l'Éternel. Où entendre la sagesse qui sauve?</a:t>
             </a:r>
           </a:p>
           <a:p>
@@ -3098,7 +3115,7 @@
             </a:pPr>
             <a:r>
               <a:rPr lang="fr-CA" sz="1400" dirty="0"/>
-              <a:t>Traiter les versets 2 à 7 comme une simple introduction poétique, ou, à l'inverse, comme une révélation qui sauve : elle rend inexcusable, sans convertir (BEM, 19.2-7).</a:t>
+              <a:t>Traiter les versets 2 à 7 comme une simple introduction poétique, ou, à l'inverse, comme une révélation qui sauve : la création rend l'homme inexcusable, sans le convertir (BEM, 19.2-7).</a:t>
             </a:r>
           </a:p>
           <a:p>
@@ -3272,7 +3289,7 @@
             </a:r>
             <a:r>
               <a:rPr lang="fr-CA" sz="1400" dirty="0"/>
-              <a:t>parfaite, sûre, droite, claire, nette, vraie (80-308). Le tableau affiche les mots de la NEG79; dire à voix haute « claire » et « nette ».</a:t>
+              <a:t>parfaite, sûre, droite, claire, nette, vraie (80-308). Le tableau affiche les mots de la NEG79, puis la lecture ou le sens chez MacArthur : dire que « sûr », « clairs » et « nette » sont ses mots, non ceux de la NEG79.</a:t>
             </a:r>
           </a:p>
           <a:p>
@@ -3382,7 +3399,7 @@
             </a:pPr>
             <a:r>
               <a:rPr lang="fr-CA" sz="1400" b="1" dirty="0"/>
-              <a:t>II.A · Restaure l'âme (19.8a)</a:t>
+              <a:t>A. Elle est complète et transforme (19.8a)</a:t>
             </a:r>
           </a:p>
           <a:p>
@@ -3395,7 +3412,7 @@
             </a:pPr>
             <a:r>
               <a:rPr lang="fr-CA" sz="1400" dirty="0"/>
-              <a:t>« Restaure l'âme » : « une instruction divine si complète qu'elle peut transformer totalement l'homme intérieur tout entier » (80-420).</a:t>
+              <a:t>La « loi » serait mieux rendue par « enseignement » (BEM, 19.8; cf. Psaume 1.2).</a:t>
             </a:r>
           </a:p>
           <a:p>
@@ -3408,7 +3425,7 @@
             </a:pPr>
             <a:r>
               <a:rPr lang="fr-CA" sz="1400" dirty="0"/>
-              <a:t>C'est « une déclaration d'une portée immense sur le pouvoir de la Bible de convertir, de transformer, de régénérer par l'œuvre de l'Esprit de Dieu au moyen de son propre témoignage » (80-308).</a:t>
+              <a:t>« Parfaite » (tamim) : « non pas au sens d'irréprochable, bien que ce soit absolument vrai, mais au sens de complétude » (80-308). « On ne peut rien lui retrancher; on ne peut rien lui ajouter » (80-420).</a:t>
             </a:r>
           </a:p>
           <a:p>
@@ -3420,12 +3437,20 @@
               <a:buChar char="•"/>
             </a:pPr>
             <a:r>
+              <a:rPr lang="fr-CA" sz="1400" dirty="0"/>
+              <a:t>« La Bible est complète, elle est parfaite en ce qu'elle fournit tout ce qu'il faut pour connaître la loi de Dieu, ce qui produit le bienfait de transformer totalement l'âme » (80-250).</a:t>
+            </a:r>
+          </a:p>
+          <a:p>
+            <a:pPr marL="0" indent="0">
+              <a:spcBef>
+                <a:spcPts val="600"/>
+              </a:spcBef>
+              <a:buNone/>
+            </a:pPr>
+            <a:r>
               <a:rPr lang="fr-CA" sz="1400" b="1" dirty="0"/>
-              <a:t>Meshivat nephesh : </a:t>
-            </a:r>
-            <a:r>
-              <a:rPr lang="fr-CA" sz="1400" dirty="0"/>
-              <a:t>le verbe shouv, à la forme causative, veut dire faire revenir, ramener; il couvre ranimer, restaurer, convertir. MacArthur comprend nephesh comme la personne entière, l'être intérieur (80-19; 80-420).</a:t>
+              <a:t>Restaure l'âme</a:t>
             </a:r>
           </a:p>
           <a:p>
@@ -3437,12 +3462,8 @@
               <a:buChar char="•"/>
             </a:pPr>
             <a:r>
-              <a:rPr lang="fr-CA" sz="1400" b="1" dirty="0"/>
-              <a:t>Le montrer : </a:t>
-            </a:r>
-            <a:r>
               <a:rPr lang="fr-CA" sz="1400" dirty="0"/>
-              <a:t>la S21 dit « donne du réconfort »; la Parole fait bien plus que consoler.</a:t>
+              <a:t>« Restaure l'âme » : « une instruction divine si complète qu'elle peut transformer totalement l'homme intérieur tout entier » (80-420).</a:t>
             </a:r>
           </a:p>
           <a:p>
@@ -3454,24 +3475,8 @@
               <a:buChar char="•"/>
             </a:pPr>
             <a:r>
-              <a:rPr lang="fr-CA" sz="1400" b="1" dirty="0"/>
-              <a:t>Street </a:t>
-            </a:r>
-            <a:r>
               <a:rPr lang="fr-CA" sz="1400" dirty="0"/>
-              <a:t>rapproche Hébreux 4.12 : la Parole juge les pensées et les intentions du cœur.</a:t>
-            </a:r>
-          </a:p>
-          <a:p>
-            <a:pPr marL="0" indent="0">
-              <a:spcBef>
-                <a:spcPts val="600"/>
-              </a:spcBef>
-              <a:buNone/>
-            </a:pPr>
-            <a:r>
-              <a:rPr lang="fr-CA" sz="1400" b="1" dirty="0"/>
-              <a:t>À éviter</a:t>
+              <a:t>C'est « une déclaration d'une portée immense sur le pouvoir de la Bible de convertir, de transformer, de régénérer par l'œuvre de l'Esprit de Dieu au moyen de son propre témoignage » (80-308).</a:t>
             </a:r>
           </a:p>
           <a:p>
@@ -3483,8 +3488,71 @@
               <a:buChar char="•"/>
             </a:pPr>
             <a:r>
+              <a:rPr lang="fr-CA" sz="1400" b="1" dirty="0"/>
+              <a:t>Meshivat nephesh : </a:t>
+            </a:r>
+            <a:r>
               <a:rPr lang="fr-CA" sz="1400" dirty="0"/>
-              <a:t>Affaiblir « restaure l'âme » en simple réconfort : c'est la conversion et la transformation de la personne entière (80-308).</a:t>
+              <a:t>le verbe shouv, à la forme causative, veut dire faire revenir, ramener; il couvre ranimer, restaurer, convertir. MacArthur comprend nephesh comme la personne entière, l'être intérieur (80-19; 80-420).</a:t>
+            </a:r>
+          </a:p>
+          <a:p>
+            <a:pPr marL="228600" indent="-228600">
+              <a:spcBef>
+                <a:spcPts val="300"/>
+              </a:spcBef>
+              <a:buFont typeface="Arial"/>
+              <a:buChar char="•"/>
+            </a:pPr>
+            <a:r>
+              <a:rPr lang="fr-CA" sz="1400" b="1" dirty="0"/>
+              <a:t>Le montrer : </a:t>
+            </a:r>
+            <a:r>
+              <a:rPr lang="fr-CA" sz="1400" dirty="0"/>
+              <a:t>la S21 dit « donne du réconfort »; la Parole fait bien plus que consoler.</a:t>
+            </a:r>
+          </a:p>
+          <a:p>
+            <a:pPr marL="228600" indent="-228600">
+              <a:spcBef>
+                <a:spcPts val="300"/>
+              </a:spcBef>
+              <a:buFont typeface="Arial"/>
+              <a:buChar char="•"/>
+            </a:pPr>
+            <a:r>
+              <a:rPr lang="fr-CA" sz="1400" b="1" dirty="0"/>
+              <a:t>Street </a:t>
+            </a:r>
+            <a:r>
+              <a:rPr lang="fr-CA" sz="1400" dirty="0"/>
+              <a:t>rapproche Hébreux 4.12 : la Parole « juge les sentiments et les pensées du cœur ».</a:t>
+            </a:r>
+          </a:p>
+          <a:p>
+            <a:pPr marL="0" indent="0">
+              <a:spcBef>
+                <a:spcPts val="600"/>
+              </a:spcBef>
+              <a:buNone/>
+            </a:pPr>
+            <a:r>
+              <a:rPr lang="fr-CA" sz="1400" b="1" dirty="0"/>
+              <a:t>À éviter</a:t>
+            </a:r>
+          </a:p>
+          <a:p>
+            <a:pPr marL="228600" indent="-228600">
+              <a:spcBef>
+                <a:spcPts val="300"/>
+              </a:spcBef>
+              <a:buFont typeface="Arial"/>
+              <a:buChar char="•"/>
+            </a:pPr>
+            <a:r>
+              <a:rPr lang="fr-CA" sz="1400" dirty="0"/>
+              <a:t>Réduire « restaure l'âme » à un simple réconfort : c'est la conversion et la transformation de la personne entière (80-308).</a:t>
             </a:r>
           </a:p>
         </p:txBody>
@@ -3577,7 +3645,7 @@
             </a:pPr>
             <a:r>
               <a:rPr lang="fr-CA" sz="1400" b="1" dirty="0"/>
-              <a:t>A. Elle est complète et transforme (19.8a)</a:t>
+              <a:t>A. Complète (19.8a) : rappel</a:t>
             </a:r>
           </a:p>
           <a:p>
@@ -3590,7 +3658,19 @@
             </a:pPr>
             <a:r>
               <a:rPr lang="fr-CA" sz="1400" dirty="0"/>
-              <a:t>La « loi » serait mieux rendue par « enseignement » (BEM, 19.8; cf. Psaume 1.2).</a:t>
+              <a:t>Colonne de gauche : traitée à la diapositive précédente; la montrer d'un mot et passer à B.</a:t>
+            </a:r>
+          </a:p>
+          <a:p>
+            <a:pPr marL="0" indent="0">
+              <a:spcBef>
+                <a:spcPts val="600"/>
+              </a:spcBef>
+              <a:buNone/>
+            </a:pPr>
+            <a:r>
+              <a:rPr lang="fr-CA" sz="1400" b="1" dirty="0"/>
+              <a:t>B. Elle est sûre et claire (19.8b-9)</a:t>
             </a:r>
           </a:p>
           <a:p>
@@ -3603,7 +3683,7 @@
             </a:pPr>
             <a:r>
               <a:rPr lang="fr-CA" sz="1400" dirty="0"/>
-              <a:t>« Parfaite » (tamim) : « non pas au sens d'irréprochable, bien que ce soit absolument vrai, mais au sens de complétude » (80-308). « On ne peut rien lui retrancher; on ne peut rien lui ajouter » (80-420).</a:t>
+              <a:t>Le « témoignage » témoigne de son auteur divin (BEM, 19.8). « Il est fiable, digne de confiance. Et il y a beaucoup de livres dans le monde auxquels on ne peut pas se fier » (80-308).</a:t>
             </a:r>
           </a:p>
           <a:p>
@@ -3616,7 +3696,7 @@
             </a:pPr>
             <a:r>
               <a:rPr lang="fr-CA" sz="1400" dirty="0"/>
-              <a:t>« La Bible est complète, elle est parfaite en ce qu'elle fournit tout ce qu'il faut pour connaître la loi de Dieu, ce qui produit le bienfait de transformer totalement l'âme » (80-250).</a:t>
+              <a:t>Pierre, témoin de la transfiguration, tient « pour d'autant plus certaine la parole prophétique » (2 Pierre 1.19) : MacArthur y lit une Parole plus sûre que l'expérience (80-250).</a:t>
             </a:r>
           </a:p>
           <a:p>
@@ -3629,19 +3709,7 @@
             </a:pPr>
             <a:r>
               <a:rPr lang="fr-CA" sz="1400" dirty="0"/>
-              <a:t>« Restaure l'âme » : voir la diapositive précédente (80-420; 80-308; S21; Hébreux 4.12).</a:t>
-            </a:r>
-          </a:p>
-          <a:p>
-            <a:pPr marL="0" indent="0">
-              <a:spcBef>
-                <a:spcPts val="600"/>
-              </a:spcBef>
-              <a:buNone/>
-            </a:pPr>
-            <a:r>
-              <a:rPr lang="fr-CA" sz="1400" b="1" dirty="0"/>
-              <a:t>B. Elle est sûre et claire (19.8b-9)</a:t>
+              <a:t>L'« ignorant » (peti) : « L'Écriture prend le naïf, l'inexpérimenté, l'homme sans discernement, le mal informé, et lui apporte la sagesse » (80-19). « Sage » (chakam) : « maîtriser l'art de vivre, vivre en parfait accord avec la connaissance de Dieu » (80-250).</a:t>
             </a:r>
           </a:p>
           <a:p>
@@ -3654,7 +3722,7 @@
             </a:pPr>
             <a:r>
               <a:rPr lang="fr-CA" sz="1400" dirty="0"/>
-              <a:t>Le « témoignage » témoigne de son auteur divin (BEM, 19.8). « Il est fiable, digne de confiance. Et il y a beaucoup de livres dans le monde auxquels on ne peut pas se fier » (80-308).</a:t>
+              <a:t>Les « ordonnances », moyens par lesquels Dieu gouverne (BEM, 19.9) : « La Parole n'est pas seulement une lampe à nos pieds qui éclaire le sentier, la Parole est le sentier » (80-250). La joie vient en le suivant (80-19).</a:t>
             </a:r>
           </a:p>
           <a:p>
@@ -3667,7 +3735,19 @@
             </a:pPr>
             <a:r>
               <a:rPr lang="fr-CA" sz="1400" dirty="0"/>
-              <a:t>Pierre, témoin de la transfiguration, tient la Parole pour plus sûre que ce qu'il a vu (2 Pierre 1.16-19; 80-250).</a:t>
+              <a:t>Les « commandements » lient; MacArthur les lit « clairs » (S21 : « clairs »; NEG79 : « purs ») : la Parole est limpide, elle « éclaire les yeux » (80-308; TM19-6).</a:t>
+            </a:r>
+          </a:p>
+          <a:p>
+            <a:pPr marL="0" indent="0">
+              <a:spcBef>
+                <a:spcPts val="600"/>
+              </a:spcBef>
+              <a:buNone/>
+            </a:pPr>
+            <a:r>
+              <a:rPr lang="fr-CA" sz="1400" b="1" dirty="0"/>
+              <a:t>C. Elle est pure et vraie (19.10)</a:t>
             </a:r>
           </a:p>
           <a:p>
@@ -3680,7 +3760,7 @@
             </a:pPr>
             <a:r>
               <a:rPr lang="fr-CA" sz="1400" dirty="0"/>
-              <a:t>« L'Écriture prend le naïf, l'inexpérimenté, l'homme sans discernement, le mal informé, et lui apporte la sagesse » (80-19). « Sage » (chakam) : « maîtriser l'art de vivre, vivre en parfait accord avec la connaissance de Dieu » (80-250).</a:t>
+              <a:t>La « crainte » ne désigne pas techniquement la Parole, mais l'Écriture comme « guide pour l'adoration de Dieu » (BEM, 19.10); « La Bible est un manuel du culte; elle vous dit comment adorer le Seigneur en esprit et en vérité » (80-308).</a:t>
             </a:r>
           </a:p>
           <a:p>
@@ -3693,7 +3773,7 @@
             </a:pPr>
             <a:r>
               <a:rPr lang="fr-CA" sz="1400" dirty="0"/>
-              <a:t>Les « ordonnances », moyens par lesquels Dieu gouverne (BEM, 19.9) : « La Parole n'est pas seulement une lampe à nos pieds qui éclaire le sentier, la Parole est le sentier » (80-250).</a:t>
+              <a:t>Nette, « sans tache, sans défaut » (80-308), elle « subsiste à toujours » : elle n'a jamais besoin de mise à jour (80-19).</a:t>
             </a:r>
           </a:p>
           <a:p>
@@ -3706,7 +3786,7 @@
             </a:pPr>
             <a:r>
               <a:rPr lang="fr-CA" sz="1400" dirty="0"/>
-              <a:t>Les « commandements » lient; MacArthur les lit « clairs » (S21 : « clairs »; NEG79 : « purs ») (80-308; TM19-6).</a:t>
+              <a:t>Les « jugements », verdicts de Dieu (BEM, 19.10) : « Elle est vraie. Je ne saurais trop insister. […] Dans un monde de mensonges, dans un monde de tromperie, elle est vraie; elle est absolument, sans équivoque, vraie » (80-308).</a:t>
             </a:r>
           </a:p>
           <a:p>
@@ -3718,7 +3798,7 @@
             </a:pPr>
             <a:r>
               <a:rPr lang="fr-CA" sz="1400" b="1" dirty="0"/>
-              <a:t>C. Elle est pure et vraie (19.10)</a:t>
+              <a:t>Synthèse</a:t>
             </a:r>
           </a:p>
           <a:p>
@@ -3731,58 +3811,7 @@
             </a:pPr>
             <a:r>
               <a:rPr lang="fr-CA" sz="1400" dirty="0"/>
-              <a:t>La « crainte » : l'Écriture comme « guide pour l'adoration de Dieu » (BEM, 19.10); « La Bible est un manuel du culte; elle vous dit comment adorer le Seigneur en esprit et en vérité » (80-308).</a:t>
-            </a:r>
-          </a:p>
-          <a:p>
-            <a:pPr marL="228600" indent="-228600">
-              <a:spcBef>
-                <a:spcPts val="300"/>
-              </a:spcBef>
-              <a:buFont typeface="Arial"/>
-              <a:buChar char="•"/>
-            </a:pPr>
-            <a:r>
-              <a:rPr lang="fr-CA" sz="1400" dirty="0"/>
-              <a:t>Nette, « sans tache, sans défaut » (80-308), elle « subsiste à toujours » : jamais besoin de mise à jour (80-19).</a:t>
-            </a:r>
-          </a:p>
-          <a:p>
-            <a:pPr marL="228600" indent="-228600">
-              <a:spcBef>
-                <a:spcPts val="300"/>
-              </a:spcBef>
-              <a:buFont typeface="Arial"/>
-              <a:buChar char="•"/>
-            </a:pPr>
-            <a:r>
-              <a:rPr lang="fr-CA" sz="1400" dirty="0"/>
-              <a:t>Les « jugements », verdicts de Dieu (BEM, 19.10) : « Il est vrai. Je ne saurais trop insister. Dans un monde de mensonges, dans un monde de tromperie, il est vrai; il est absolument, sans équivoque, vrai » (80-308).</a:t>
-            </a:r>
-          </a:p>
-          <a:p>
-            <a:pPr marL="0" indent="0">
-              <a:spcBef>
-                <a:spcPts val="600"/>
-              </a:spcBef>
-              <a:buNone/>
-            </a:pPr>
-            <a:r>
-              <a:rPr lang="fr-CA" sz="1400" b="1" dirty="0"/>
-              <a:t>Synthèse</a:t>
-            </a:r>
-          </a:p>
-          <a:p>
-            <a:pPr marL="228600" indent="-228600">
-              <a:spcBef>
-                <a:spcPts val="300"/>
-              </a:spcBef>
-              <a:buFont typeface="Arial"/>
-              <a:buChar char="•"/>
-            </a:pPr>
-            <a:r>
-              <a:rPr lang="fr-CA" sz="1400" dirty="0"/>
-              <a:t>La Parole « fournit tout ce qu'il faut » (80-250) : toute l'Écriture rend l'homme de Dieu accompli (2 Timothée 3.16-17). Retour au Rappel.</a:t>
+              <a:t>La Parole « fournit tout ce qu'il faut » (80-250) : toute l'Écriture rend l'homme de Dieu accompli et propre à toute bonne œuvre (2 Timothée 3.16-17). Retour au Rappel.</a:t>
             </a:r>
           </a:p>
           <a:p>
@@ -4528,7 +4557,7 @@
               <a:buNone/>
             </a:pPr>
             <a:r>
-              <a:rPr lang="fr-CA" altLang="en-US" sz="1800" i="1" dirty="0">
+              <a:rPr lang="fr-CA" altLang="en-US" sz="1700" i="1" dirty="0">
                 <a:solidFill>
                   <a:srgbClr val="C9BCAD"/>
                 </a:solidFill>
@@ -4536,7 +4565,25 @@
                 <a:ea typeface="Calibri" pitchFamily="34" charset="-122"/>
                 <a:cs typeface="Calibri" pitchFamily="34" charset="-120"/>
               </a:rPr>
-              <a:t>« La loi de l'Éternel est parfaite, elle restaure l'âme; le témoignage de l'Éternel est véritable, il rend sage l'ignorant. »</a:t>
+              <a:t>« La loi de l'Éternel est parfaite, elle restaure l'âme; </a:t>
+            </a:r>
+            <a:br/>
+            <a:pPr indent="0" marL="0">
+              <a:spcAft>
+                <a:spcPts val="400"/>
+              </a:spcAft>
+              <a:buNone/>
+            </a:pPr>
+            <a:r>
+              <a:rPr lang="fr-CA" altLang="en-US" sz="1700" i="1" dirty="0">
+                <a:solidFill>
+                  <a:srgbClr val="C9BCAD"/>
+                </a:solidFill>
+                <a:latin typeface="Calibri" pitchFamily="34" charset="0"/>
+                <a:ea typeface="Calibri" pitchFamily="34" charset="-122"/>
+                <a:cs typeface="Calibri" pitchFamily="34" charset="-120"/>
+              </a:rPr>
+              <a:t>le témoignage de l'Éternel est véritable, il rend sage l'ignorant. »</a:t>
             </a:r>
             <a:endParaRPr lang="fr-CA" sz="1800" dirty="0"/>
           </a:p>
@@ -4598,7 +4645,7 @@
                 <a:ea typeface="Calibri" pitchFamily="34" charset="-122"/>
                 <a:cs typeface="Calibri" pitchFamily="34" charset="-120"/>
               </a:rPr>
-              <a:t>André-Guy Bruneau</a:t>
+              <a:t>André‑Guy Bruneau</a:t>
             </a:r>
             <a:endParaRPr lang="fr-CA" sz="1600" dirty="0"/>
           </a:p>
@@ -5020,7 +5067,7 @@
                 <a:ea typeface="Cambria" pitchFamily="34" charset="-122"/>
                 <a:cs typeface="Cambria" pitchFamily="34" charset="-120"/>
               </a:rPr>
-              <a:t>Ce qui tient lieu de Parole</a:t>
+              <a:t>Ce qu'on ajoute à la Parole</a:t>
             </a:r>
             <a:endParaRPr lang="fr-CA" sz="3800" dirty="0"/>
           </a:p>
@@ -5059,7 +5106,7 @@
                 <a:ea typeface="Calibri" pitchFamily="34" charset="-122"/>
                 <a:cs typeface="Calibri" pitchFamily="34" charset="-120"/>
               </a:rPr>
-              <a:t>Vers quoi vous tournez-vous en premier quand votre âme est troublée?</a:t>
+              <a:t>Vers quoi vous tournez‑vous en premier quand votre âme est troublée?</a:t>
             </a:r>
             <a:endParaRPr lang="fr-CA" sz="1900" dirty="0"/>
           </a:p>
@@ -5644,7 +5691,7 @@
       </p:sp>
       <p:pic>
         <p:nvPicPr>
-          <p:cNvPr id="24" name="Image 4" descr="Icône : cerveau">    </p:cNvPr>
+          <p:cNvPr id="24" name="Image 4" descr="Icône : porte-voix">    </p:cNvPr>
           <p:cNvPicPr>
             <a:picLocks noChangeAspect="1"/>
           </p:cNvPicPr>
@@ -5699,7 +5746,7 @@
                 <a:ea typeface="Calibri" pitchFamily="34" charset="-122"/>
                 <a:cs typeface="Calibri" pitchFamily="34" charset="-120"/>
               </a:rPr>
-              <a:t>Psychologie</a:t>
+              <a:t>Confession positive</a:t>
             </a:r>
             <a:endParaRPr lang="fr-CA" sz="1800" dirty="0"/>
           </a:p>
@@ -5874,7 +5921,7 @@
       </p:sp>
       <p:pic>
         <p:nvPicPr>
-          <p:cNvPr id="32" name="Image 6" descr="Icône : porte-voix">    </p:cNvPr>
+          <p:cNvPr id="32" name="Image 6" descr="Icône : cerveau">    </p:cNvPr>
           <p:cNvPicPr>
             <a:picLocks noChangeAspect="1"/>
           </p:cNvPicPr>
@@ -5929,7 +5976,7 @@
                 <a:ea typeface="Calibri" pitchFamily="34" charset="-122"/>
                 <a:cs typeface="Calibri" pitchFamily="34" charset="-120"/>
               </a:rPr>
-              <a:t>Confession positive</a:t>
+              <a:t>Psychologie</a:t>
             </a:r>
             <a:endParaRPr lang="fr-CA" sz="1800" dirty="0"/>
           </a:p>
@@ -5968,7 +6015,7 @@
                 <a:ea typeface="Calibri" pitchFamily="34" charset="-122"/>
                 <a:cs typeface="Calibri" pitchFamily="34" charset="-120"/>
               </a:rPr>
-              <a:t>Ce qui, dans l'Église, prend la place de la Parole : MacArthur, 1985</a:t>
+              <a:t>Ce qui, dans l'Église, s'attaque à la suffisance de la Parole : MacArthur, 1985</a:t>
             </a:r>
             <a:endParaRPr lang="fr-CA" sz="1400" dirty="0"/>
           </a:p>
@@ -6068,7 +6115,7 @@
                 <a:ea typeface="Calibri" pitchFamily="34" charset="-122"/>
                 <a:cs typeface="Calibri" pitchFamily="34" charset="-120"/>
               </a:rPr>
-              <a:t>Sciences et médecine restent des bienfaits de Dieu; la suffisance vise le domaine de l'âme.</a:t>
+              <a:t>Sciences naturelles et médecine restent des bienfaits de Dieu; la suffisance vise le domaine de l'âme.</a:t>
             </a:r>
             <a:endParaRPr lang="fr-CA" sz="1700" dirty="0"/>
           </a:p>
@@ -6800,11 +6847,8 @@
                 <a:ea typeface="Calibri" pitchFamily="34" charset="-122"/>
                 <a:cs typeface="Calibri" pitchFamily="34" charset="-120"/>
               </a:rPr>
-              <a:t>Plus précieuse que l'or affiné (paz)</a:t>
-            </a:r>
-            <a:endParaRPr lang="fr-CA" sz="1500" dirty="0"/>
-          </a:p>
-          <a:p>
+              <a:t>Plus précieuse que l'or affiné (</a:t>
+            </a:r>
             <a:pPr indent="0" marL="0">
               <a:spcBef>
                 <a:spcPts val="200"/>
@@ -6812,6 +6856,43 @@
               <a:buNone/>
             </a:pPr>
             <a:r>
+              <a:rPr lang="fr-CA" altLang="en-US" sz="1800" b="1" i="1" dirty="0">
+                <a:solidFill>
+                  <a:srgbClr val="F4EDE4"/>
+                </a:solidFill>
+                <a:latin typeface="Calibri" pitchFamily="34" charset="0"/>
+                <a:ea typeface="Calibri" pitchFamily="34" charset="-122"/>
+                <a:cs typeface="Calibri" pitchFamily="34" charset="-120"/>
+              </a:rPr>
+              <a:t>paz</a:t>
+            </a:r>
+            <a:pPr indent="0" marL="0">
+              <a:spcBef>
+                <a:spcPts val="200"/>
+              </a:spcBef>
+              <a:buNone/>
+            </a:pPr>
+            <a:r>
+              <a:rPr lang="fr-CA" altLang="en-US" sz="1800" b="1" dirty="0">
+                <a:solidFill>
+                  <a:srgbClr val="F4EDE4"/>
+                </a:solidFill>
+                <a:latin typeface="Calibri" pitchFamily="34" charset="0"/>
+                <a:ea typeface="Calibri" pitchFamily="34" charset="-122"/>
+                <a:cs typeface="Calibri" pitchFamily="34" charset="-120"/>
+              </a:rPr>
+              <a:t>)</a:t>
+            </a:r>
+            <a:endParaRPr lang="fr-CA" sz="1500" dirty="0"/>
+          </a:p>
+          <a:p>
+            <a:pPr indent="0" marL="0">
+              <a:spcBef>
+                <a:spcPts val="200"/>
+              </a:spcBef>
+              <a:buNone/>
+            </a:pPr>
+            <a:r>
               <a:rPr lang="fr-CA" altLang="en-US" sz="1500" dirty="0">
                 <a:solidFill>
                   <a:srgbClr val="A89A8C"/>
@@ -6820,7 +6901,27 @@
                 <a:ea typeface="Calibri" pitchFamily="34" charset="-122"/>
                 <a:cs typeface="Calibri" pitchFamily="34" charset="-120"/>
               </a:rPr>
-              <a:t>Le bien suprême d'ici-bas : le plus grand bien qu'on puisse posséder.</a:t>
+              <a:t>Le bien suprême d'ici‑bas :</a:t>
+            </a:r>
+            <a:endParaRPr lang="fr-CA" sz="1500" dirty="0"/>
+          </a:p>
+          <a:p>
+            <a:pPr indent="0" marL="0">
+              <a:spcBef>
+                <a:spcPts val="200"/>
+              </a:spcBef>
+              <a:buNone/>
+            </a:pPr>
+            <a:r>
+              <a:rPr lang="fr-CA" altLang="en-US" sz="1500" dirty="0">
+                <a:solidFill>
+                  <a:srgbClr val="A89A8C"/>
+                </a:solidFill>
+                <a:latin typeface="Calibri" pitchFamily="34" charset="0"/>
+                <a:ea typeface="Calibri" pitchFamily="34" charset="-122"/>
+                <a:cs typeface="Calibri" pitchFamily="34" charset="-120"/>
+              </a:rPr>
+              <a:t>le plus grand bien qu'on puisse posséder.</a:t>
             </a:r>
             <a:endParaRPr lang="fr-CA" sz="1500" dirty="0"/>
           </a:p>
@@ -6931,7 +7032,27 @@
                 <a:ea typeface="Calibri" pitchFamily="34" charset="-122"/>
                 <a:cs typeface="Calibri" pitchFamily="34" charset="-120"/>
               </a:rPr>
-              <a:t>Le délice des délices : le plus grand plaisir qu'on puisse goûter.</a:t>
+              <a:t>Le délice des délices :</a:t>
+            </a:r>
+            <a:endParaRPr lang="fr-CA" sz="1500" dirty="0"/>
+          </a:p>
+          <a:p>
+            <a:pPr indent="0" marL="0">
+              <a:spcBef>
+                <a:spcPts val="200"/>
+              </a:spcBef>
+              <a:buNone/>
+            </a:pPr>
+            <a:r>
+              <a:rPr lang="fr-CA" altLang="en-US" sz="1500" dirty="0">
+                <a:solidFill>
+                  <a:srgbClr val="A89A8C"/>
+                </a:solidFill>
+                <a:latin typeface="Calibri" pitchFamily="34" charset="0"/>
+                <a:ea typeface="Calibri" pitchFamily="34" charset="-122"/>
+                <a:cs typeface="Calibri" pitchFamily="34" charset="-120"/>
+              </a:rPr>
+              <a:t>le plus grand plaisir qu'on puisse goûter.</a:t>
             </a:r>
             <a:endParaRPr lang="fr-CA" sz="1500" dirty="0"/>
           </a:p>
@@ -7022,7 +7143,7 @@
                 <a:ea typeface="Calibri" pitchFamily="34" charset="-122"/>
                 <a:cs typeface="Calibri" pitchFamily="34" charset="-120"/>
               </a:rPr>
-              <a:t>Elle avertit (19.12)</a:t>
+              <a:t>Elle avertit</a:t>
             </a:r>
             <a:endParaRPr lang="fr-CA" sz="1500" dirty="0"/>
           </a:p>
@@ -7153,7 +7274,27 @@
                 <a:ea typeface="Calibri" pitchFamily="34" charset="-122"/>
                 <a:cs typeface="Calibri" pitchFamily="34" charset="-120"/>
               </a:rPr>
-              <a:t>« En les gardant, il y a la fin » : non ici et maintenant, mais la gloire à venir.</a:t>
+              <a:t>« En les gardant, il y a la fin » :</a:t>
+            </a:r>
+            <a:endParaRPr lang="fr-CA" sz="1500" dirty="0"/>
+          </a:p>
+          <a:p>
+            <a:pPr indent="0" marL="0">
+              <a:spcBef>
+                <a:spcPts val="200"/>
+              </a:spcBef>
+              <a:buNone/>
+            </a:pPr>
+            <a:r>
+              <a:rPr lang="fr-CA" altLang="en-US" sz="1500" dirty="0">
+                <a:solidFill>
+                  <a:srgbClr val="A89A8C"/>
+                </a:solidFill>
+                <a:latin typeface="Calibri" pitchFamily="34" charset="0"/>
+                <a:ea typeface="Calibri" pitchFamily="34" charset="-122"/>
+                <a:cs typeface="Calibri" pitchFamily="34" charset="-120"/>
+              </a:rPr>
+              <a:t>non ici et maintenant, mais la bénédiction éternelle.</a:t>
             </a:r>
             <a:endParaRPr lang="fr-CA" sz="1500" dirty="0"/>
           </a:p>
@@ -7653,7 +7794,7 @@
                 <a:ea typeface="Calibri" pitchFamily="34" charset="-122"/>
                 <a:cs typeface="Calibri" pitchFamily="34" charset="-120"/>
               </a:rPr>
-              <a:t>« Qui connaît ses égarements? » Réponse : personne, sans la Parole (Street)</a:t>
+              <a:t>La Parole qui me montre mon péché me conduit à mon Rédempteur</a:t>
             </a:r>
             <a:endParaRPr lang="fr-CA" sz="1900" dirty="0"/>
           </a:p>
@@ -7824,7 +7965,7 @@
         <p:spPr>
           <a:xfrm>
             <a:off x="548640" y="1874520"/>
-            <a:ext cx="3502152" cy="2834640"/>
+            <a:ext cx="3520440" cy="2834640"/>
           </a:xfrm>
           <a:prstGeom prst="roundRect">
             <a:avLst>
@@ -8038,7 +8179,7 @@
               <a:buNone/>
             </a:pPr>
             <a:r>
-              <a:rPr lang="fr-CA" altLang="en-US" sz="1300" dirty="0">
+              <a:rPr lang="fr-CA" altLang="en-US" sz="1500" dirty="0">
                 <a:solidFill>
                   <a:srgbClr val="F4EDE4"/>
                 </a:solidFill>
@@ -8048,7 +8189,7 @@
               </a:rPr>
               <a:t>Lévitique 4 : un sacrifice prévu</a:t>
             </a:r>
-            <a:endParaRPr lang="fr-CA" sz="1300" dirty="0"/>
+            <a:endParaRPr lang="fr-CA" sz="1500" dirty="0"/>
           </a:p>
         </p:txBody>
       </p:sp>
@@ -8085,7 +8226,7 @@
                 <a:ea typeface="Calibri" pitchFamily="34" charset="-122"/>
                 <a:cs typeface="Calibri" pitchFamily="34" charset="-120"/>
               </a:rPr>
-              <a:t>« Pardonne-moi » : acquitte-moi</a:t>
+              <a:t>« Pardonne‑moi » : acquitte‑moi</a:t>
             </a:r>
             <a:endParaRPr lang="fr-CA" sz="1500" dirty="0"/>
           </a:p>
@@ -8099,8 +8240,8 @@
         </p:nvSpPr>
         <p:spPr>
           <a:xfrm>
-            <a:off x="4078224" y="3246120"/>
-            <a:ext cx="219456" cy="228600"/>
+            <a:off x="4096512" y="3246120"/>
+            <a:ext cx="219456" cy="182880"/>
           </a:xfrm>
           <a:prstGeom prst="line">
             <a:avLst/>
@@ -8123,8 +8264,8 @@
         </p:nvSpPr>
         <p:spPr>
           <a:xfrm>
-            <a:off x="4320540" y="2103120"/>
-            <a:ext cx="3502152" cy="2834640"/>
+            <a:off x="4334256" y="2057400"/>
+            <a:ext cx="3520440" cy="2834640"/>
           </a:xfrm>
           <a:prstGeom prst="roundRect">
             <a:avLst>
@@ -8150,7 +8291,7 @@
         </p:nvSpPr>
         <p:spPr>
           <a:xfrm>
-            <a:off x="4576572" y="2304288"/>
+            <a:off x="4590288" y="2258568"/>
             <a:ext cx="603504" cy="603504"/>
           </a:xfrm>
           <a:prstGeom prst="ellipse">
@@ -8183,7 +8324,7 @@
         </p:blipFill>
         <p:spPr>
           <a:xfrm>
-            <a:off x="4697273" y="2424989"/>
+            <a:off x="4710989" y="2379269"/>
             <a:ext cx="362102" cy="362102"/>
           </a:xfrm>
           <a:prstGeom prst="rect">
@@ -8199,7 +8340,7 @@
         </p:nvSpPr>
         <p:spPr>
           <a:xfrm>
-            <a:off x="7155180" y="2286000"/>
+            <a:off x="7168896" y="2240280"/>
             <a:ext cx="457200" cy="457200"/>
           </a:xfrm>
           <a:prstGeom prst="rect">
@@ -8238,7 +8379,7 @@
         </p:nvSpPr>
         <p:spPr>
           <a:xfrm>
-            <a:off x="4576572" y="3017520"/>
+            <a:off x="4590288" y="2971800"/>
             <a:ext cx="3017520" cy="1097280"/>
           </a:xfrm>
           <a:prstGeom prst="rect">
@@ -8294,7 +8435,7 @@
         </p:nvSpPr>
         <p:spPr>
           <a:xfrm>
-            <a:off x="4576572" y="4114800"/>
+            <a:off x="4590288" y="4069080"/>
             <a:ext cx="2990088" cy="384048"/>
           </a:xfrm>
           <a:prstGeom prst="roundRect">
@@ -8321,7 +8462,7 @@
         </p:nvSpPr>
         <p:spPr>
           <a:xfrm>
-            <a:off x="4576572" y="4114800"/>
+            <a:off x="4590288" y="4069080"/>
             <a:ext cx="2990088" cy="384048"/>
           </a:xfrm>
           <a:prstGeom prst="rect">
@@ -8338,7 +8479,7 @@
               <a:buNone/>
             </a:pPr>
             <a:r>
-              <a:rPr lang="fr-CA" altLang="en-US" sz="1300" dirty="0">
+              <a:rPr lang="fr-CA" altLang="en-US" sz="1500" dirty="0">
                 <a:solidFill>
                   <a:srgbClr val="F4EDE4"/>
                 </a:solidFill>
@@ -8348,7 +8489,7 @@
               </a:rPr>
               <a:t>Nombres 15.30‑31 : aucun sacrifice</a:t>
             </a:r>
-            <a:endParaRPr lang="fr-CA" sz="1300" dirty="0"/>
+            <a:endParaRPr lang="fr-CA" sz="1500" dirty="0"/>
           </a:p>
         </p:txBody>
       </p:sp>
@@ -8360,7 +8501,7 @@
         </p:nvSpPr>
         <p:spPr>
           <a:xfrm>
-            <a:off x="4576572" y="4553712"/>
+            <a:off x="4590288" y="4507992"/>
             <a:ext cx="3017520" cy="347472"/>
           </a:xfrm>
           <a:prstGeom prst="rect">
@@ -8399,8 +8540,8 @@
         </p:nvSpPr>
         <p:spPr>
           <a:xfrm>
-            <a:off x="7850124" y="3474720"/>
-            <a:ext cx="219456" cy="228600"/>
+            <a:off x="7882128" y="3429000"/>
+            <a:ext cx="219456" cy="182880"/>
           </a:xfrm>
           <a:prstGeom prst="line">
             <a:avLst/>
@@ -8423,8 +8564,8 @@
         </p:nvSpPr>
         <p:spPr>
           <a:xfrm>
-            <a:off x="8092440" y="2331720"/>
-            <a:ext cx="3502152" cy="2834640"/>
+            <a:off x="8119872" y="2240280"/>
+            <a:ext cx="3520440" cy="2834640"/>
           </a:xfrm>
           <a:prstGeom prst="roundRect">
             <a:avLst>
@@ -8450,7 +8591,7 @@
         </p:nvSpPr>
         <p:spPr>
           <a:xfrm>
-            <a:off x="8348472" y="2532888"/>
+            <a:off x="8375904" y="2441448"/>
             <a:ext cx="603504" cy="603504"/>
           </a:xfrm>
           <a:prstGeom prst="ellipse">
@@ -8483,7 +8624,7 @@
         </p:blipFill>
         <p:spPr>
           <a:xfrm>
-            <a:off x="8469173" y="2653589"/>
+            <a:off x="8496605" y="2562149"/>
             <a:ext cx="362102" cy="362102"/>
           </a:xfrm>
           <a:prstGeom prst="rect">
@@ -8499,7 +8640,7 @@
         </p:nvSpPr>
         <p:spPr>
           <a:xfrm>
-            <a:off x="10927080" y="2514600"/>
+            <a:off x="10954512" y="2423160"/>
             <a:ext cx="457200" cy="457200"/>
           </a:xfrm>
           <a:prstGeom prst="rect">
@@ -8538,7 +8679,7 @@
         </p:nvSpPr>
         <p:spPr>
           <a:xfrm>
-            <a:off x="8348472" y="3246120"/>
+            <a:off x="8375904" y="3154680"/>
             <a:ext cx="3017520" cy="1097280"/>
           </a:xfrm>
           <a:prstGeom prst="rect">
@@ -8580,7 +8721,24 @@
                 <a:ea typeface="Calibri" pitchFamily="34" charset="-122"/>
                 <a:cs typeface="Calibri" pitchFamily="34" charset="-120"/>
               </a:rPr>
-              <a:t>La rébellion ouverte : se détourner du Seigneur.</a:t>
+              <a:t>La rébellion ouverte :</a:t>
+            </a:r>
+            <a:endParaRPr lang="fr-CA" sz="1500" dirty="0"/>
+          </a:p>
+          <a:p>
+            <a:pPr indent="0" marL="0">
+              <a:buNone/>
+            </a:pPr>
+            <a:r>
+              <a:rPr lang="fr-CA" altLang="en-US" sz="1500" dirty="0">
+                <a:solidFill>
+                  <a:srgbClr val="A89A8C"/>
+                </a:solidFill>
+                <a:latin typeface="Calibri" pitchFamily="34" charset="0"/>
+                <a:ea typeface="Calibri" pitchFamily="34" charset="-122"/>
+                <a:cs typeface="Calibri" pitchFamily="34" charset="-120"/>
+              </a:rPr>
+              <a:t>se détourner du Seigneur.</a:t>
             </a:r>
             <a:endParaRPr lang="fr-CA" sz="1500" dirty="0"/>
           </a:p>
@@ -8594,7 +8752,7 @@
         </p:nvSpPr>
         <p:spPr>
           <a:xfrm>
-            <a:off x="8348472" y="4343400"/>
+            <a:off x="8375904" y="4251960"/>
             <a:ext cx="2990088" cy="384048"/>
           </a:xfrm>
           <a:prstGeom prst="roundRect">
@@ -8621,7 +8779,7 @@
         </p:nvSpPr>
         <p:spPr>
           <a:xfrm>
-            <a:off x="8348472" y="4343400"/>
+            <a:off x="8375904" y="4251960"/>
             <a:ext cx="2990088" cy="384048"/>
           </a:xfrm>
           <a:prstGeom prst="rect">
@@ -8638,7 +8796,7 @@
               <a:buNone/>
             </a:pPr>
             <a:r>
-              <a:rPr lang="fr-CA" altLang="en-US" sz="1300" dirty="0">
+              <a:rPr lang="fr-CA" altLang="en-US" sz="1500" dirty="0">
                 <a:solidFill>
                   <a:srgbClr val="F4EDE4"/>
                 </a:solidFill>
@@ -8648,7 +8806,7 @@
               </a:rPr>
               <a:t>Le terme de la pente</a:t>
             </a:r>
-            <a:endParaRPr lang="fr-CA" sz="1300" dirty="0"/>
+            <a:endParaRPr lang="fr-CA" sz="1500" dirty="0"/>
           </a:p>
         </p:txBody>
       </p:sp>
@@ -8660,7 +8818,7 @@
         </p:nvSpPr>
         <p:spPr>
           <a:xfrm>
-            <a:off x="8348472" y="4782312"/>
+            <a:off x="8375904" y="4690872"/>
             <a:ext cx="3017520" cy="347472"/>
           </a:xfrm>
           <a:prstGeom prst="rect">
@@ -9693,7 +9851,41 @@
                 <a:ea typeface="Calibri" pitchFamily="34" charset="-122"/>
                 <a:cs typeface="Calibri" pitchFamily="34" charset="-120"/>
               </a:rPr>
-              <a:t>Reçois favorablement (leratson)</a:t>
+              <a:t>Reçois favorablement (</a:t>
+            </a:r>
+            <a:pPr indent="0" marL="0">
+              <a:spcBef>
+                <a:spcPts val="200"/>
+              </a:spcBef>
+              <a:buNone/>
+            </a:pPr>
+            <a:r>
+              <a:rPr lang="fr-CA" altLang="en-US" sz="1800" b="1" i="1" dirty="0">
+                <a:solidFill>
+                  <a:srgbClr val="F4EDE4"/>
+                </a:solidFill>
+                <a:latin typeface="Calibri" pitchFamily="34" charset="0"/>
+                <a:ea typeface="Calibri" pitchFamily="34" charset="-122"/>
+                <a:cs typeface="Calibri" pitchFamily="34" charset="-120"/>
+              </a:rPr>
+              <a:t>leratson</a:t>
+            </a:r>
+            <a:pPr indent="0" marL="0">
+              <a:spcBef>
+                <a:spcPts val="200"/>
+              </a:spcBef>
+              <a:buNone/>
+            </a:pPr>
+            <a:r>
+              <a:rPr lang="fr-CA" altLang="en-US" sz="1800" b="1" dirty="0">
+                <a:solidFill>
+                  <a:srgbClr val="F4EDE4"/>
+                </a:solidFill>
+                <a:latin typeface="Calibri" pitchFamily="34" charset="0"/>
+                <a:ea typeface="Calibri" pitchFamily="34" charset="-122"/>
+                <a:cs typeface="Calibri" pitchFamily="34" charset="-120"/>
+              </a:rPr>
+              <a:t>)</a:t>
             </a:r>
             <a:endParaRPr lang="fr-CA" sz="1500" dirty="0"/>
           </a:p>
@@ -9935,7 +10127,41 @@
                 <a:ea typeface="Calibri" pitchFamily="34" charset="-122"/>
                 <a:cs typeface="Calibri" pitchFamily="34" charset="-120"/>
               </a:rPr>
-              <a:t>Le goel : le parent proche qui paie pour racheter (Lévitique 25.25).</a:t>
+              <a:t>Le </a:t>
+            </a:r>
+            <a:pPr indent="0" marL="0">
+              <a:spcBef>
+                <a:spcPts val="200"/>
+              </a:spcBef>
+              <a:buNone/>
+            </a:pPr>
+            <a:r>
+              <a:rPr lang="fr-CA" altLang="en-US" sz="1500" i="1" dirty="0">
+                <a:solidFill>
+                  <a:srgbClr val="A89A8C"/>
+                </a:solidFill>
+                <a:latin typeface="Calibri" pitchFamily="34" charset="0"/>
+                <a:ea typeface="Calibri" pitchFamily="34" charset="-122"/>
+                <a:cs typeface="Calibri" pitchFamily="34" charset="-120"/>
+              </a:rPr>
+              <a:t>goel</a:t>
+            </a:r>
+            <a:pPr indent="0" marL="0">
+              <a:spcBef>
+                <a:spcPts val="200"/>
+              </a:spcBef>
+              <a:buNone/>
+            </a:pPr>
+            <a:r>
+              <a:rPr lang="fr-CA" altLang="en-US" sz="1500" dirty="0">
+                <a:solidFill>
+                  <a:srgbClr val="A89A8C"/>
+                </a:solidFill>
+                <a:latin typeface="Calibri" pitchFamily="34" charset="0"/>
+                <a:ea typeface="Calibri" pitchFamily="34" charset="-122"/>
+                <a:cs typeface="Calibri" pitchFamily="34" charset="-120"/>
+              </a:rPr>
+              <a:t> : le parent proche qui paie pour racheter (Lévitique 25.25).</a:t>
             </a:r>
             <a:endParaRPr lang="fr-CA" sz="1500" dirty="0"/>
           </a:p>
@@ -10026,7 +10252,7 @@
                 <a:ea typeface="Calibri" pitchFamily="34" charset="-122"/>
                 <a:cs typeface="Calibri" pitchFamily="34" charset="-120"/>
               </a:rPr>
-              <a:t>Le Rédempteur a un nom</a:t>
+              <a:t>Il conduit à Christ</a:t>
             </a:r>
             <a:endParaRPr lang="fr-CA" sz="1500" dirty="0"/>
           </a:p>
@@ -11114,7 +11340,7 @@
                 <a:ea typeface="Calibri" pitchFamily="34" charset="-122"/>
                 <a:cs typeface="Calibri" pitchFamily="34" charset="-120"/>
               </a:rPr>
-              <a:t>Dieu nous a parlé en son Fils (Hébreux 1.1‑2).</a:t>
+              <a:t>Dieu nous a parlé par le Fils (Hébreux 1.1‑2).</a:t>
             </a:r>
             <a:endParaRPr lang="fr-CA" sz="1500" dirty="0"/>
           </a:p>
@@ -11134,7 +11360,7 @@
                 <a:ea typeface="Calibri" pitchFamily="34" charset="-122"/>
                 <a:cs typeface="Calibri" pitchFamily="34" charset="-120"/>
               </a:rPr>
-              <a:t>« Personne ne peut être sauvé, régénéré, né de nouveau sans comprendre la Parole de Dieu, en particulier la Parole de Dieu concernant la personne de Jésus-Christ » (MacArthur).</a:t>
+              <a:t>« Personne ne peut être sauvé, régénéré, né de nouveau sans comprendre la Parole de Dieu, en particulier la Parole de Dieu concernant la personne de Jésus‑Christ » (MacArthur).</a:t>
             </a:r>
             <a:endParaRPr lang="fr-CA" sz="1500" dirty="0"/>
           </a:p>
@@ -11239,7 +11465,7 @@
                 <a:ea typeface="Calibri" pitchFamily="34" charset="-122"/>
                 <a:cs typeface="Calibri" pitchFamily="34" charset="-120"/>
               </a:rPr>
-              <a:t>Les cieux vous ont parlé toute votre vie : vous êtes sans excuse. Aujourd'hui, la Parole vous parle du Rédempteur.</a:t>
+              <a:t>Les cieux vous ont parlé toute votre vie : vous êtes sans excuse. Christ est mort pour nos péchés et il est ressuscité (1 Corinthiens 15.3‑4).</a:t>
             </a:r>
             <a:endParaRPr lang="fr-CA" sz="1500" dirty="0"/>
           </a:p>
@@ -11251,7 +11477,7 @@
               <a:buNone/>
             </a:pPr>
             <a:r>
-              <a:rPr lang="fr-CA" altLang="en-US" sz="1500" b="1" dirty="0">
+              <a:rPr lang="fr-CA" altLang="en-US" sz="1700" b="1" dirty="0">
                 <a:solidFill>
                   <a:srgbClr val="F4EDE4"/>
                 </a:solidFill>
@@ -11259,7 +11485,7 @@
                 <a:ea typeface="Calibri" pitchFamily="34" charset="-122"/>
                 <a:cs typeface="Calibri" pitchFamily="34" charset="-120"/>
               </a:rPr>
-              <a:t>Repentez-vous, croyez en Christ et soumettez-vous à lui comme Seigneur.</a:t>
+              <a:t>Repentez‑vous, croyez en Christ et soumettez‑vous à lui comme Seigneur.</a:t>
             </a:r>
             <a:endParaRPr lang="fr-CA" sz="1500" dirty="0"/>
           </a:p>
@@ -11364,7 +11590,7 @@
                 <a:ea typeface="Calibri" pitchFamily="34" charset="-122"/>
                 <a:cs typeface="Calibri" pitchFamily="34" charset="-120"/>
               </a:rPr>
-              <a:t>Ne cherchez pas ailleurs ce que la Parole vous donne. Désirez-la, laissez-la vous sonder, offrez-vous à Dieu.</a:t>
+              <a:t>Ne cherchez pas ailleurs ce que la Parole vous donne. Désirez‑la, laissez‑la vous sonder, offrez‑vous à Dieu.</a:t>
             </a:r>
             <a:endParaRPr lang="fr-CA" sz="1500" dirty="0"/>
           </a:p>
@@ -11384,7 +11610,7 @@
                 <a:ea typeface="Calibri" pitchFamily="34" charset="-122"/>
                 <a:cs typeface="Calibri" pitchFamily="34" charset="-120"/>
               </a:rPr>
-              <a:t>« Dans votre cœur, en ce moment, pouvez-vous prendre devant le Seigneur un engagement renouvelé à vous vouer à sa Parole? » (MacArthur)</a:t>
+              <a:t>« Dans votre cœur, en ce moment, pouvez‑vous prendre devant le Seigneur un engagement renouvelé à vous vouer à sa Parole? » (MacArthur)</a:t>
             </a:r>
             <a:endParaRPr lang="fr-CA" sz="1500" dirty="0"/>
           </a:p>
@@ -11915,7 +12141,7 @@
                 <a:ea typeface="Cambria" pitchFamily="34" charset="-122"/>
                 <a:cs typeface="Cambria" pitchFamily="34" charset="-120"/>
               </a:rPr>
-              <a:t>Et les sentiments de mon cœur,</a:t>
+              <a:t>et les sentiments de mon cœur,</a:t>
             </a:r>
             <a:endParaRPr lang="fr-CA" sz="3200" dirty="0"/>
           </a:p>
@@ -12000,7 +12226,7 @@
         </p:blipFill>
         <p:spPr>
           <a:xfrm>
-            <a:off x="8138160" y="2011680"/>
+            <a:off x="8065008" y="2011680"/>
             <a:ext cx="3520440" cy="3520440"/>
           </a:xfrm>
           <a:prstGeom prst="rect">
@@ -12016,8 +12242,8 @@
         </p:nvSpPr>
         <p:spPr>
           <a:xfrm>
-            <a:off x="7818120" y="5596128"/>
-            <a:ext cx="4114800" cy="731520"/>
+            <a:off x="8001000" y="5596128"/>
+            <a:ext cx="3639312" cy="731520"/>
           </a:xfrm>
           <a:prstGeom prst="rect">
             <a:avLst/>
@@ -12041,7 +12267,24 @@
                 <a:ea typeface="Calibri" pitchFamily="34" charset="-122"/>
                 <a:cs typeface="Calibri" pitchFamily="34" charset="-120"/>
               </a:rPr>
-              <a:t>De la lumière des étoiles à l'autel du cœur, la Parole de l'Éternel suffit.</a:t>
+              <a:t>De la lumière des étoiles à l'autel du cœur,</a:t>
+            </a:r>
+            <a:endParaRPr lang="fr-CA" sz="1500" dirty="0"/>
+          </a:p>
+          <a:p>
+            <a:pPr algn="ctr" indent="0" marL="0">
+              <a:buNone/>
+            </a:pPr>
+            <a:r>
+              <a:rPr lang="fr-CA" altLang="en-US" sz="1500" i="1" dirty="0">
+                <a:solidFill>
+                  <a:srgbClr val="A89A8C"/>
+                </a:solidFill>
+                <a:latin typeface="Calibri" pitchFamily="34" charset="0"/>
+                <a:ea typeface="Calibri" pitchFamily="34" charset="-122"/>
+                <a:cs typeface="Calibri" pitchFamily="34" charset="-120"/>
+              </a:rPr>
+              <a:t>la Parole de l'Éternel suffit.</a:t>
             </a:r>
             <a:endParaRPr lang="fr-CA" sz="1500" dirty="0"/>
           </a:p>
@@ -12692,6 +12935,20 @@
               <a:buNone/>
             </a:pPr>
             <a:r>
+              <a:rPr lang="fr-CA" altLang="en-US" sz="1600" i="1" dirty="0">
+                <a:solidFill>
+                  <a:srgbClr val="A89A8C"/>
+                </a:solidFill>
+                <a:latin typeface="Calibri" pitchFamily="34" charset="0"/>
+                <a:ea typeface="Calibri" pitchFamily="34" charset="-122"/>
+                <a:cs typeface="Calibri" pitchFamily="34" charset="-120"/>
+              </a:rPr>
+              <a:t>El</a:t>
+            </a:r>
+            <a:pPr algn="ctr" indent="0" marL="0">
+              <a:buNone/>
+            </a:pPr>
+            <a:r>
               <a:rPr lang="fr-CA" altLang="en-US" sz="1600" dirty="0">
                 <a:solidFill>
                   <a:srgbClr val="A89A8C"/>
@@ -12700,7 +12957,7 @@
                 <a:ea typeface="Calibri" pitchFamily="34" charset="-122"/>
                 <a:cs typeface="Calibri" pitchFamily="34" charset="-120"/>
               </a:rPr>
-              <a:t>El : la puissance du Créateur</a:t>
+              <a:t> : la puissance du Créateur</a:t>
             </a:r>
             <a:endParaRPr lang="fr-CA" sz="1600" dirty="0"/>
           </a:p>
@@ -13081,7 +13338,7 @@
       </p:sp>
       <p:pic>
         <p:nvPicPr>
-          <p:cNvPr id="20" name="Mouvement 3" descr="Médaillon : un cœur au-dessus de la flamme de l'autel">    </p:cNvPr>
+          <p:cNvPr id="20" name="Mouvement 3" descr="Médaillon : un cœur au-dessus d'une flamme, dans le ciel étoilé">    </p:cNvPr>
           <p:cNvPicPr>
             <a:picLocks noChangeAspect="1"/>
           </p:cNvPicPr>
@@ -13231,7 +13488,7 @@
                 <a:ea typeface="Calibri" pitchFamily="34" charset="-122"/>
                 <a:cs typeface="Calibri" pitchFamily="34" charset="-120"/>
               </a:rPr>
-              <a:t>L'application</a:t>
+              <a:t>Application de la Parole</a:t>
             </a:r>
             <a:endParaRPr lang="fr-CA" sz="1600" dirty="0"/>
           </a:p>
@@ -13248,7 +13505,7 @@
                 <a:ea typeface="Calibri" pitchFamily="34" charset="-122"/>
                 <a:cs typeface="Calibri" pitchFamily="34" charset="-120"/>
               </a:rPr>
-              <a:t>sondé, gardé, offert au Rédempteur</a:t>
+              <a:t>sondé, gardé, présenté au Rédempteur</a:t>
             </a:r>
             <a:endParaRPr lang="fr-CA" sz="1600" dirty="0"/>
           </a:p>
@@ -13775,7 +14032,7 @@
                 <a:ea typeface="Calibri" pitchFamily="34" charset="-122"/>
                 <a:cs typeface="Calibri" pitchFamily="34" charset="-120"/>
               </a:rPr>
-              <a:t>Babylone la fait se réclamer du dieu-soleil; le Psaume 19 la remet entre les mains de l'Éternel</a:t>
+              <a:t>Babylone la fait se réclamer du dieu‑soleil; le Psaume 19 la remet entre les mains de l'Éternel</a:t>
             </a:r>
             <a:endParaRPr lang="fr-CA" sz="1900" dirty="0"/>
           </a:p>
@@ -13855,7 +14112,7 @@
                 <a:ea typeface="Calibri" pitchFamily="34" charset="-122"/>
                 <a:cs typeface="Calibri" pitchFamily="34" charset="-120"/>
               </a:rPr>
-              <a:t>le roi devant Shamash, le dieu-soleil</a:t>
+              <a:t>le roi devant Shamash, le dieu‑soleil</a:t>
             </a:r>
             <a:endParaRPr lang="fr-CA" sz="1500" dirty="0"/>
           </a:p>
@@ -13986,7 +14243,7 @@
                 <a:ea typeface="Calibri" pitchFamily="34" charset="-122"/>
                 <a:cs typeface="Calibri" pitchFamily="34" charset="-120"/>
               </a:rPr>
-              <a:t>Shamash, dieu-soleil et dieu de la justice : la loi du roi se réclame de lui.</a:t>
+              <a:t>Shamash, dieu‑soleil et dieu de la justice : la loi du roi se réclame de lui.</a:t>
             </a:r>
             <a:endParaRPr lang="fr-CA" sz="1500" dirty="0"/>
           </a:p>
@@ -14216,7 +14473,7 @@
                 <a:ea typeface="Calibri" pitchFamily="34" charset="-122"/>
                 <a:cs typeface="Calibri" pitchFamily="34" charset="-120"/>
               </a:rPr>
-              <a:t>Où allez-vous chercher la vérité qui gouverne votre vie?</a:t>
+              <a:t>Où allez‑vous chercher la vérité qui gouverne votre vie?</a:t>
             </a:r>
             <a:endParaRPr lang="fr-CA" sz="2100" dirty="0"/>
           </a:p>
@@ -14799,7 +15056,35 @@
                 <a:ea typeface="Calibri" pitchFamily="34" charset="-122"/>
                 <a:cs typeface="Calibri" pitchFamily="34" charset="-120"/>
               </a:rPr>
-              <a:t>le monde · El, Dieu de puissance</a:t>
+              <a:t>le monde · </a:t>
+            </a:r>
+            <a:pPr indent="0" marL="0">
+              <a:buNone/>
+            </a:pPr>
+            <a:r>
+              <a:rPr lang="fr-CA" altLang="en-US" sz="1500" i="1" dirty="0">
+                <a:solidFill>
+                  <a:srgbClr val="A89A8C"/>
+                </a:solidFill>
+                <a:latin typeface="Calibri" pitchFamily="34" charset="0"/>
+                <a:ea typeface="Calibri" pitchFamily="34" charset="-122"/>
+                <a:cs typeface="Calibri" pitchFamily="34" charset="-120"/>
+              </a:rPr>
+              <a:t>El</a:t>
+            </a:r>
+            <a:pPr indent="0" marL="0">
+              <a:buNone/>
+            </a:pPr>
+            <a:r>
+              <a:rPr lang="fr-CA" altLang="en-US" sz="1500" dirty="0">
+                <a:solidFill>
+                  <a:srgbClr val="A89A8C"/>
+                </a:solidFill>
+                <a:latin typeface="Calibri" pitchFamily="34" charset="0"/>
+                <a:ea typeface="Calibri" pitchFamily="34" charset="-122"/>
+                <a:cs typeface="Calibri" pitchFamily="34" charset="-120"/>
+              </a:rPr>
+              <a:t>, Dieu de puissance</a:t>
             </a:r>
             <a:endParaRPr lang="fr-CA" sz="1500" dirty="0"/>
           </a:p>
@@ -14850,6 +15135,20 @@
               <a:buNone/>
             </a:pPr>
             <a:r>
+              <a:rPr lang="fr-CA" altLang="en-US" sz="1500" b="1" i="1" dirty="0">
+                <a:solidFill>
+                  <a:srgbClr val="A89A8C"/>
+                </a:solidFill>
+                <a:latin typeface="Calibri" pitchFamily="34" charset="0"/>
+                <a:ea typeface="Calibri" pitchFamily="34" charset="-122"/>
+                <a:cs typeface="Calibri" pitchFamily="34" charset="-120"/>
+              </a:rPr>
+              <a:t>El</a:t>
+            </a:r>
+            <a:pPr algn="r" indent="0" marL="0">
+              <a:buNone/>
+            </a:pPr>
+            <a:r>
               <a:rPr lang="fr-CA" altLang="en-US" sz="1500" b="1" dirty="0">
                 <a:solidFill>
                   <a:srgbClr val="A89A8C"/>
@@ -14858,7 +15157,7 @@
                 <a:ea typeface="Calibri" pitchFamily="34" charset="-122"/>
                 <a:cs typeface="Calibri" pitchFamily="34" charset="-120"/>
               </a:rPr>
-              <a:t>El × 1</a:t>
+              <a:t> × 1</a:t>
             </a:r>
             <a:endParaRPr lang="fr-CA" sz="1500" dirty="0"/>
           </a:p>
@@ -15288,8 +15587,8 @@
         </p:nvSpPr>
         <p:spPr>
           <a:xfrm>
-            <a:off x="777240" y="4617720"/>
-            <a:ext cx="3794760" cy="1234440"/>
+            <a:off x="777240" y="4553712"/>
+            <a:ext cx="3794760" cy="603504"/>
           </a:xfrm>
           <a:prstGeom prst="rect">
             <a:avLst/>
@@ -15298,6 +15597,45 @@
           <a:ln/>
         </p:spPr>
         <p:txBody>
+          <a:bodyPr wrap="square" lIns="0" tIns="0" rIns="0" bIns="0" rtlCol="0" anchor="b"/>
+          <a:lstStyle/>
+          <a:p>
+            <a:pPr indent="0" marL="0">
+              <a:buNone/>
+            </a:pPr>
+            <a:r>
+              <a:rPr lang="fr-CA" altLang="en-US" sz="1800" b="1" dirty="0">
+                <a:solidFill>
+                  <a:srgbClr val="F4EDE4"/>
+                </a:solidFill>
+                <a:latin typeface="Calibri" pitchFamily="34" charset="0"/>
+                <a:ea typeface="Calibri" pitchFamily="34" charset="-122"/>
+                <a:cs typeface="Calibri" pitchFamily="34" charset="-120"/>
+              </a:rPr>
+              <a:t>Le ciel qui parle</a:t>
+            </a:r>
+            <a:endParaRPr lang="fr-CA" sz="1800" dirty="0"/>
+          </a:p>
+        </p:txBody>
+      </p:sp>
+      <p:sp>
+        <p:nvSpPr>
+          <p:cNvPr id="26" name="Text 23"/>
+          <p:cNvSpPr txBox="1"/>
+          <p:nvPr/>
+        </p:nvSpPr>
+        <p:spPr>
+          <a:xfrm>
+            <a:off x="777240" y="5175504"/>
+            <a:ext cx="3794760" cy="685800"/>
+          </a:xfrm>
+          <a:prstGeom prst="rect">
+            <a:avLst/>
+          </a:prstGeom>
+          <a:noFill/>
+          <a:ln/>
+        </p:spPr>
+        <p:txBody>
           <a:bodyPr wrap="square" lIns="0" tIns="0" rIns="0" bIns="0" rtlCol="0" anchor="t"/>
           <a:lstStyle/>
           <a:p>
@@ -15305,15 +15643,15 @@
               <a:buNone/>
             </a:pPr>
             <a:r>
-              <a:rPr lang="fr-CA" altLang="en-US" sz="1800" b="1" dirty="0">
-                <a:solidFill>
-                  <a:srgbClr val="F4EDE4"/>
-                </a:solidFill>
-                <a:latin typeface="Calibri" pitchFamily="34" charset="0"/>
-                <a:ea typeface="Calibri" pitchFamily="34" charset="-122"/>
-                <a:cs typeface="Calibri" pitchFamily="34" charset="-120"/>
-              </a:rPr>
-              <a:t>Le ciel qui parle</a:t>
+              <a:rPr lang="fr-CA" altLang="en-US" sz="1500" dirty="0">
+                <a:solidFill>
+                  <a:srgbClr val="E8742A"/>
+                </a:solidFill>
+                <a:latin typeface="Calibri" pitchFamily="34" charset="0"/>
+                <a:ea typeface="Calibri" pitchFamily="34" charset="-122"/>
+                <a:cs typeface="Calibri" pitchFamily="34" charset="-120"/>
+              </a:rPr>
+              <a:t>Psaume 19.2‑7</a:t>
             </a:r>
             <a:endParaRPr lang="fr-CA" sz="1500" dirty="0"/>
           </a:p>
@@ -15322,40 +15660,23 @@
               <a:buNone/>
             </a:pPr>
             <a:r>
-              <a:rPr lang="fr-CA" altLang="en-US" sz="1500" dirty="0">
-                <a:solidFill>
-                  <a:srgbClr val="E8742A"/>
-                </a:solidFill>
-                <a:latin typeface="Calibri" pitchFamily="34" charset="0"/>
-                <a:ea typeface="Calibri" pitchFamily="34" charset="-122"/>
-                <a:cs typeface="Calibri" pitchFamily="34" charset="-120"/>
-              </a:rPr>
-              <a:t>Psaume 19.2‑7</a:t>
+              <a:rPr lang="fr-CA" altLang="en-US" sz="1400" dirty="0">
+                <a:solidFill>
+                  <a:srgbClr val="A89A8C"/>
+                </a:solidFill>
+                <a:latin typeface="Calibri" pitchFamily="34" charset="0"/>
+                <a:ea typeface="Calibri" pitchFamily="34" charset="-122"/>
+                <a:cs typeface="Calibri" pitchFamily="34" charset="-120"/>
+              </a:rPr>
+              <a:t>Proclamation des cieux (19.2‑5b), importance du soleil (19.5c‑7)</a:t>
             </a:r>
             <a:endParaRPr lang="fr-CA" sz="1500" dirty="0"/>
           </a:p>
-          <a:p>
-            <a:pPr indent="0" marL="0">
-              <a:buNone/>
-            </a:pPr>
-            <a:r>
-              <a:rPr lang="fr-CA" altLang="en-US" sz="1400" dirty="0">
-                <a:solidFill>
-                  <a:srgbClr val="A89A8C"/>
-                </a:solidFill>
-                <a:latin typeface="Calibri" pitchFamily="34" charset="0"/>
-                <a:ea typeface="Calibri" pitchFamily="34" charset="-122"/>
-                <a:cs typeface="Calibri" pitchFamily="34" charset="-120"/>
-              </a:rPr>
-              <a:t>Proclamation des cieux (19.2‑5b), importance du soleil (19.5c-7)</a:t>
-            </a:r>
-            <a:endParaRPr lang="fr-CA" sz="1500" dirty="0"/>
-          </a:p>
-        </p:txBody>
-      </p:sp>
-      <p:sp>
-        <p:nvSpPr>
-          <p:cNvPr id="26" name="Shape 23"/>
+        </p:txBody>
+      </p:sp>
+      <p:sp>
+        <p:nvSpPr>
+          <p:cNvPr id="27" name="Shape 24"/>
           <p:cNvSpPr/>
           <p:nvPr/>
         </p:nvSpPr>
@@ -15382,7 +15703,7 @@
       </p:sp>
       <p:sp>
         <p:nvSpPr>
-          <p:cNvPr id="27" name="Shape 24"/>
+          <p:cNvPr id="28" name="Shape 25"/>
           <p:cNvSpPr/>
           <p:nvPr/>
         </p:nvSpPr>
@@ -15407,7 +15728,7 @@
       </p:sp>
       <p:pic>
         <p:nvPicPr>
-          <p:cNvPr id="28" name="Image 1" descr="Icône : livre ouvert">    </p:cNvPr>
+          <p:cNvPr id="29" name="Image 1" descr="Icône : livre ouvert">    </p:cNvPr>
           <p:cNvPicPr>
             <a:picLocks noChangeAspect="1"/>
           </p:cNvPicPr>
@@ -15431,7 +15752,7 @@
       </p:pic>
       <p:sp>
         <p:nvSpPr>
-          <p:cNvPr id="29" name="Text 25"/>
+          <p:cNvPr id="30" name="Text 26"/>
           <p:cNvSpPr txBox="1"/>
           <p:nvPr/>
         </p:nvSpPr>
@@ -15470,14 +15791,14 @@
       </p:sp>
       <p:sp>
         <p:nvSpPr>
-          <p:cNvPr id="30" name="Text 26"/>
+          <p:cNvPr id="31" name="Text 27"/>
           <p:cNvSpPr txBox="1"/>
           <p:nvPr/>
         </p:nvSpPr>
         <p:spPr>
           <a:xfrm>
-            <a:off x="5212080" y="4617720"/>
-            <a:ext cx="1664208" cy="1234440"/>
+            <a:off x="5212080" y="4553712"/>
+            <a:ext cx="1664208" cy="603504"/>
           </a:xfrm>
           <a:prstGeom prst="rect">
             <a:avLst/>
@@ -15486,6 +15807,45 @@
           <a:ln/>
         </p:spPr>
         <p:txBody>
+          <a:bodyPr wrap="square" lIns="0" tIns="0" rIns="0" bIns="0" rtlCol="0" anchor="b"/>
+          <a:lstStyle/>
+          <a:p>
+            <a:pPr indent="0" marL="0">
+              <a:buNone/>
+            </a:pPr>
+            <a:r>
+              <a:rPr lang="fr-CA" altLang="en-US" sz="1800" b="1" dirty="0">
+                <a:solidFill>
+                  <a:srgbClr val="F4EDE4"/>
+                </a:solidFill>
+                <a:latin typeface="Calibri" pitchFamily="34" charset="0"/>
+                <a:ea typeface="Calibri" pitchFamily="34" charset="-122"/>
+                <a:cs typeface="Calibri" pitchFamily="34" charset="-120"/>
+              </a:rPr>
+              <a:t>La Parole qui suffit</a:t>
+            </a:r>
+            <a:endParaRPr lang="fr-CA" sz="1800" dirty="0"/>
+          </a:p>
+        </p:txBody>
+      </p:sp>
+      <p:sp>
+        <p:nvSpPr>
+          <p:cNvPr id="32" name="Text 28"/>
+          <p:cNvSpPr txBox="1"/>
+          <p:nvPr/>
+        </p:nvSpPr>
+        <p:spPr>
+          <a:xfrm>
+            <a:off x="5212080" y="5175504"/>
+            <a:ext cx="1664208" cy="685800"/>
+          </a:xfrm>
+          <a:prstGeom prst="rect">
+            <a:avLst/>
+          </a:prstGeom>
+          <a:noFill/>
+          <a:ln/>
+        </p:spPr>
+        <p:txBody>
           <a:bodyPr wrap="square" lIns="0" tIns="0" rIns="0" bIns="0" rtlCol="0" anchor="t"/>
           <a:lstStyle/>
           <a:p>
@@ -15493,15 +15853,15 @@
               <a:buNone/>
             </a:pPr>
             <a:r>
-              <a:rPr lang="fr-CA" altLang="en-US" sz="1800" b="1" dirty="0">
-                <a:solidFill>
-                  <a:srgbClr val="F4EDE4"/>
-                </a:solidFill>
-                <a:latin typeface="Calibri" pitchFamily="34" charset="0"/>
-                <a:ea typeface="Calibri" pitchFamily="34" charset="-122"/>
-                <a:cs typeface="Calibri" pitchFamily="34" charset="-120"/>
-              </a:rPr>
-              <a:t>La Parole qui suffit</a:t>
+              <a:rPr lang="fr-CA" altLang="en-US" sz="1500" dirty="0">
+                <a:solidFill>
+                  <a:srgbClr val="E8742A"/>
+                </a:solidFill>
+                <a:latin typeface="Calibri" pitchFamily="34" charset="0"/>
+                <a:ea typeface="Calibri" pitchFamily="34" charset="-122"/>
+                <a:cs typeface="Calibri" pitchFamily="34" charset="-120"/>
+              </a:rPr>
+              <a:t>Psaume 19.8‑10</a:t>
             </a:r>
             <a:endParaRPr lang="fr-CA" sz="1500" dirty="0"/>
           </a:p>
@@ -15510,40 +15870,23 @@
               <a:buNone/>
             </a:pPr>
             <a:r>
-              <a:rPr lang="fr-CA" altLang="en-US" sz="1500" dirty="0">
-                <a:solidFill>
-                  <a:srgbClr val="E8742A"/>
-                </a:solidFill>
-                <a:latin typeface="Calibri" pitchFamily="34" charset="0"/>
-                <a:ea typeface="Calibri" pitchFamily="34" charset="-122"/>
-                <a:cs typeface="Calibri" pitchFamily="34" charset="-120"/>
-              </a:rPr>
-              <a:t>Psaume 19.8‑10</a:t>
+              <a:rPr lang="fr-CA" altLang="en-US" sz="1400" dirty="0">
+                <a:solidFill>
+                  <a:srgbClr val="A89A8C"/>
+                </a:solidFill>
+                <a:latin typeface="Calibri" pitchFamily="34" charset="0"/>
+                <a:ea typeface="Calibri" pitchFamily="34" charset="-122"/>
+                <a:cs typeface="Calibri" pitchFamily="34" charset="-120"/>
+              </a:rPr>
+              <a:t>Attributs</a:t>
             </a:r>
             <a:endParaRPr lang="fr-CA" sz="1500" dirty="0"/>
           </a:p>
-          <a:p>
-            <a:pPr indent="0" marL="0">
-              <a:buNone/>
-            </a:pPr>
-            <a:r>
-              <a:rPr lang="fr-CA" altLang="en-US" sz="1400" dirty="0">
-                <a:solidFill>
-                  <a:srgbClr val="A89A8C"/>
-                </a:solidFill>
-                <a:latin typeface="Calibri" pitchFamily="34" charset="0"/>
-                <a:ea typeface="Calibri" pitchFamily="34" charset="-122"/>
-                <a:cs typeface="Calibri" pitchFamily="34" charset="-120"/>
-              </a:rPr>
-              <a:t>Attributs de la Parole</a:t>
-            </a:r>
-            <a:endParaRPr lang="fr-CA" sz="1500" dirty="0"/>
-          </a:p>
-        </p:txBody>
-      </p:sp>
-      <p:sp>
-        <p:nvSpPr>
-          <p:cNvPr id="31" name="Shape 27"/>
+        </p:txBody>
+      </p:sp>
+      <p:sp>
+        <p:nvSpPr>
+          <p:cNvPr id="33" name="Shape 29"/>
           <p:cNvSpPr/>
           <p:nvPr/>
         </p:nvSpPr>
@@ -15570,7 +15913,7 @@
       </p:sp>
       <p:sp>
         <p:nvSpPr>
-          <p:cNvPr id="32" name="Shape 28"/>
+          <p:cNvPr id="34" name="Shape 30"/>
           <p:cNvSpPr/>
           <p:nvPr/>
         </p:nvSpPr>
@@ -15595,7 +15938,7 @@
       </p:sp>
       <p:pic>
         <p:nvPicPr>
-          <p:cNvPr id="33" name="Image 2" descr="Icône : lingots d'or">    </p:cNvPr>
+          <p:cNvPr id="35" name="Image 2" descr="Icône : lingots d'or">    </p:cNvPr>
           <p:cNvPicPr>
             <a:picLocks noChangeAspect="1"/>
           </p:cNvPicPr>
@@ -15619,7 +15962,7 @@
       </p:pic>
       <p:sp>
         <p:nvSpPr>
-          <p:cNvPr id="34" name="Text 29"/>
+          <p:cNvPr id="36" name="Text 31"/>
           <p:cNvSpPr txBox="1"/>
           <p:nvPr/>
         </p:nvSpPr>
@@ -15658,14 +16001,14 @@
       </p:sp>
       <p:sp>
         <p:nvSpPr>
-          <p:cNvPr id="35" name="Text 30"/>
+          <p:cNvPr id="37" name="Text 32"/>
           <p:cNvSpPr txBox="1"/>
           <p:nvPr/>
         </p:nvSpPr>
         <p:spPr>
           <a:xfrm>
-            <a:off x="7502652" y="4617720"/>
-            <a:ext cx="1664208" cy="1234440"/>
+            <a:off x="7502652" y="4553712"/>
+            <a:ext cx="1664208" cy="603504"/>
           </a:xfrm>
           <a:prstGeom prst="rect">
             <a:avLst/>
@@ -15674,6 +16017,45 @@
           <a:ln/>
         </p:spPr>
         <p:txBody>
+          <a:bodyPr wrap="square" lIns="0" tIns="0" rIns="0" bIns="0" rtlCol="0" anchor="b"/>
+          <a:lstStyle/>
+          <a:p>
+            <a:pPr indent="0" marL="0">
+              <a:buNone/>
+            </a:pPr>
+            <a:r>
+              <a:rPr lang="fr-CA" altLang="en-US" sz="1800" b="1" dirty="0">
+                <a:solidFill>
+                  <a:srgbClr val="F4EDE4"/>
+                </a:solidFill>
+                <a:latin typeface="Calibri" pitchFamily="34" charset="0"/>
+                <a:ea typeface="Calibri" pitchFamily="34" charset="-122"/>
+                <a:cs typeface="Calibri" pitchFamily="34" charset="-120"/>
+              </a:rPr>
+              <a:t>La Parole qu'on désire</a:t>
+            </a:r>
+            <a:endParaRPr lang="fr-CA" sz="1800" dirty="0"/>
+          </a:p>
+        </p:txBody>
+      </p:sp>
+      <p:sp>
+        <p:nvSpPr>
+          <p:cNvPr id="38" name="Text 33"/>
+          <p:cNvSpPr txBox="1"/>
+          <p:nvPr/>
+        </p:nvSpPr>
+        <p:spPr>
+          <a:xfrm>
+            <a:off x="7502652" y="5175504"/>
+            <a:ext cx="1664208" cy="685800"/>
+          </a:xfrm>
+          <a:prstGeom prst="rect">
+            <a:avLst/>
+          </a:prstGeom>
+          <a:noFill/>
+          <a:ln/>
+        </p:spPr>
+        <p:txBody>
           <a:bodyPr wrap="square" lIns="0" tIns="0" rIns="0" bIns="0" rtlCol="0" anchor="t"/>
           <a:lstStyle/>
           <a:p>
@@ -15681,15 +16063,15 @@
               <a:buNone/>
             </a:pPr>
             <a:r>
-              <a:rPr lang="fr-CA" altLang="en-US" sz="1800" b="1" dirty="0">
-                <a:solidFill>
-                  <a:srgbClr val="F4EDE4"/>
-                </a:solidFill>
-                <a:latin typeface="Calibri" pitchFamily="34" charset="0"/>
-                <a:ea typeface="Calibri" pitchFamily="34" charset="-122"/>
-                <a:cs typeface="Calibri" pitchFamily="34" charset="-120"/>
-              </a:rPr>
-              <a:t>La Parole qu'on désire</a:t>
+              <a:rPr lang="fr-CA" altLang="en-US" sz="1500" dirty="0">
+                <a:solidFill>
+                  <a:srgbClr val="E8742A"/>
+                </a:solidFill>
+                <a:latin typeface="Calibri" pitchFamily="34" charset="0"/>
+                <a:ea typeface="Calibri" pitchFamily="34" charset="-122"/>
+                <a:cs typeface="Calibri" pitchFamily="34" charset="-120"/>
+              </a:rPr>
+              <a:t>Psaume 19.11‑12</a:t>
             </a:r>
             <a:endParaRPr lang="fr-CA" sz="1500" dirty="0"/>
           </a:p>
@@ -15698,40 +16080,23 @@
               <a:buNone/>
             </a:pPr>
             <a:r>
-              <a:rPr lang="fr-CA" altLang="en-US" sz="1500" dirty="0">
-                <a:solidFill>
-                  <a:srgbClr val="E8742A"/>
-                </a:solidFill>
-                <a:latin typeface="Calibri" pitchFamily="34" charset="0"/>
-                <a:ea typeface="Calibri" pitchFamily="34" charset="-122"/>
-                <a:cs typeface="Calibri" pitchFamily="34" charset="-120"/>
-              </a:rPr>
-              <a:t>Psaume 19.11‑12</a:t>
+              <a:rPr lang="fr-CA" altLang="en-US" sz="1400" dirty="0">
+                <a:solidFill>
+                  <a:srgbClr val="A89A8C"/>
+                </a:solidFill>
+                <a:latin typeface="Calibri" pitchFamily="34" charset="0"/>
+                <a:ea typeface="Calibri" pitchFamily="34" charset="-122"/>
+                <a:cs typeface="Calibri" pitchFamily="34" charset="-120"/>
+              </a:rPr>
+              <a:t>Appréciation</a:t>
             </a:r>
             <a:endParaRPr lang="fr-CA" sz="1500" dirty="0"/>
           </a:p>
-          <a:p>
-            <a:pPr indent="0" marL="0">
-              <a:buNone/>
-            </a:pPr>
-            <a:r>
-              <a:rPr lang="fr-CA" altLang="en-US" sz="1400" dirty="0">
-                <a:solidFill>
-                  <a:srgbClr val="A89A8C"/>
-                </a:solidFill>
-                <a:latin typeface="Calibri" pitchFamily="34" charset="0"/>
-                <a:ea typeface="Calibri" pitchFamily="34" charset="-122"/>
-                <a:cs typeface="Calibri" pitchFamily="34" charset="-120"/>
-              </a:rPr>
-              <a:t>Appréciation</a:t>
-            </a:r>
-            <a:endParaRPr lang="fr-CA" sz="1500" dirty="0"/>
-          </a:p>
-        </p:txBody>
-      </p:sp>
-      <p:sp>
-        <p:nvSpPr>
-          <p:cNvPr id="36" name="Shape 31"/>
+        </p:txBody>
+      </p:sp>
+      <p:sp>
+        <p:nvSpPr>
+          <p:cNvPr id="39" name="Shape 34"/>
           <p:cNvSpPr/>
           <p:nvPr/>
         </p:nvSpPr>
@@ -15758,7 +16123,7 @@
       </p:sp>
       <p:sp>
         <p:nvSpPr>
-          <p:cNvPr id="37" name="Shape 32"/>
+          <p:cNvPr id="40" name="Shape 35"/>
           <p:cNvSpPr/>
           <p:nvPr/>
         </p:nvSpPr>
@@ -15783,7 +16148,7 @@
       </p:sp>
       <p:pic>
         <p:nvPicPr>
-          <p:cNvPr id="38" name="Image 3" descr="Icône : cœur">    </p:cNvPr>
+          <p:cNvPr id="41" name="Image 3" descr="Icône : cœur">    </p:cNvPr>
           <p:cNvPicPr>
             <a:picLocks noChangeAspect="1"/>
           </p:cNvPicPr>
@@ -15807,7 +16172,7 @@
       </p:pic>
       <p:sp>
         <p:nvSpPr>
-          <p:cNvPr id="39" name="Text 33"/>
+          <p:cNvPr id="42" name="Text 36"/>
           <p:cNvSpPr txBox="1"/>
           <p:nvPr/>
         </p:nvSpPr>
@@ -15846,14 +16211,14 @@
       </p:sp>
       <p:sp>
         <p:nvSpPr>
-          <p:cNvPr id="40" name="Text 34"/>
+          <p:cNvPr id="43" name="Text 37"/>
           <p:cNvSpPr txBox="1"/>
           <p:nvPr/>
         </p:nvSpPr>
         <p:spPr>
           <a:xfrm>
-            <a:off x="9793224" y="4617720"/>
-            <a:ext cx="1664208" cy="1234440"/>
+            <a:off x="9793224" y="4553712"/>
+            <a:ext cx="1664208" cy="603504"/>
           </a:xfrm>
           <a:prstGeom prst="rect">
             <a:avLst/>
@@ -15862,6 +16227,45 @@
           <a:ln/>
         </p:spPr>
         <p:txBody>
+          <a:bodyPr wrap="square" lIns="0" tIns="0" rIns="0" bIns="0" rtlCol="0" anchor="b"/>
+          <a:lstStyle/>
+          <a:p>
+            <a:pPr indent="0" marL="0">
+              <a:buNone/>
+            </a:pPr>
+            <a:r>
+              <a:rPr lang="fr-CA" altLang="en-US" sz="1800" b="1" dirty="0">
+                <a:solidFill>
+                  <a:srgbClr val="F4EDE4"/>
+                </a:solidFill>
+                <a:latin typeface="Calibri" pitchFamily="34" charset="0"/>
+                <a:ea typeface="Calibri" pitchFamily="34" charset="-122"/>
+                <a:cs typeface="Calibri" pitchFamily="34" charset="-120"/>
+              </a:rPr>
+              <a:t>Le cœur qui s'offre</a:t>
+            </a:r>
+            <a:endParaRPr lang="fr-CA" sz="1800" dirty="0"/>
+          </a:p>
+        </p:txBody>
+      </p:sp>
+      <p:sp>
+        <p:nvSpPr>
+          <p:cNvPr id="44" name="Text 38"/>
+          <p:cNvSpPr txBox="1"/>
+          <p:nvPr/>
+        </p:nvSpPr>
+        <p:spPr>
+          <a:xfrm>
+            <a:off x="9793224" y="5175504"/>
+            <a:ext cx="1664208" cy="685800"/>
+          </a:xfrm>
+          <a:prstGeom prst="rect">
+            <a:avLst/>
+          </a:prstGeom>
+          <a:noFill/>
+          <a:ln/>
+        </p:spPr>
+        <p:txBody>
           <a:bodyPr wrap="square" lIns="0" tIns="0" rIns="0" bIns="0" rtlCol="0" anchor="t"/>
           <a:lstStyle/>
           <a:p>
@@ -15869,15 +16273,15 @@
               <a:buNone/>
             </a:pPr>
             <a:r>
-              <a:rPr lang="fr-CA" altLang="en-US" sz="1800" b="1" dirty="0">
-                <a:solidFill>
-                  <a:srgbClr val="F4EDE4"/>
-                </a:solidFill>
-                <a:latin typeface="Calibri" pitchFamily="34" charset="0"/>
-                <a:ea typeface="Calibri" pitchFamily="34" charset="-122"/>
-                <a:cs typeface="Calibri" pitchFamily="34" charset="-120"/>
-              </a:rPr>
-              <a:t>Le cœur qui s'offre</a:t>
+              <a:rPr lang="fr-CA" altLang="en-US" sz="1500" dirty="0">
+                <a:solidFill>
+                  <a:srgbClr val="E8742A"/>
+                </a:solidFill>
+                <a:latin typeface="Calibri" pitchFamily="34" charset="0"/>
+                <a:ea typeface="Calibri" pitchFamily="34" charset="-122"/>
+                <a:cs typeface="Calibri" pitchFamily="34" charset="-120"/>
+              </a:rPr>
+              <a:t>Psaume 19.13‑15</a:t>
             </a:r>
             <a:endParaRPr lang="fr-CA" sz="1500" dirty="0"/>
           </a:p>
@@ -15886,40 +16290,23 @@
               <a:buNone/>
             </a:pPr>
             <a:r>
-              <a:rPr lang="fr-CA" altLang="en-US" sz="1500" dirty="0">
-                <a:solidFill>
-                  <a:srgbClr val="E8742A"/>
-                </a:solidFill>
-                <a:latin typeface="Calibri" pitchFamily="34" charset="0"/>
-                <a:ea typeface="Calibri" pitchFamily="34" charset="-122"/>
-                <a:cs typeface="Calibri" pitchFamily="34" charset="-120"/>
-              </a:rPr>
-              <a:t>Psaume 19.13‑15</a:t>
+              <a:rPr lang="fr-CA" altLang="en-US" sz="1400" dirty="0">
+                <a:solidFill>
+                  <a:srgbClr val="A89A8C"/>
+                </a:solidFill>
+                <a:latin typeface="Calibri" pitchFamily="34" charset="0"/>
+                <a:ea typeface="Calibri" pitchFamily="34" charset="-122"/>
+                <a:cs typeface="Calibri" pitchFamily="34" charset="-120"/>
+              </a:rPr>
+              <a:t>Application</a:t>
             </a:r>
             <a:endParaRPr lang="fr-CA" sz="1500" dirty="0"/>
           </a:p>
-          <a:p>
-            <a:pPr indent="0" marL="0">
-              <a:buNone/>
-            </a:pPr>
-            <a:r>
-              <a:rPr lang="fr-CA" altLang="en-US" sz="1400" dirty="0">
-                <a:solidFill>
-                  <a:srgbClr val="A89A8C"/>
-                </a:solidFill>
-                <a:latin typeface="Calibri" pitchFamily="34" charset="0"/>
-                <a:ea typeface="Calibri" pitchFamily="34" charset="-122"/>
-                <a:cs typeface="Calibri" pitchFamily="34" charset="-120"/>
-              </a:rPr>
-              <a:t>Application</a:t>
-            </a:r>
-            <a:endParaRPr lang="fr-CA" sz="1500" dirty="0"/>
-          </a:p>
-        </p:txBody>
-      </p:sp>
-      <p:sp>
-        <p:nvSpPr>
-          <p:cNvPr id="41" name="Text 35"/>
+        </p:txBody>
+      </p:sp>
+      <p:sp>
+        <p:nvSpPr>
+          <p:cNvPr id="45" name="Text 39"/>
           <p:cNvSpPr txBox="1"/>
           <p:nvPr/>
         </p:nvSpPr>
@@ -15942,7 +16329,7 @@
               <a:buNone/>
             </a:pPr>
             <a:r>
-              <a:rPr lang="fr-CA" altLang="en-US" sz="1400" i="1" dirty="0">
+              <a:rPr lang="fr-CA" altLang="en-US" sz="1600" i="1" dirty="0">
                 <a:solidFill>
                   <a:srgbClr val="A89A8C"/>
                 </a:solidFill>
@@ -15950,9 +16337,9 @@
                 <a:ea typeface="Calibri" pitchFamily="34" charset="-122"/>
                 <a:cs typeface="Calibri" pitchFamily="34" charset="-120"/>
               </a:rPr>
-              <a:t>« Je pense que c'est le plus grand passage, à lui seul, sur la suffisance de l'Écriture dans toute la Bible »  (MacArthur)</a:t>
-            </a:r>
-            <a:endParaRPr lang="fr-CA" sz="1400" dirty="0"/>
+              <a:t>« Je pense que c'est le plus grand passage de toute la Bible sur la suffisance de l'Écriture » (MacArthur)</a:t>
+            </a:r>
+            <a:endParaRPr lang="fr-CA" sz="1600" dirty="0"/>
           </a:p>
         </p:txBody>
       </p:sp>
@@ -15972,7 +16359,7 @@
         </p:grpSpPr>
         <p:sp>
           <p:nvSpPr>
-            <p:cNvPr id="42" name="Progression 1"/>
+            <p:cNvPr id="46" name="Progression 1"/>
             <p:cNvSpPr/>
             <p:nvPr/>
           </p:nvSpPr>
@@ -15992,7 +16379,7 @@
         </p:sp>
         <p:sp>
           <p:nvSpPr>
-            <p:cNvPr id="43" name="Progression 2"/>
+            <p:cNvPr id="47" name="Progression 2"/>
             <p:cNvSpPr/>
             <p:nvPr/>
           </p:nvSpPr>
@@ -16012,7 +16399,7 @@
         </p:sp>
         <p:sp>
           <p:nvSpPr>
-            <p:cNvPr id="44" name="Progression 3"/>
+            <p:cNvPr id="48" name="Progression 3"/>
             <p:cNvSpPr/>
             <p:nvPr/>
           </p:nvSpPr>
@@ -16032,7 +16419,7 @@
         </p:sp>
         <p:sp>
           <p:nvSpPr>
-            <p:cNvPr id="45" name="Progression 4"/>
+            <p:cNvPr id="49" name="Progression 4"/>
             <p:cNvSpPr/>
             <p:nvPr/>
           </p:nvSpPr>
@@ -16052,7 +16439,7 @@
         </p:sp>
         <p:sp>
           <p:nvSpPr>
-            <p:cNvPr id="46" name="Progression 5"/>
+            <p:cNvPr id="50" name="Progression 5"/>
             <p:cNvSpPr/>
             <p:nvPr/>
           </p:nvSpPr>
@@ -16072,7 +16459,7 @@
         </p:sp>
         <p:sp>
           <p:nvSpPr>
-            <p:cNvPr id="47" name="Progression 6"/>
+            <p:cNvPr id="51" name="Progression 6"/>
             <p:cNvSpPr/>
             <p:nvPr/>
           </p:nvSpPr>
@@ -16092,7 +16479,7 @@
         </p:sp>
         <p:sp>
           <p:nvSpPr>
-            <p:cNvPr id="48" name="Progression 7"/>
+            <p:cNvPr id="52" name="Progression 7"/>
             <p:cNvSpPr/>
             <p:nvPr/>
           </p:nvSpPr>
@@ -16112,7 +16499,7 @@
         </p:sp>
         <p:sp>
           <p:nvSpPr>
-            <p:cNvPr id="49" name="Progression 8"/>
+            <p:cNvPr id="53" name="Progression 8"/>
             <p:cNvSpPr/>
             <p:nvPr/>
           </p:nvSpPr>
@@ -16132,7 +16519,7 @@
         </p:sp>
         <p:sp>
           <p:nvSpPr>
-            <p:cNvPr id="50" name="Progression 9"/>
+            <p:cNvPr id="54" name="Progression 9"/>
             <p:cNvSpPr/>
             <p:nvPr/>
           </p:nvSpPr>
@@ -16152,7 +16539,7 @@
         </p:sp>
         <p:sp>
           <p:nvSpPr>
-            <p:cNvPr id="51" name="Progression 10"/>
+            <p:cNvPr id="55" name="Progression 10"/>
             <p:cNvSpPr/>
             <p:nvPr/>
           </p:nvSpPr>
@@ -16172,7 +16559,7 @@
         </p:sp>
         <p:sp>
           <p:nvSpPr>
-            <p:cNvPr id="52" name="Progression 11"/>
+            <p:cNvPr id="56" name="Progression 11"/>
             <p:cNvSpPr/>
             <p:nvPr/>
           </p:nvSpPr>
@@ -16192,7 +16579,7 @@
         </p:sp>
         <p:sp>
           <p:nvSpPr>
-            <p:cNvPr id="53" name="Progression 12"/>
+            <p:cNvPr id="57" name="Progression 12"/>
             <p:cNvSpPr/>
             <p:nvPr/>
           </p:nvSpPr>
@@ -16212,7 +16599,7 @@
         </p:sp>
         <p:sp>
           <p:nvSpPr>
-            <p:cNvPr id="54" name="Progression 13"/>
+            <p:cNvPr id="58" name="Progression 13"/>
             <p:cNvSpPr/>
             <p:nvPr/>
           </p:nvSpPr>
@@ -16232,7 +16619,7 @@
         </p:sp>
         <p:sp>
           <p:nvSpPr>
-            <p:cNvPr id="55" name="Progression 14"/>
+            <p:cNvPr id="59" name="Progression 14"/>
             <p:cNvSpPr/>
             <p:nvPr/>
           </p:nvSpPr>
@@ -16252,7 +16639,7 @@
         </p:sp>
         <p:sp>
           <p:nvSpPr>
-            <p:cNvPr id="56" name="Progression 15"/>
+            <p:cNvPr id="60" name="Progression 15"/>
             <p:cNvSpPr/>
             <p:nvPr/>
           </p:nvSpPr>
@@ -16606,7 +16993,7 @@
         <p:spPr>
           <a:xfrm>
             <a:off x="548640" y="5577840"/>
-            <a:ext cx="1828800" cy="731520"/>
+            <a:ext cx="1737360" cy="731520"/>
           </a:xfrm>
           <a:prstGeom prst="roundRect">
             <a:avLst>
@@ -16633,7 +17020,7 @@
         <p:spPr>
           <a:xfrm>
             <a:off x="640080" y="5577840"/>
-            <a:ext cx="1645920" cy="731520"/>
+            <a:ext cx="1554480" cy="731520"/>
           </a:xfrm>
           <a:prstGeom prst="rect">
             <a:avLst/>
@@ -16688,8 +17075,8 @@
         </p:nvSpPr>
         <p:spPr>
           <a:xfrm>
-            <a:off x="2468880" y="5577840"/>
-            <a:ext cx="1920240" cy="731520"/>
+            <a:off x="2377440" y="5577840"/>
+            <a:ext cx="1828800" cy="731520"/>
           </a:xfrm>
           <a:prstGeom prst="roundRect">
             <a:avLst>
@@ -16715,8 +17102,8 @@
         </p:nvSpPr>
         <p:spPr>
           <a:xfrm>
-            <a:off x="2560320" y="5577840"/>
-            <a:ext cx="1737360" cy="731520"/>
+            <a:off x="2468880" y="5577840"/>
+            <a:ext cx="1645920" cy="731520"/>
           </a:xfrm>
           <a:prstGeom prst="rect">
             <a:avLst/>
@@ -16757,7 +17144,7 @@
                 <a:ea typeface="Calibri" pitchFamily="34" charset="-122"/>
                 <a:cs typeface="Calibri" pitchFamily="34" charset="-120"/>
               </a:rPr>
-              <a:t>19.5c-7</a:t>
+              <a:t>19.5c‑7</a:t>
             </a:r>
             <a:endParaRPr lang="fr-CA" sz="1400" dirty="0"/>
           </a:p>
@@ -16771,7 +17158,7 @@
         </p:nvSpPr>
         <p:spPr>
           <a:xfrm>
-            <a:off x="4480560" y="5577840"/>
+            <a:off x="4297680" y="5577840"/>
             <a:ext cx="2514600" cy="731520"/>
           </a:xfrm>
           <a:prstGeom prst="roundRect">
@@ -16798,7 +17185,7 @@
         </p:nvSpPr>
         <p:spPr>
           <a:xfrm>
-            <a:off x="4572000" y="5577840"/>
+            <a:off x="4389120" y="5577840"/>
             <a:ext cx="2331720" cy="731520"/>
           </a:xfrm>
           <a:prstGeom prst="rect">
@@ -17042,7 +17429,7 @@
                 <a:ea typeface="Calibri" pitchFamily="34" charset="-122"/>
                 <a:cs typeface="Calibri" pitchFamily="34" charset="-120"/>
               </a:rPr>
-              <a:t>La gloire, c'est le poids</a:t>
+              <a:t>Le poids de la gloire</a:t>
             </a:r>
             <a:endParaRPr lang="fr-CA" sz="1500" dirty="0"/>
           </a:p>
@@ -17054,6 +17441,23 @@
               <a:buNone/>
             </a:pPr>
             <a:r>
+              <a:rPr lang="fr-CA" altLang="en-US" sz="1500" i="1" dirty="0">
+                <a:solidFill>
+                  <a:srgbClr val="A89A8C"/>
+                </a:solidFill>
+                <a:latin typeface="Calibri" pitchFamily="34" charset="0"/>
+                <a:ea typeface="Calibri" pitchFamily="34" charset="-122"/>
+                <a:cs typeface="Calibri" pitchFamily="34" charset="-120"/>
+              </a:rPr>
+              <a:t>Kavod</a:t>
+            </a:r>
+            <a:pPr indent="0" marL="0">
+              <a:spcBef>
+                <a:spcPts val="200"/>
+              </a:spcBef>
+              <a:buNone/>
+            </a:pPr>
+            <a:r>
               <a:rPr lang="fr-CA" altLang="en-US" sz="1500" dirty="0">
                 <a:solidFill>
                   <a:srgbClr val="A89A8C"/>
@@ -17062,7 +17466,7 @@
                 <a:ea typeface="Calibri" pitchFamily="34" charset="-122"/>
                 <a:cs typeface="Calibri" pitchFamily="34" charset="-120"/>
               </a:rPr>
-              <a:t>Kavod : le ciel nocturne fait sentir le poids de Dieu (Street).</a:t>
+              <a:t> : le ciel nocturne fait comprendre le poids de Dieu (Street).</a:t>
             </a:r>
             <a:endParaRPr lang="fr-CA" sz="1500" dirty="0"/>
           </a:p>
@@ -17095,7 +17499,7 @@
       </p:sp>
       <p:pic>
         <p:nvPicPr>
-          <p:cNvPr id="23" name="Image 3" descr="Icône : disque moitié clair, moitié sombre : le jour et la nuit">    </p:cNvPr>
+          <p:cNvPr id="23" name="Image 3" descr="Icône : disque moitié clair, moitié sombre (le jour et la nuit)">    </p:cNvPr>
           <p:cNvPicPr>
             <a:picLocks noChangeAspect="1"/>
           </p:cNvPicPr>
@@ -17745,7 +18149,7 @@
                 <a:ea typeface="Calibri" pitchFamily="34" charset="-122"/>
                 <a:cs typeface="Calibri" pitchFamily="34" charset="-120"/>
               </a:rPr>
-              <a:t>« Ce qu'on ne peut pas connaître, c'est la sagesse qui sauve »  (MacArthur)</a:t>
+              <a:t>« Ce qu'on ne peut pas connaître, c'est la sagesse qui sauve » (MacArthur)</a:t>
             </a:r>
             <a:endParaRPr lang="fr-CA" sz="1900" dirty="0"/>
           </a:p>
@@ -18103,6 +18507,20 @@
               <a:buNone/>
             </a:pPr>
             <a:r>
+              <a:rPr lang="fr-CA" altLang="en-US" sz="1700" i="1" dirty="0">
+                <a:solidFill>
+                  <a:srgbClr val="F4EDE4"/>
+                </a:solidFill>
+                <a:latin typeface="Calibri" pitchFamily="34" charset="0"/>
+                <a:ea typeface="Calibri" pitchFamily="34" charset="-122"/>
+                <a:cs typeface="Calibri" pitchFamily="34" charset="-120"/>
+              </a:rPr>
+              <a:t>El</a:t>
+            </a:r>
+            <a:pPr indent="0" marL="0">
+              <a:buNone/>
+            </a:pPr>
+            <a:r>
               <a:rPr lang="fr-CA" altLang="en-US" sz="1700" dirty="0">
                 <a:solidFill>
                   <a:srgbClr val="F4EDE4"/>
@@ -18111,7 +18529,7 @@
                 <a:ea typeface="Calibri" pitchFamily="34" charset="-122"/>
                 <a:cs typeface="Calibri" pitchFamily="34" charset="-120"/>
               </a:rPr>
-              <a:t>El, Dieu de puissance</a:t>
+              <a:t>, Dieu de puissance</a:t>
             </a:r>
             <a:endParaRPr lang="fr-CA" sz="1700" dirty="0"/>
           </a:p>
@@ -18870,7 +19288,7 @@
               <a:buNone/>
             </a:pPr>
             <a:r>
-              <a:rPr lang="fr-CA" altLang="en-US" sz="1400" dirty="0">
+              <a:rPr lang="fr-CA" altLang="en-US" sz="1600" dirty="0">
                 <a:solidFill>
                   <a:srgbClr val="A89A8C"/>
                 </a:solidFill>
@@ -19339,7 +19757,7 @@
                 <a:ea typeface="Calibri" pitchFamily="34" charset="-122"/>
                 <a:cs typeface="Calibri" pitchFamily="34" charset="-120"/>
               </a:rPr>
-              <a:t>Six titres, six qualités, six bienfaits : six fois « l'Éternel »  (MacArthur)</a:t>
+              <a:t>Il ne manque rien à la Parole, et il ne manque rien à celui qu'elle instruit</a:t>
             </a:r>
             <a:endParaRPr lang="fr-CA" sz="1900" dirty="0"/>
           </a:p>
@@ -19710,7 +20128,7 @@
               <a:buNone/>
             </a:pPr>
             <a:r>
-              <a:rPr lang="fr-CA" altLang="en-US" sz="1300" i="1" dirty="0">
+              <a:rPr lang="fr-CA" altLang="en-US" sz="1500" i="1" dirty="0">
                 <a:solidFill>
                   <a:srgbClr val="E8742A"/>
                 </a:solidFill>
@@ -19771,7 +20189,7 @@
                 <a:ea typeface="Calibri" pitchFamily="34" charset="-122"/>
                 <a:cs typeface="Calibri" pitchFamily="34" charset="-120"/>
               </a:rPr>
-              <a:t>  · complète</a:t>
+              <a:t> · complète</a:t>
             </a:r>
             <a:endParaRPr lang="fr-CA" sz="1600" dirty="0"/>
           </a:p>
@@ -19828,7 +20246,7 @@
       </p:sp>
       <p:pic>
         <p:nvPicPr>
-          <p:cNvPr id="17" name="Image 0" descr="Icône : cœur">    </p:cNvPr>
+          <p:cNvPr id="17" name="Image 0" descr="Icône : flèche de retour">    </p:cNvPr>
           <p:cNvPicPr>
             <a:picLocks noChangeAspect="1"/>
           </p:cNvPicPr>
@@ -19981,7 +20399,7 @@
               <a:buNone/>
             </a:pPr>
             <a:r>
-              <a:rPr lang="fr-CA" altLang="en-US" sz="1300" i="1" dirty="0">
+              <a:rPr lang="fr-CA" altLang="en-US" sz="1500" i="1" dirty="0">
                 <a:solidFill>
                   <a:srgbClr val="E8742A"/>
                 </a:solidFill>
@@ -20042,7 +20460,7 @@
                 <a:ea typeface="Calibri" pitchFamily="34" charset="-122"/>
                 <a:cs typeface="Calibri" pitchFamily="34" charset="-120"/>
               </a:rPr>
-              <a:t>  · sûr</a:t>
+              <a:t> · sûr</a:t>
             </a:r>
             <a:endParaRPr lang="fr-CA" sz="1600" dirty="0"/>
           </a:p>
@@ -20252,7 +20670,7 @@
               <a:buNone/>
             </a:pPr>
             <a:r>
-              <a:rPr lang="fr-CA" altLang="en-US" sz="1300" i="1" dirty="0">
+              <a:rPr lang="fr-CA" altLang="en-US" sz="1500" i="1" dirty="0">
                 <a:solidFill>
                   <a:srgbClr val="E8742A"/>
                 </a:solidFill>
@@ -20313,7 +20731,7 @@
                 <a:ea typeface="Calibri" pitchFamily="34" charset="-122"/>
                 <a:cs typeface="Calibri" pitchFamily="34" charset="-120"/>
               </a:rPr>
-              <a:t>  · le droit chemin</a:t>
+              <a:t> · le droit chemin</a:t>
             </a:r>
             <a:endParaRPr lang="fr-CA" sz="1600" dirty="0"/>
           </a:p>
@@ -20523,7 +20941,7 @@
               <a:buNone/>
             </a:pPr>
             <a:r>
-              <a:rPr lang="fr-CA" altLang="en-US" sz="1300" i="1" dirty="0">
+              <a:rPr lang="fr-CA" altLang="en-US" sz="1500" i="1" dirty="0">
                 <a:solidFill>
                   <a:srgbClr val="E8742A"/>
                 </a:solidFill>
@@ -20584,7 +21002,7 @@
                 <a:ea typeface="Calibri" pitchFamily="34" charset="-122"/>
                 <a:cs typeface="Calibri" pitchFamily="34" charset="-120"/>
               </a:rPr>
-              <a:t>  · clairs</a:t>
+              <a:t> · clairs</a:t>
             </a:r>
             <a:endParaRPr lang="fr-CA" sz="1600" dirty="0"/>
           </a:p>
@@ -20794,7 +21212,7 @@
               <a:buNone/>
             </a:pPr>
             <a:r>
-              <a:rPr lang="fr-CA" altLang="en-US" sz="1300" i="1" dirty="0">
+              <a:rPr lang="fr-CA" altLang="en-US" sz="1500" i="1" dirty="0">
                 <a:solidFill>
                   <a:srgbClr val="E8742A"/>
                 </a:solidFill>
@@ -20855,7 +21273,7 @@
                 <a:ea typeface="Calibri" pitchFamily="34" charset="-122"/>
                 <a:cs typeface="Calibri" pitchFamily="34" charset="-120"/>
               </a:rPr>
-              <a:t>  · nette</a:t>
+              <a:t> · nette</a:t>
             </a:r>
             <a:endParaRPr lang="fr-CA" sz="1600" dirty="0"/>
           </a:p>
@@ -21065,7 +21483,7 @@
               <a:buNone/>
             </a:pPr>
             <a:r>
-              <a:rPr lang="fr-CA" altLang="en-US" sz="1300" i="1" dirty="0">
+              <a:rPr lang="fr-CA" altLang="en-US" sz="1500" i="1" dirty="0">
                 <a:solidFill>
                   <a:srgbClr val="E8742A"/>
                 </a:solidFill>
@@ -21126,7 +21544,7 @@
                 <a:ea typeface="Calibri" pitchFamily="34" charset="-122"/>
                 <a:cs typeface="Calibri" pitchFamily="34" charset="-120"/>
               </a:rPr>
-              <a:t>  · absolument vrais</a:t>
+              <a:t> · absolument vrais</a:t>
             </a:r>
             <a:endParaRPr lang="fr-CA" sz="1600" dirty="0"/>
           </a:p>
@@ -22428,7 +22846,7 @@
                 <a:ea typeface="Cambria" pitchFamily="34" charset="-122"/>
                 <a:cs typeface="Cambria" pitchFamily="34" charset="-120"/>
               </a:rPr>
-              <a:t>« Une instruction divine si complète qu'elle peut transformer totalement l'homme intérieur tout entier »  (MacArthur)</a:t>
+              <a:t>« Une instruction divine si complète qu'elle peut transformer totalement l'homme intérieur tout entier » (MacArthur)</a:t>
             </a:r>
             <a:endParaRPr lang="fr-CA" sz="1600" dirty="0"/>
           </a:p>
@@ -22448,7 +22866,27 @@
                 <a:ea typeface="Calibri" pitchFamily="34" charset="-122"/>
                 <a:cs typeface="Calibri" pitchFamily="34" charset="-120"/>
               </a:rPr>
-              <a:t>Convertir, transformer, régénérer par l'œuvre de l'Esprit. Street rapproche Hébreux 4.12 : la Parole juge les pensées et les intentions du cœur.</a:t>
+              <a:t>Convertir, transformer, régénérer par l'œuvre de l'Esprit.</a:t>
+            </a:r>
+            <a:endParaRPr lang="fr-CA" sz="1600" dirty="0"/>
+          </a:p>
+          <a:p>
+            <a:pPr indent="0" marL="0">
+              <a:spcBef>
+                <a:spcPts val="800"/>
+              </a:spcBef>
+              <a:buNone/>
+            </a:pPr>
+            <a:r>
+              <a:rPr lang="fr-CA" altLang="en-US" sz="1500" dirty="0">
+                <a:solidFill>
+                  <a:srgbClr val="A89A8C"/>
+                </a:solidFill>
+                <a:latin typeface="Calibri" pitchFamily="34" charset="0"/>
+                <a:ea typeface="Calibri" pitchFamily="34" charset="-122"/>
+                <a:cs typeface="Calibri" pitchFamily="34" charset="-120"/>
+              </a:rPr>
+              <a:t>Street rapproche Hébreux 4.12 : la Parole « juge les sentiments et les pensées du cœur ».</a:t>
             </a:r>
             <a:endParaRPr lang="fr-CA" sz="1600" dirty="0"/>
           </a:p>
@@ -22909,7 +23347,7 @@
                 <a:ea typeface="Calibri" pitchFamily="34" charset="-122"/>
                 <a:cs typeface="Calibri" pitchFamily="34" charset="-120"/>
               </a:rPr>
-              <a:t>« On ne peut rien lui retrancher; on ne peut rien lui ajouter »  (MacArthur)</a:t>
+              <a:t>« On ne peut rien lui retrancher; on ne peut rien lui ajouter » (MacArthur)</a:t>
             </a:r>
             <a:endParaRPr lang="fr-CA" sz="1900" dirty="0"/>
           </a:p>
@@ -23261,7 +23699,7 @@
                 <a:ea typeface="Calibri" pitchFamily="34" charset="-122"/>
                 <a:cs typeface="Calibri" pitchFamily="34" charset="-120"/>
               </a:rPr>
-              <a:t>« Parfaite » : au sens de complétude, non seulement d'irréprochable.</a:t>
+              <a:t>« Parfaite » : au sens de complétude, bien qu'elle soit aussi irréprochable.</a:t>
             </a:r>
             <a:endParaRPr lang="fr-CA" sz="1500" dirty="0"/>
           </a:p>
@@ -23435,7 +23873,7 @@
                 <a:ea typeface="Calibri" pitchFamily="34" charset="-122"/>
                 <a:cs typeface="Calibri" pitchFamily="34" charset="-120"/>
               </a:rPr>
-              <a:t>Psaume 19.8b-9</a:t>
+              <a:t>Psaume 19.8b‑9</a:t>
             </a:r>
             <a:endParaRPr lang="fr-CA" sz="1500" dirty="0"/>
           </a:p>
@@ -23478,7 +23916,7 @@
                 <a:ea typeface="Calibri" pitchFamily="34" charset="-122"/>
                 <a:cs typeface="Calibri" pitchFamily="34" charset="-120"/>
               </a:rPr>
-              <a:t>Plus sûre que l'expérience : Pierre, témoin de la transfiguration (2 Pierre 1.16‑19).</a:t>
+              <a:t>Plus sûre que l'expérience : Pierre, témoin de la transfiguration (2 Pierre 1.16‑19).</a:t>
             </a:r>
             <a:endParaRPr lang="fr-CA" sz="1500" dirty="0"/>
           </a:p>
@@ -23779,7 +24217,7 @@
                 <a:ea typeface="Calibri" pitchFamily="34" charset="-122"/>
                 <a:cs typeface="Calibri" pitchFamily="34" charset="-120"/>
               </a:rPr>
-              <a:t>« Absolument, sans équivoque, vrai » (MacArthur).</a:t>
+              <a:t>« Absolument, sans équivoque, vraie » (MacArthur).</a:t>
             </a:r>
             <a:endParaRPr lang="fr-CA" sz="1500" dirty="0"/>
           </a:p>

</xml_diff>